<commit_message>
docs: update FRP project manuscripts, reports, and presentation materials including new AI report
</commit_message>
<xml_diff>
--- a/SEM_8/FRP/FRP End Term.pptx
+++ b/SEM_8/FRP/FRP End Term.pptx
@@ -776,7 +776,15 @@
             </a:pPr>
             <a:r>
               <a:rPr lang="en"/>
-              <a:t>Good morning. I'm Dinanath, representing Group 3 alongside Satyajeet, Avignyan, and Ashutosh. Today, we are presenting our Review-1 progress on the automated detection of hardcoded secrets using LLM-augmented static analysis.</a:t>
+              <a:t>Good morning. I'm Dinanath, representing Group 3 alongside Satyajeet, Avignyan, and Ashutosh. </a:t>
+            </a:r>
+            <a:r>
+              <a:rPr lang="en" sz="1200">
+                <a:solidFill>
+                  <a:schemeClr val="dk1"/>
+                </a:solidFill>
+              </a:rPr>
+              <a:t>Today, we are presenting our End Term Research Project on the automated detection of hardcoded secrets in modern source code repositories. Specifically, we are going to demonstrate how we utilized LLM-augmented static analysis to solve this.</a:t>
             </a:r>
             <a:endParaRPr/>
           </a:p>
@@ -866,17 +874,68 @@
           <a:lstStyle/>
           <a:p>
             <a:pPr indent="0" lvl="0" marL="0" rtl="0" algn="l">
-              <a:spcBef>
-                <a:spcPts val="0"/>
-              </a:spcBef>
-              <a:spcAft>
-                <a:spcPts val="0"/>
-              </a:spcAft>
+              <a:lnSpc>
+                <a:spcPct val="115000"/>
+              </a:lnSpc>
+              <a:spcBef>
+                <a:spcPts val="1200"/>
+              </a:spcBef>
+              <a:spcAft>
+                <a:spcPts val="0"/>
+              </a:spcAft>
+              <a:buClr>
+                <a:schemeClr val="dk1"/>
+              </a:buClr>
+              <a:buSzPts val="1100"/>
+              <a:buFont typeface="Arial"/>
               <a:buNone/>
             </a:pPr>
             <a:r>
               <a:rPr lang="en"/>
-              <a:t>Here is the schematic of our model. We are evaluating this architecture against the open-source CredData benchmark, which contains roughly 27,000 lines of real-world code. Everything is orchestrated in Python and runs locally on Apple Silicon utilizing Unified Memory.</a:t>
+              <a:t>To test this architecture, we utilized the open-source CredData benchmark, which comprises approximately 27,000 lines of source code.</a:t>
+            </a:r>
+            <a:endParaRPr/>
+          </a:p>
+          <a:p>
+            <a:pPr indent="0" lvl="0" marL="0" rtl="0" algn="l">
+              <a:lnSpc>
+                <a:spcPct val="115000"/>
+              </a:lnSpc>
+              <a:spcBef>
+                <a:spcPts val="1200"/>
+              </a:spcBef>
+              <a:spcAft>
+                <a:spcPts val="0"/>
+              </a:spcAft>
+              <a:buClr>
+                <a:schemeClr val="dk1"/>
+              </a:buClr>
+              <a:buSzPts val="1100"/>
+              <a:buFont typeface="Arial"/>
+              <a:buNone/>
+            </a:pPr>
+            <a:r>
+              <a:rPr lang="en"/>
+              <a:t>It is important to note a critical engineering constraint here: due to extreme local compute limitations, we evaluated the legacy baseline tools against the full 27,000-line dataset, but rigorously benchmarked our Hybrid LLM against a standardized 1,000-hit subset.</a:t>
+            </a:r>
+            <a:endParaRPr/>
+          </a:p>
+          <a:p>
+            <a:pPr indent="0" lvl="0" marL="0" rtl="0" algn="l">
+              <a:lnSpc>
+                <a:spcPct val="115000"/>
+              </a:lnSpc>
+              <a:spcBef>
+                <a:spcPts val="1200"/>
+              </a:spcBef>
+              <a:spcAft>
+                <a:spcPts val="1200"/>
+              </a:spcAft>
+              <a:buNone/>
+            </a:pPr>
+            <a:r>
+              <a:rPr lang="en"/>
+              <a:t>Our stack is strictly Python 3.10+ orchestrating a 4-bit quantized Meta Llama 3 8B Instruct model. We rely entirely on the Apple MLX Framework running locally on M-series Apple Silicon. By utilizing Apple's Unified Memory, we achieve total offline inference.</a:t>
             </a:r>
             <a:endParaRPr/>
           </a:p>
@@ -966,17 +1025,68 @@
           <a:lstStyle/>
           <a:p>
             <a:pPr indent="0" lvl="0" marL="0" rtl="0" algn="l">
-              <a:spcBef>
-                <a:spcPts val="0"/>
-              </a:spcBef>
-              <a:spcAft>
-                <a:spcPts val="0"/>
-              </a:spcAft>
+              <a:lnSpc>
+                <a:spcPct val="115000"/>
+              </a:lnSpc>
+              <a:spcBef>
+                <a:spcPts val="1200"/>
+              </a:spcBef>
+              <a:spcAft>
+                <a:spcPts val="0"/>
+              </a:spcAft>
+              <a:buClr>
+                <a:schemeClr val="dk1"/>
+              </a:buClr>
+              <a:buSzPts val="1100"/>
+              <a:buFont typeface="Arial"/>
               <a:buNone/>
             </a:pPr>
             <a:r>
               <a:rPr lang="en"/>
-              <a:t>Regarding our progress, Phase 1—the Regex and AST context extraction—and Phase 2—the local MLX inference—are fully operational. We have successfully fine-tuned the model using LoRA at 3000 iterations to enforce strict JSON output parsing, and we have scaled our testing to the full CredData dataset.</a:t>
+              <a:t>Executing entirely on local hardware ensures we strictly enforce our zero-trust data privacy constraints. Corporate code never touches a network interface.</a:t>
+            </a:r>
+            <a:endParaRPr/>
+          </a:p>
+          <a:p>
+            <a:pPr indent="0" lvl="0" marL="0" rtl="0" algn="l">
+              <a:lnSpc>
+                <a:spcPct val="115000"/>
+              </a:lnSpc>
+              <a:spcBef>
+                <a:spcPts val="1200"/>
+              </a:spcBef>
+              <a:spcAft>
+                <a:spcPts val="0"/>
+              </a:spcAft>
+              <a:buClr>
+                <a:schemeClr val="dk1"/>
+              </a:buClr>
+              <a:buSzPts val="1100"/>
+              <a:buFont typeface="Arial"/>
+              <a:buNone/>
+            </a:pPr>
+            <a:r>
+              <a:rPr lang="en"/>
+              <a:t>Regarding the pipeline implementation, both Phase 1—the Regex and AST context extraction—and Phase 2—the Apple MLX inference—are fully integrated and operationalized. A major hurdle in LLM integration is standardizing output. We solved this through targeted model fine-tuning. Running LoRA at 3000 iterations successfully stabilized the model to output strict, predictable JSON parsing, allowing seamless integration with our evaluation suite.</a:t>
+            </a:r>
+            <a:endParaRPr/>
+          </a:p>
+          <a:p>
+            <a:pPr indent="0" lvl="0" marL="0" rtl="0" algn="l">
+              <a:lnSpc>
+                <a:spcPct val="115000"/>
+              </a:lnSpc>
+              <a:spcBef>
+                <a:spcPts val="1200"/>
+              </a:spcBef>
+              <a:spcAft>
+                <a:spcPts val="1200"/>
+              </a:spcAft>
+              <a:buNone/>
+            </a:pPr>
+            <a:r>
+              <a:rPr lang="en"/>
+              <a:t>I will now hand it over to Satyajeet to break down the exact performance metrics and address our current latency challenges.</a:t>
             </a:r>
             <a:endParaRPr/>
           </a:p>
@@ -1066,17 +1176,68 @@
           <a:lstStyle/>
           <a:p>
             <a:pPr indent="0" lvl="0" marL="0" rtl="0" algn="l">
-              <a:spcBef>
-                <a:spcPts val="0"/>
-              </a:spcBef>
-              <a:spcAft>
-                <a:spcPts val="0"/>
-              </a:spcAft>
+              <a:lnSpc>
+                <a:spcPct val="115000"/>
+              </a:lnSpc>
+              <a:spcBef>
+                <a:spcPts val="1200"/>
+              </a:spcBef>
+              <a:spcAft>
+                <a:spcPts val="0"/>
+              </a:spcAft>
+              <a:buClr>
+                <a:schemeClr val="dk1"/>
+              </a:buClr>
+              <a:buSzPts val="1100"/>
+              <a:buFont typeface="Arial"/>
               <a:buNone/>
             </a:pPr>
             <a:r>
               <a:rPr lang="en"/>
-              <a:t>The baseline results expose the 'context blindness' of traditional tools. In our tests, TruffleHog failed entirely with a 0.0123 recall, while Gitleaks missed 74% of actual secrets. In contrast, our hybrid model achieved an 87% overall accuracy. We maintained a highly competitive Precision of 0.8117 while surging our Recall to 0.9427. The F1-Score sits at a dominant 0.8723.</a:t>
+              <a:t>Avignyan walked you through the architecture, but architecture is theoretical until benchmarked. We conducted a head-to-head comparative analysis on the CredData dataset against two industry standards: TruffleHog and Gitleaks.</a:t>
+            </a:r>
+            <a:endParaRPr/>
+          </a:p>
+          <a:p>
+            <a:pPr indent="0" lvl="0" marL="0" rtl="0" algn="l">
+              <a:lnSpc>
+                <a:spcPct val="115000"/>
+              </a:lnSpc>
+              <a:spcBef>
+                <a:spcPts val="1200"/>
+              </a:spcBef>
+              <a:spcAft>
+                <a:spcPts val="0"/>
+              </a:spcAft>
+              <a:buClr>
+                <a:schemeClr val="dk1"/>
+              </a:buClr>
+              <a:buSzPts val="1100"/>
+              <a:buFont typeface="Arial"/>
+              <a:buNone/>
+            </a:pPr>
+            <a:r>
+              <a:rPr lang="en"/>
+              <a:t>The baseline failure is entirely rooted in context blindness. TruffleHog failed our offline execution parameters entirely, yielding a near-zero recall of 0.0123. Gitleaks, functioning purely on Regex, maintained a high precision of 0.8600, but suffered catastrophic false negatives. Because it lacks semantic awareness, Gitleaks missed 74% of actual hardcoded secrets, resulting in a recall of just 0.2600.</a:t>
+            </a:r>
+            <a:endParaRPr/>
+          </a:p>
+          <a:p>
+            <a:pPr indent="0" lvl="0" marL="0" rtl="0" algn="l">
+              <a:lnSpc>
+                <a:spcPct val="115000"/>
+              </a:lnSpc>
+              <a:spcBef>
+                <a:spcPts val="1200"/>
+              </a:spcBef>
+              <a:spcAft>
+                <a:spcPts val="1200"/>
+              </a:spcAft>
+              <a:buNone/>
+            </a:pPr>
+            <a:r>
+              <a:rPr lang="en"/>
+              <a:t>Against this, our Hybrid Model achieved an overall accuracy of 87.0% across our standardized 1,000-hit subset. While maintaining highly competitive precision at 0.8117, our recall surged to 0.9427.</a:t>
             </a:r>
             <a:endParaRPr/>
           </a:p>
@@ -1175,8 +1336,12 @@
               <a:buNone/>
             </a:pPr>
             <a:r>
-              <a:rPr lang="en"/>
-              <a:t>The baseline results expose the 'context blindness' of traditional tools. In our tests, TruffleHog failed entirely with a 0.0123 recall, while Gitleaks missed 74% of actual secrets. In contrast, our hybrid model achieved an 87% overall accuracy. We maintained a highly competitive Precision of 0.8117 while surging our Recall to 0.9427. The F1-Score sits at a dominant 0.8723.</a:t>
+              <a:rPr lang="en" sz="1200">
+                <a:solidFill>
+                  <a:schemeClr val="dk1"/>
+                </a:solidFill>
+              </a:rPr>
+              <a:t>Looking at the visual breakdown, the trade-off is clear. We sacrificed a negligible fraction of precision compared to Gitleaks to achieve a massive leap in recall. Consequently, our hybrid model dominates the F1-Score metric at 0.8723, comprehensively outperforming both baselines. We successfully eliminated the false alarms without blinding the scanner.</a:t>
             </a:r>
             <a:endParaRPr/>
           </a:p>
@@ -1266,17 +1431,44 @@
           <a:lstStyle/>
           <a:p>
             <a:pPr indent="0" lvl="0" marL="0" rtl="0" algn="l">
-              <a:spcBef>
-                <a:spcPts val="0"/>
-              </a:spcBef>
-              <a:spcAft>
-                <a:spcPts val="0"/>
-              </a:spcAft>
+              <a:lnSpc>
+                <a:spcPct val="115000"/>
+              </a:lnSpc>
+              <a:spcBef>
+                <a:spcPts val="1200"/>
+              </a:spcBef>
+              <a:spcAft>
+                <a:spcPts val="0"/>
+              </a:spcAft>
+              <a:buClr>
+                <a:schemeClr val="dk1"/>
+              </a:buClr>
+              <a:buSzPts val="1100"/>
+              <a:buFont typeface="Arial"/>
               <a:buNone/>
             </a:pPr>
             <a:r>
               <a:rPr lang="en"/>
-              <a:t>However, we must address the operational reality: executing this 1,000-hit subset took 3.5 hours locally. Sequential LLM inference is currently a severe bottleneck that makes monolithic repository scans impractical for fast-paced CI/CD pipelines. Moving forward, our priority shifts aggressively from detection accuracy to operational speed. We will investigate batch processing and model pruning to bring inference times down to viable thresholds, and we will validate our generalization against the FPSecretBench dataset before packaging this as a deployable GitHub Action.</a:t>
+              <a:t>However, we must address the engineering reality: latency. While the Apple MLX framework guarantees zero-trust privacy via local execution, running a quantized 8-billion parameter model is fundamentally slower than pure C-based Regex.</a:t>
+            </a:r>
+            <a:endParaRPr/>
+          </a:p>
+          <a:p>
+            <a:pPr indent="0" lvl="0" marL="0" rtl="0" algn="l">
+              <a:lnSpc>
+                <a:spcPct val="115000"/>
+              </a:lnSpc>
+              <a:spcBef>
+                <a:spcPts val="1200"/>
+              </a:spcBef>
+              <a:spcAft>
+                <a:spcPts val="1200"/>
+              </a:spcAft>
+              <a:buNone/>
+            </a:pPr>
+            <a:r>
+              <a:rPr lang="en"/>
+              <a:t>Currently, executing sequential LLM inference on hundreds of Regex matches creates a severe pipeline block. It is impractical for monolithic repository scans in a fast-paced CI/CD environment. We actively mitigated this by implementing a strict few-shot prompting template, which successfully halved our initial context processing time and stabilized the JSON output. But baseline per-snippet inference speed remains our primary technical hurdle for production deployment.</a:t>
             </a:r>
             <a:endParaRPr/>
           </a:p>
@@ -1366,17 +1558,44 @@
           <a:lstStyle/>
           <a:p>
             <a:pPr indent="0" lvl="0" marL="0" rtl="0" algn="l">
-              <a:spcBef>
-                <a:spcPts val="0"/>
-              </a:spcBef>
-              <a:spcAft>
-                <a:spcPts val="0"/>
-              </a:spcAft>
+              <a:lnSpc>
+                <a:spcPct val="115000"/>
+              </a:lnSpc>
+              <a:spcBef>
+                <a:spcPts val="1200"/>
+              </a:spcBef>
+              <a:spcAft>
+                <a:spcPts val="0"/>
+              </a:spcAft>
+              <a:buClr>
+                <a:schemeClr val="dk1"/>
+              </a:buClr>
+              <a:buSzPts val="1100"/>
+              <a:buFont typeface="Arial"/>
               <a:buNone/>
             </a:pPr>
             <a:r>
               <a:rPr lang="en"/>
-              <a:t>However, we must address the operational reality: executing this 1,000-hit subset took 3.5 hours locally. Sequential LLM inference is currently a severe bottleneck that makes monolithic repository scans impractical for fast-paced CI/CD pipelines. Moving forward, our priority shifts aggressively from detection accuracy to operational speed. We will investigate batch processing and model pruning to bring inference times down to viable thresholds, and we will validate our generalization against the FPSecretBench dataset before packaging this as a deployable GitHub Action.</a:t>
+              <a:t>To conclude, our hybrid LLM-augmented pipeline definitively validated our core research hypothesis: we successfully eliminated Regex context-blindness—achieving an 87.23% F1-Score—while guaranteeing zero-trust data privacy via local MLX execution.</a:t>
+            </a:r>
+            <a:endParaRPr/>
+          </a:p>
+          <a:p>
+            <a:pPr indent="0" lvl="0" marL="0" rtl="0" algn="l">
+              <a:lnSpc>
+                <a:spcPct val="115000"/>
+              </a:lnSpc>
+              <a:spcBef>
+                <a:spcPts val="1200"/>
+              </a:spcBef>
+              <a:spcAft>
+                <a:spcPts val="1200"/>
+              </a:spcAft>
+              <a:buNone/>
+            </a:pPr>
+            <a:r>
+              <a:rPr lang="en"/>
+              <a:t>Moving forward, our immediate scope dictates three actions. First, cross-dataset validation. Our model is heavily biased toward the CredData benchmark, so we are pending access to the FPSecretBench dataset to test generalization. Second, aggressive latency mitigation. We are shifting focus from detection accuracy to operational speed, specifically investigating batch processing through the MLX engine. Finally, we plan to package this architecture into a standardized GitHub Action for seamless CI/CD integration.</a:t>
             </a:r>
             <a:endParaRPr/>
           </a:p>
@@ -1828,17 +2047,48 @@
           <a:lstStyle/>
           <a:p>
             <a:pPr indent="0" lvl="0" marL="0" rtl="0" algn="l">
-              <a:spcBef>
-                <a:spcPts val="0"/>
-              </a:spcBef>
-              <a:spcAft>
-                <a:spcPts val="0"/>
-              </a:spcAft>
+              <a:lnSpc>
+                <a:spcPct val="115000"/>
+              </a:lnSpc>
+              <a:spcBef>
+                <a:spcPts val="1200"/>
+              </a:spcBef>
+              <a:spcAft>
+                <a:spcPts val="0"/>
+              </a:spcAft>
+              <a:buClr>
+                <a:schemeClr val="dk1"/>
+              </a:buClr>
+              <a:buSzPts val="1100"/>
+              <a:buFont typeface="Arial"/>
               <a:buNone/>
             </a:pPr>
             <a:r>
               <a:rPr lang="en"/>
-              <a:t>In DevSecOps, traditional static secret scanners rely heavily on Regex and Entropy. The fatal flaw here is a lack of semantic understanding—they flag dummy credentials and safe test variables, creating massive False Positive Rates. This leads to severe alert fatigue for security teams. Our primary objective is to implement a two-stage hybrid scanning pipeline to slash these false positives without compromising our recall capabilities. Furthermore, we are committed to keeping this zero-trust by executing the LLM entirely offline.</a:t>
+              <a:t>Our research operates within the domain of DevSecOps and Software Supply Chain Security. The fundamental problem we are addressing is that traditional static secret scanners lack semantic understanding. Because they rely heavily on pattern matching, they generate prohibitively high False Positive Rates by constantly flagging safe test variables.</a:t>
+            </a:r>
+            <a:endParaRPr/>
+          </a:p>
+          <a:p>
+            <a:pPr indent="0" lvl="0" marL="0" rtl="0" algn="l">
+              <a:lnSpc>
+                <a:spcPct val="115000"/>
+              </a:lnSpc>
+              <a:spcBef>
+                <a:spcPts val="1200"/>
+              </a:spcBef>
+              <a:spcAft>
+                <a:spcPts val="1200"/>
+              </a:spcAft>
+              <a:buNone/>
+            </a:pPr>
+            <a:r>
+              <a:rPr lang="en"/>
+              <a:t>To resolve this, we engineered a two-stage hybrid scanning pipeline. We use standard Regex as a Stage-1 pre-filter, which then invokes a locally deployed, 4-bit quantized Meta Llama 3 model. By feeding the LLM a strict 11-line context window, our solution drastically reduces false alarms. Most importantly, it does this while maintaining total offline execution and data privacy</a:t>
+            </a:r>
+            <a:r>
+              <a:rPr lang="en"/>
+              <a:t>.</a:t>
             </a:r>
             <a:endParaRPr/>
           </a:p>
@@ -1928,17 +2178,68 @@
           <a:lstStyle/>
           <a:p>
             <a:pPr indent="0" lvl="0" marL="0" rtl="0" algn="l">
-              <a:spcBef>
-                <a:spcPts val="0"/>
-              </a:spcBef>
-              <a:spcAft>
-                <a:spcPts val="0"/>
-              </a:spcAft>
+              <a:lnSpc>
+                <a:spcPct val="115000"/>
+              </a:lnSpc>
+              <a:spcBef>
+                <a:spcPts val="1200"/>
+              </a:spcBef>
+              <a:spcAft>
+                <a:spcPts val="0"/>
+              </a:spcAft>
+              <a:buClr>
+                <a:schemeClr val="dk1"/>
+              </a:buClr>
+              <a:buSzPts val="1100"/>
+              <a:buFont typeface="Arial"/>
               <a:buNone/>
             </a:pPr>
             <a:r>
               <a:rPr lang="en"/>
-              <a:t>In DevSecOps, traditional static secret scanners rely heavily on Regex and Entropy. The fatal flaw here is a lack of semantic understanding—they flag dummy credentials and safe test variables, creating massive False Positive Rates. This leads to severe alert fatigue for security teams. Our primary objective is to implement a two-stage hybrid scanning pipeline to slash these false positives without compromising our recall capabilities. Furthermore, we are committed to keeping this zero-trust by executing the LLM entirely offline.</a:t>
+              <a:t>Why is this necessary? Because high False Positive Rates cause severe 'Alert Fatigue' among security teams. When developers are flooded with false alarms, CI/CD pipelines are delayed, and the likelihood of ignoring genuine, critical vulnerabilities in large-scale codebases increases drastically.</a:t>
+            </a:r>
+            <a:endParaRPr/>
+          </a:p>
+          <a:p>
+            <a:pPr indent="0" lvl="0" marL="0" rtl="0" algn="l">
+              <a:lnSpc>
+                <a:spcPct val="115000"/>
+              </a:lnSpc>
+              <a:spcBef>
+                <a:spcPts val="1200"/>
+              </a:spcBef>
+              <a:spcAft>
+                <a:spcPts val="0"/>
+              </a:spcAft>
+              <a:buClr>
+                <a:schemeClr val="dk1"/>
+              </a:buClr>
+              <a:buSzPts val="1100"/>
+              <a:buFont typeface="Arial"/>
+              <a:buNone/>
+            </a:pPr>
+            <a:r>
+              <a:rPr lang="en"/>
+              <a:t>Our primary objective was to design and implement a pipeline that drastically reduces these False Positive Rates without compromising our recall capabilities. We measured this success by evaluating baseline Regex performance against our Hybrid LLM pipeline using a quantitative Confusion Matrix. Furthermore, we guaranteed zero-trust data privacy by executing the fine-tuned LLM entirely offline, while strictly benchmarking the inference latency trade-offs that come with local execution.</a:t>
+            </a:r>
+            <a:endParaRPr/>
+          </a:p>
+          <a:p>
+            <a:pPr indent="0" lvl="0" marL="0" rtl="0" algn="l">
+              <a:lnSpc>
+                <a:spcPct val="115000"/>
+              </a:lnSpc>
+              <a:spcBef>
+                <a:spcPts val="1200"/>
+              </a:spcBef>
+              <a:spcAft>
+                <a:spcPts val="1200"/>
+              </a:spcAft>
+              <a:buNone/>
+            </a:pPr>
+            <a:r>
+              <a:rPr lang="en"/>
+              <a:t>I will now hand it over to Ashutosh to discuss the current literature and where existing solutions fall short.</a:t>
             </a:r>
             <a:endParaRPr/>
           </a:p>
@@ -2028,17 +2329,44 @@
           <a:lstStyle/>
           <a:p>
             <a:pPr indent="0" lvl="0" marL="0" rtl="0" algn="l">
-              <a:spcBef>
-                <a:spcPts val="0"/>
-              </a:spcBef>
-              <a:spcAft>
-                <a:spcPts val="0"/>
-              </a:spcAft>
+              <a:lnSpc>
+                <a:spcPct val="115000"/>
+              </a:lnSpc>
+              <a:spcBef>
+                <a:spcPts val="1200"/>
+              </a:spcBef>
+              <a:spcAft>
+                <a:spcPts val="0"/>
+              </a:spcAft>
+              <a:buClr>
+                <a:schemeClr val="dk1"/>
+              </a:buClr>
+              <a:buSzPts val="1100"/>
+              <a:buFont typeface="Arial"/>
               <a:buNone/>
             </a:pPr>
             <a:r>
               <a:rPr lang="en"/>
-              <a:t>We analyzed current literature and existing solutions to establish our baseline. The consensus is that while LLMs improve accuracy, they introduce new, restrictive barriers in real-world application.</a:t>
+              <a:t>Following Dinanath’s problem statement, we must examine why current solutions fail in production environments. Slides 5 and 6 summarize our comprehensive review of recent literature.</a:t>
+            </a:r>
+            <a:endParaRPr/>
+          </a:p>
+          <a:p>
+            <a:pPr indent="0" lvl="0" marL="0" rtl="0" algn="l">
+              <a:lnSpc>
+                <a:spcPct val="115000"/>
+              </a:lnSpc>
+              <a:spcBef>
+                <a:spcPts val="1200"/>
+              </a:spcBef>
+              <a:spcAft>
+                <a:spcPts val="1200"/>
+              </a:spcAft>
+              <a:buNone/>
+            </a:pPr>
+            <a:r>
+              <a:rPr lang="en"/>
+              <a:t>The data reveals three recurring points of failure across the industry. First, as noted by Jin in 2025, attempting to adapt LLMs for static analysis results in severe token consumption and context window exhaustion. Second, vulnerability models fundamentally lack line-level granularity, as shown by Apostolidis, and focus too heavily on overall file semantics rather than isolated vulnerability concepts, as highlighted by Li. Finally, standard LLM metrics are dangerously inflated on open-source data due to training contamination, meaning they fail when applied to proprietary corporate codebases.</a:t>
             </a:r>
             <a:endParaRPr/>
           </a:p>
@@ -2128,17 +2456,44 @@
           <a:lstStyle/>
           <a:p>
             <a:pPr indent="0" lvl="0" marL="0" rtl="0" algn="l">
-              <a:spcBef>
-                <a:spcPts val="0"/>
-              </a:spcBef>
-              <a:spcAft>
-                <a:spcPts val="0"/>
-              </a:spcAft>
+              <a:lnSpc>
+                <a:spcPct val="115000"/>
+              </a:lnSpc>
+              <a:spcBef>
+                <a:spcPts val="1200"/>
+              </a:spcBef>
+              <a:spcAft>
+                <a:spcPts val="0"/>
+              </a:spcAft>
+              <a:buClr>
+                <a:schemeClr val="dk1"/>
+              </a:buClr>
+              <a:buSzPts val="1100"/>
+              <a:buFont typeface="Arial"/>
               <a:buNone/>
             </a:pPr>
             <a:r>
               <a:rPr lang="en"/>
-              <a:t>We analyzed current literature and existing solutions to establish our baseline. The consensus is that while LLMs improve accuracy, they introduce new, restrictive barriers in real-world application.</a:t>
+              <a:t>Following Dinanath’s problem statement, we must examine why current solutions fail in production environments. Slides 5 and 6 summarize our comprehensive review of recent literature.</a:t>
+            </a:r>
+            <a:endParaRPr/>
+          </a:p>
+          <a:p>
+            <a:pPr indent="0" lvl="0" marL="0" rtl="0" algn="l">
+              <a:lnSpc>
+                <a:spcPct val="115000"/>
+              </a:lnSpc>
+              <a:spcBef>
+                <a:spcPts val="1200"/>
+              </a:spcBef>
+              <a:spcAft>
+                <a:spcPts val="1200"/>
+              </a:spcAft>
+              <a:buNone/>
+            </a:pPr>
+            <a:r>
+              <a:rPr lang="en"/>
+              <a:t>The data reveals three recurring points of failure across the industry. First, as noted by Jin in 2025, attempting to adapt LLMs for static analysis results in severe token consumption and context window exhaustion. Second, vulnerability models fundamentally lack line-level granularity, as shown by Apostolidis, and focus too heavily on overall file semantics rather than isolated vulnerability concepts, as highlighted by Li. Finally, standard LLM metrics are dangerously inflated on open-source data due to training contamination, meaning they fail when applied to proprietary corporate codebases.</a:t>
             </a:r>
             <a:endParaRPr/>
           </a:p>
@@ -2228,17 +2583,44 @@
           <a:lstStyle/>
           <a:p>
             <a:pPr indent="0" lvl="0" marL="0" rtl="0" algn="l">
-              <a:spcBef>
-                <a:spcPts val="0"/>
-              </a:spcBef>
-              <a:spcAft>
-                <a:spcPts val="0"/>
-              </a:spcAft>
+              <a:lnSpc>
+                <a:spcPct val="115000"/>
+              </a:lnSpc>
+              <a:spcBef>
+                <a:spcPts val="1200"/>
+              </a:spcBef>
+              <a:spcAft>
+                <a:spcPts val="0"/>
+              </a:spcAft>
+              <a:buClr>
+                <a:schemeClr val="dk1"/>
+              </a:buClr>
+              <a:buSzPts val="1100"/>
+              <a:buFont typeface="Arial"/>
               <a:buNone/>
             </a:pPr>
             <a:r>
               <a:rPr lang="en"/>
-              <a:t>We identified three major limitations in current research: token inefficiency, context blindness, and data privacy. Sending raw source code to external APIs like OpenAI violates zero-trust models. To solve this, we use a cascading filter. We use Regex as a Stage-1 pre-filter, and only send a strict 11-line Abstract Syntax Tree context to the LLM. To guarantee data privacy, we deploy a 4-bit quantized Llama 3 8B model locally using the Apple MLX framework.</a:t>
+              <a:t>We translated these failures into specific research gaps. Limitation 1 is Token Inefficiency. Throwing an entire repository at an LLM is computationally unviable. Our engineered solution is a 'cascading filter' approach. We use deterministic Regex purely as a Stage-1 pre-filter. This ensures we only invoke the LLM on a strict 11-line context window, completely bypassing the latency constraints of pure-LLM scanners.</a:t>
+            </a:r>
+            <a:endParaRPr/>
+          </a:p>
+          <a:p>
+            <a:pPr indent="0" lvl="0" marL="0" rtl="0" algn="l">
+              <a:lnSpc>
+                <a:spcPct val="115000"/>
+              </a:lnSpc>
+              <a:spcBef>
+                <a:spcPts val="1200"/>
+              </a:spcBef>
+              <a:spcAft>
+                <a:spcPts val="1200"/>
+              </a:spcAft>
+              <a:buNone/>
+            </a:pPr>
+            <a:r>
+              <a:rPr lang="en"/>
+              <a:t>Limitation 2 is Context Blindness. Existing models evaluate the whole file and miss the nuances of specific lines.</a:t>
             </a:r>
             <a:endParaRPr/>
           </a:p>
@@ -2328,17 +2710,92 @@
           <a:lstStyle/>
           <a:p>
             <a:pPr indent="0" lvl="0" marL="0" rtl="0" algn="l">
-              <a:spcBef>
-                <a:spcPts val="0"/>
-              </a:spcBef>
-              <a:spcAft>
-                <a:spcPts val="0"/>
-              </a:spcAft>
+              <a:lnSpc>
+                <a:spcPct val="115000"/>
+              </a:lnSpc>
+              <a:spcBef>
+                <a:spcPts val="1200"/>
+              </a:spcBef>
+              <a:spcAft>
+                <a:spcPts val="0"/>
+              </a:spcAft>
+              <a:buClr>
+                <a:schemeClr val="dk1"/>
+              </a:buClr>
+              <a:buSzPts val="1100"/>
+              <a:buFont typeface="Arial"/>
               <a:buNone/>
             </a:pPr>
             <a:r>
               <a:rPr lang="en"/>
-              <a:t>We identified three major limitations in current research: token inefficiency, context blindness, and data privacy. Sending raw source code to external APIs like OpenAI violates zero-trust models. To solve this, we use a cascading filter. We use Regex as a Stage-1 pre-filter, and only send a strict 11-line Abstract Syntax Tree context to the LLM. To guarantee data privacy, we deploy a 4-bit quantized Llama 3 8B model locally using the Apple MLX framework.</a:t>
+              <a:t>To solve this Context Blindness, we extracted the Abstract Syntax Tree context—specifically, 5 lines above and below the initial Regex match. We then applied LoRA fine-tuning to explicitly train our model to evaluate variable scope and dummy test parameters within that exact micro-context.</a:t>
+            </a:r>
+            <a:endParaRPr/>
+          </a:p>
+          <a:p>
+            <a:pPr indent="0" lvl="0" marL="0" rtl="0" algn="l">
+              <a:lnSpc>
+                <a:spcPct val="115000"/>
+              </a:lnSpc>
+              <a:spcBef>
+                <a:spcPts val="1200"/>
+              </a:spcBef>
+              <a:spcAft>
+                <a:spcPts val="0"/>
+              </a:spcAft>
+              <a:buClr>
+                <a:schemeClr val="dk1"/>
+              </a:buClr>
+              <a:buSzPts val="1100"/>
+              <a:buFont typeface="Arial"/>
+              <a:buNone/>
+            </a:pPr>
+            <a:r>
+              <a:rPr lang="en"/>
+              <a:t>The final, and arguably most critical, gap is Limitation 3: The Data Privacy Paradigm. State-of-the-art security tools currently rely on cloud-based APIs. Sending proprietary, unredacted corporate source code to external servers like OpenAI or Anthropic is a direct violation of Zero-Trust security models and data compliance laws.</a:t>
+            </a:r>
+            <a:endParaRPr/>
+          </a:p>
+          <a:p>
+            <a:pPr indent="0" lvl="0" marL="0" rtl="0" algn="l">
+              <a:lnSpc>
+                <a:spcPct val="115000"/>
+              </a:lnSpc>
+              <a:spcBef>
+                <a:spcPts val="1200"/>
+              </a:spcBef>
+              <a:spcAft>
+                <a:spcPts val="0"/>
+              </a:spcAft>
+              <a:buClr>
+                <a:schemeClr val="dk1"/>
+              </a:buClr>
+              <a:buSzPts val="1100"/>
+              <a:buFont typeface="Arial"/>
+              <a:buNone/>
+            </a:pPr>
+            <a:r>
+              <a:rPr lang="en"/>
+              <a:t>Our engineered solution mandates total offline execution. We bridged this gap by deploying a 4-bit quantized Meta Llama 3 8B model locally. By leveraging the Apple MLX framework and Unified Memory, we achieve secure, on-device inference without data ever leaving the machine.</a:t>
+            </a:r>
+            <a:endParaRPr/>
+          </a:p>
+          <a:p>
+            <a:pPr indent="0" lvl="0" marL="0" rtl="0" algn="l">
+              <a:lnSpc>
+                <a:spcPct val="115000"/>
+              </a:lnSpc>
+              <a:spcBef>
+                <a:spcPts val="1200"/>
+              </a:spcBef>
+              <a:spcAft>
+                <a:spcPts val="1200"/>
+              </a:spcAft>
+              <a:buNone/>
+            </a:pPr>
+            <a:r>
+              <a:rPr lang="en"/>
+              <a:t>I will now hand it over to Avignyan, who will walk you through the architectural implementation of these solutions.</a:t>
             </a:r>
             <a:endParaRPr/>
           </a:p>
@@ -2428,17 +2885,68 @@
           <a:lstStyle/>
           <a:p>
             <a:pPr indent="0" lvl="0" marL="0" rtl="0" algn="l">
-              <a:spcBef>
-                <a:spcPts val="0"/>
-              </a:spcBef>
-              <a:spcAft>
-                <a:spcPts val="0"/>
-              </a:spcAft>
+              <a:lnSpc>
+                <a:spcPct val="115000"/>
+              </a:lnSpc>
+              <a:spcBef>
+                <a:spcPts val="1200"/>
+              </a:spcBef>
+              <a:spcAft>
+                <a:spcPts val="0"/>
+              </a:spcAft>
+              <a:buClr>
+                <a:schemeClr val="dk1"/>
+              </a:buClr>
+              <a:buSzPts val="1100"/>
+              <a:buFont typeface="Arial"/>
               <a:buNone/>
             </a:pPr>
             <a:r>
               <a:rPr lang="en"/>
-              <a:t>Here is the schematic of our model. We are evaluating this architecture against the open-source CredData benchmark, which contains roughly 27,000 lines of real-world code. Everything is orchestrated in Python and runs locally on Apple Silicon utilizing Unified Memory.</a:t>
+              <a:t>Building on the privacy and latency requirements Ashutosh outlined, this is the schematic of our engineered pipeline.</a:t>
+            </a:r>
+            <a:endParaRPr/>
+          </a:p>
+          <a:p>
+            <a:pPr indent="0" lvl="0" marL="0" rtl="0" algn="l">
+              <a:lnSpc>
+                <a:spcPct val="115000"/>
+              </a:lnSpc>
+              <a:spcBef>
+                <a:spcPts val="1200"/>
+              </a:spcBef>
+              <a:spcAft>
+                <a:spcPts val="0"/>
+              </a:spcAft>
+              <a:buClr>
+                <a:schemeClr val="dk1"/>
+              </a:buClr>
+              <a:buSzPts val="1100"/>
+              <a:buFont typeface="Arial"/>
+              <a:buNone/>
+            </a:pPr>
+            <a:r>
+              <a:rPr lang="en"/>
+              <a:t>The flow begins by feeding a raw source code repository into our Python preprocessing script. We apply strict directory filtering to drop binaries and irrelevant files, then run the deterministic Regex Matcher. When Regex flags a potential secret, our 11-Line Context Extractor isolates the match along with its immediate surrounding Abstract Syntax Tree.</a:t>
+            </a:r>
+            <a:endParaRPr/>
+          </a:p>
+          <a:p>
+            <a:pPr indent="0" lvl="0" marL="0" rtl="0" algn="l">
+              <a:lnSpc>
+                <a:spcPct val="115000"/>
+              </a:lnSpc>
+              <a:spcBef>
+                <a:spcPts val="1200"/>
+              </a:spcBef>
+              <a:spcAft>
+                <a:spcPts val="1200"/>
+              </a:spcAft>
+              <a:buNone/>
+            </a:pPr>
+            <a:r>
+              <a:rPr lang="en"/>
+              <a:t>This micro-context is then passed to our Local Apple MLX Engine. Here, our LoRA fine-tuned Meta Llama 3 8B model evaluates the semantics. The output layer forces a strict JSON response, which our parser evaluates to classify the secret as either 'SAFE' or 'CRITICAL', before passing the metrics to our evaluation suite.</a:t>
             </a:r>
             <a:endParaRPr/>
           </a:p>
@@ -20676,9 +21184,9 @@
           </a:bodyPr>
           <a:lstStyle/>
           <a:p>
-            <a:pPr indent="0" lvl="0" marL="0" marR="0" rtl="0" algn="just">
+            <a:pPr indent="-304800" lvl="0" marL="457200" rtl="0" algn="l">
               <a:lnSpc>
-                <a:spcPct val="100000"/>
+                <a:spcPct val="115000"/>
               </a:lnSpc>
               <a:spcBef>
                 <a:spcPts val="0"/>
@@ -20691,7 +21199,7 @@
               </a:buClr>
               <a:buSzPts val="1200"/>
               <a:buFont typeface="Times New Roman"/>
-              <a:buNone/>
+              <a:buAutoNum type="arabicPeriod"/>
             </a:pPr>
             <a:r>
               <a:rPr lang="en" sz="1200">
@@ -20703,7 +21211,7 @@
                 <a:cs typeface="Times New Roman"/>
                 <a:sym typeface="Times New Roman"/>
               </a:rPr>
-              <a:t>[1] G. D. Apostolidis, I. Kalouptsoglou, M. Siavvas, D. Kehagias, and D. Tzovaras, "AI-Enhanced Static Analysis: Reducing False Alarms Using Large Language Models," in 2025 IEEE International Conference on Smart Computing (SMARTCOMP), 2025.</a:t>
+              <a:t>Schwarz, D. (2025) 'Countermind: A Multi-Layered Security Architecture for Large Language Models', arXiv preprint arXiv:2510.11837v1.</a:t>
             </a:r>
             <a:endParaRPr sz="1200">
               <a:solidFill>
@@ -20716,12 +21224,12 @@
             </a:endParaRPr>
           </a:p>
           <a:p>
-            <a:pPr indent="0" lvl="0" marL="0" marR="0" rtl="0" algn="just">
+            <a:pPr indent="-304800" lvl="0" marL="457200" rtl="0" algn="l">
               <a:lnSpc>
-                <a:spcPct val="100000"/>
+                <a:spcPct val="115000"/>
               </a:lnSpc>
               <a:spcBef>
-                <a:spcPts val="800"/>
+                <a:spcPts val="0"/>
               </a:spcBef>
               <a:spcAft>
                 <a:spcPts val="0"/>
@@ -20731,7 +21239,7 @@
               </a:buClr>
               <a:buSzPts val="1200"/>
               <a:buFont typeface="Times New Roman"/>
-              <a:buNone/>
+              <a:buAutoNum type="arabicPeriod"/>
             </a:pPr>
             <a:r>
               <a:rPr lang="en" sz="1200">
@@ -20743,7 +21251,7 @@
                 <a:cs typeface="Times New Roman"/>
                 <a:sym typeface="Times New Roman"/>
               </a:rPr>
-              <a:t>[2] S. Jin, "Large Language Models for Vulnerability Detection in Static Code Analysis: A Survey," in 2025 8th International Conference on Artificial Intelligence and Big Data (ICAIBD), 2025.</a:t>
+              <a:t>Li, J. et al. (2025) 'Steering Large Language Models for Vulnerability Detection', 2025 IEEE International Conference on Acoustics, Speech and Signal Processing (ICASSP).</a:t>
             </a:r>
             <a:endParaRPr sz="1200">
               <a:solidFill>
@@ -20756,12 +21264,12 @@
             </a:endParaRPr>
           </a:p>
           <a:p>
-            <a:pPr indent="0" lvl="0" marL="0" marR="0" rtl="0" algn="just">
+            <a:pPr indent="-304800" lvl="0" marL="457200" rtl="0" algn="l">
               <a:lnSpc>
-                <a:spcPct val="100000"/>
+                <a:spcPct val="115000"/>
               </a:lnSpc>
               <a:spcBef>
-                <a:spcPts val="800"/>
+                <a:spcPts val="0"/>
               </a:spcBef>
               <a:spcAft>
                 <a:spcPts val="0"/>
@@ -20771,7 +21279,7 @@
               </a:buClr>
               <a:buSzPts val="1200"/>
               <a:buFont typeface="Times New Roman"/>
-              <a:buNone/>
+              <a:buAutoNum type="arabicPeriod"/>
             </a:pPr>
             <a:r>
               <a:rPr lang="en" sz="1200">
@@ -20783,7 +21291,7 @@
                 <a:cs typeface="Times New Roman"/>
                 <a:sym typeface="Times New Roman"/>
               </a:rPr>
-              <a:t>[3] K. Dozono, J. Engesser, B. Hummelt, T. Roehm, and A. Pretschner, "Should We Evaluate LLM Based Security Analysis Approaches on Open Source Systems?," in 2025 40th IEEE/ACM International Conference on Automated Software Engineering (ASE), 2025.</a:t>
+              <a:t>Kim, M., Caccia, L., Shi, Z., Pereira, M., Côté, M.-A., Yuan, X., and Sordoni, A. (2025) 'Learning to Extract Context for Context-Aware LLM Inference', Microsoft Research.</a:t>
             </a:r>
             <a:endParaRPr sz="1200">
               <a:solidFill>
@@ -20796,12 +21304,12 @@
             </a:endParaRPr>
           </a:p>
           <a:p>
-            <a:pPr indent="0" lvl="0" marL="0" marR="0" rtl="0" algn="just">
+            <a:pPr indent="-304800" lvl="0" marL="457200" rtl="0" algn="l">
               <a:lnSpc>
-                <a:spcPct val="100000"/>
+                <a:spcPct val="115000"/>
               </a:lnSpc>
               <a:spcBef>
-                <a:spcPts val="800"/>
+                <a:spcPts val="0"/>
               </a:spcBef>
               <a:spcAft>
                 <a:spcPts val="0"/>
@@ -20811,7 +21319,7 @@
               </a:buClr>
               <a:buSzPts val="1200"/>
               <a:buFont typeface="Times New Roman"/>
-              <a:buNone/>
+              <a:buAutoNum type="arabicPeriod"/>
             </a:pPr>
             <a:r>
               <a:rPr lang="en" sz="1200">
@@ -20823,7 +21331,7 @@
                 <a:cs typeface="Times New Roman"/>
                 <a:sym typeface="Times New Roman"/>
               </a:rPr>
-              <a:t>[4] Z. Guo et al., "Mitigating False Positive Static Analysis Warnings: Progress, Challenges, and Opportunities," IEEE Transactions on Software Engineering, vol. 49, no. 12, pp. 5154-5186, Dec. 2023.</a:t>
+              <a:t>Jin, S. (2025) 'Large Language Models for Vulnerability Detection in Static Code Analysis: A Survey', 2025 8th International Conference on Artificial Intelligence and Big Data (ICAIBD).</a:t>
             </a:r>
             <a:endParaRPr sz="1200">
               <a:solidFill>
@@ -20836,12 +21344,12 @@
             </a:endParaRPr>
           </a:p>
           <a:p>
-            <a:pPr indent="0" lvl="0" marL="0" marR="0" rtl="0" algn="just">
+            <a:pPr indent="-304800" lvl="0" marL="457200" rtl="0" algn="l">
               <a:lnSpc>
-                <a:spcPct val="100000"/>
+                <a:spcPct val="115000"/>
               </a:lnSpc>
               <a:spcBef>
-                <a:spcPts val="800"/>
+                <a:spcPts val="0"/>
               </a:spcBef>
               <a:spcAft>
                 <a:spcPts val="0"/>
@@ -20851,7 +21359,7 @@
               </a:buClr>
               <a:buSzPts val="1200"/>
               <a:buFont typeface="Times New Roman"/>
-              <a:buNone/>
+              <a:buAutoNum type="arabicPeriod"/>
             </a:pPr>
             <a:r>
               <a:rPr lang="en" sz="1200">
@@ -20863,7 +21371,7 @@
                 <a:cs typeface="Times New Roman"/>
                 <a:sym typeface="Times New Roman"/>
               </a:rPr>
-              <a:t>[5] J. Li et al., "Steering Large Language Models for Vulnerability Detection," in 2025 IEEE International Conference on Acoustics, Speech and Signal Processing (ICASSP), 2025.</a:t>
+              <a:t>Dozono, K., Engesser, J., Hummelt, B., Roehm, T., and Pretschner, A. (2025) 'Should We Evaluate LLM Based Security Analysis Approaches on Open Source Systems?', 2025 40th IEEE/ACM International Conference on Automated Software Engineering (ASE).</a:t>
             </a:r>
             <a:endParaRPr sz="1200">
               <a:solidFill>
@@ -20876,12 +21384,12 @@
             </a:endParaRPr>
           </a:p>
           <a:p>
-            <a:pPr indent="0" lvl="0" marL="0" marR="0" rtl="0" algn="just">
+            <a:pPr indent="-304800" lvl="0" marL="457200" rtl="0" algn="l">
               <a:lnSpc>
-                <a:spcPct val="100000"/>
+                <a:spcPct val="115000"/>
               </a:lnSpc>
               <a:spcBef>
-                <a:spcPts val="800"/>
+                <a:spcPts val="0"/>
               </a:spcBef>
               <a:spcAft>
                 <a:spcPts val="0"/>
@@ -20891,7 +21399,7 @@
               </a:buClr>
               <a:buSzPts val="1200"/>
               <a:buFont typeface="Times New Roman"/>
-              <a:buNone/>
+              <a:buAutoNum type="arabicPeriod"/>
             </a:pPr>
             <a:r>
               <a:rPr lang="en" sz="1200">
@@ -20903,7 +21411,7 @@
                 <a:cs typeface="Times New Roman"/>
                 <a:sym typeface="Times New Roman"/>
               </a:rPr>
-              <a:t>[6] T. Muske and U. P. Khedker, "Efficient Elimination of False Positives using Static Analysis," in 2015 IEEE, 2015.</a:t>
+              <a:t>Apostolidis, G. D., Kalouptsoglou, I., Siavvas, M., Kehagias, D., and Tzovaras, D. (2025) 'AI-Enhanced Static Analysis: Reducing False Alarms Using Large Language Models', 2025 IEEE International Conference on Smart Computing (SMARTCOMP).</a:t>
             </a:r>
             <a:endParaRPr sz="1200">
               <a:solidFill>
@@ -20916,12 +21424,12 @@
             </a:endParaRPr>
           </a:p>
           <a:p>
-            <a:pPr indent="0" lvl="0" marL="0" marR="0" rtl="0" algn="just">
+            <a:pPr indent="-304800" lvl="0" marL="457200" rtl="0" algn="l">
               <a:lnSpc>
-                <a:spcPct val="100000"/>
+                <a:spcPct val="115000"/>
               </a:lnSpc>
               <a:spcBef>
-                <a:spcPts val="800"/>
+                <a:spcPts val="0"/>
               </a:spcBef>
               <a:spcAft>
                 <a:spcPts val="0"/>
@@ -20931,7 +21439,7 @@
               </a:buClr>
               <a:buSzPts val="1200"/>
               <a:buFont typeface="Times New Roman"/>
-              <a:buNone/>
+              <a:buAutoNum type="arabicPeriod"/>
             </a:pPr>
             <a:r>
               <a:rPr lang="en" sz="1200">
@@ -20943,7 +21451,7 @@
                 <a:cs typeface="Times New Roman"/>
                 <a:sym typeface="Times New Roman"/>
               </a:rPr>
-              <a:t>[7] M. Kim, L. Caccia, Z. Shi, M. Pereira, M.-A. Côté, X. Yuan, and A. Sordoni, "Learning to Extract Context for Context-Aware LLM Inference," Microsoft Research, 2025.</a:t>
+              <a:t>Guo, Z. et al. (2023) 'Mitigating False Positive Static Analysis Warnings: Progress, Challenges, and Opportunities', IEEE Transactions on Software Engineering, Vol. 49, No. 12, pp. 5154-5186.</a:t>
             </a:r>
             <a:endParaRPr sz="1200">
               <a:solidFill>
@@ -20956,17 +21464,22 @@
             </a:endParaRPr>
           </a:p>
           <a:p>
-            <a:pPr indent="0" lvl="0" marL="0" marR="0" rtl="0" algn="just">
+            <a:pPr indent="-304800" lvl="0" marL="457200" rtl="0" algn="l">
               <a:lnSpc>
-                <a:spcPct val="100000"/>
+                <a:spcPct val="115000"/>
               </a:lnSpc>
               <a:spcBef>
-                <a:spcPts val="800"/>
-              </a:spcBef>
-              <a:spcAft>
-                <a:spcPts val="0"/>
-              </a:spcAft>
-              <a:buNone/>
+                <a:spcPts val="0"/>
+              </a:spcBef>
+              <a:spcAft>
+                <a:spcPts val="0"/>
+              </a:spcAft>
+              <a:buClr>
+                <a:schemeClr val="dk1"/>
+              </a:buClr>
+              <a:buSzPts val="1200"/>
+              <a:buFont typeface="Times New Roman"/>
+              <a:buAutoNum type="arabicPeriod"/>
             </a:pPr>
             <a:r>
               <a:rPr lang="en" sz="1200">
@@ -20978,7 +21491,7 @@
                 <a:cs typeface="Times New Roman"/>
                 <a:sym typeface="Times New Roman"/>
               </a:rPr>
-              <a:t>[8] D. Schwarz, "Countermind: A Multi-Layered Security Architecture for Large Language Models," arXiv preprint arXiv:2510.11837v1, Oct. 2025.</a:t>
+              <a:t>Muske, T. and Khedker, U. P. (2015) 'Efficient Elimination of False Positives using Static Analysis', 2015 IEEE.</a:t>
             </a:r>
             <a:endParaRPr sz="1200">
               <a:solidFill>
@@ -23051,7 +23564,7 @@
             <a:tbl>
               <a:tblPr bandRow="1" firstRow="1">
                 <a:noFill/>
-                <a:tableStyleId>{91615823-763D-4289-AFF7-78FB870AD9B0}</a:tableStyleId>
+                <a:tableStyleId>{4988CF06-5FA7-4D49-9562-FA9D673A86ED}</a:tableStyleId>
               </a:tblPr>
               <a:tblGrid>
                 <a:gridCol w="872025"/>
@@ -23097,7 +23610,17 @@
                       </a:endParaRPr>
                     </a:p>
                   </a:txBody>
-                  <a:tcPr marT="45725" marB="45725" marR="91450" marL="91450"/>
+                  <a:tcPr marT="45725" marB="45725" marR="91450" marL="91450">
+                    <a:lnB cap="flat" cmpd="sng" w="12700">
+                      <a:solidFill>
+                        <a:schemeClr val="lt1"/>
+                      </a:solidFill>
+                      <a:prstDash val="solid"/>
+                      <a:round/>
+                      <a:headEnd len="sm" w="sm" type="none"/>
+                      <a:tailEnd len="sm" w="sm" type="none"/>
+                    </a:lnB>
+                  </a:tcPr>
                 </a:tc>
                 <a:tc>
                   <a:txBody>
@@ -23166,7 +23689,17 @@
                       </a:endParaRPr>
                     </a:p>
                   </a:txBody>
-                  <a:tcPr marT="45725" marB="45725" marR="91450" marL="91450"/>
+                  <a:tcPr marT="45725" marB="45725" marR="91450" marL="91450">
+                    <a:lnB cap="flat" cmpd="sng" w="12700">
+                      <a:solidFill>
+                        <a:schemeClr val="lt1"/>
+                      </a:solidFill>
+                      <a:prstDash val="solid"/>
+                      <a:round/>
+                      <a:headEnd len="sm" w="sm" type="none"/>
+                      <a:tailEnd len="sm" w="sm" type="none"/>
+                    </a:lnB>
+                  </a:tcPr>
                 </a:tc>
                 <a:tc>
                   <a:txBody>
@@ -23204,7 +23737,17 @@
                       </a:endParaRPr>
                     </a:p>
                   </a:txBody>
-                  <a:tcPr marT="45725" marB="45725" marR="91450" marL="91450"/>
+                  <a:tcPr marT="45725" marB="45725" marR="91450" marL="91450">
+                    <a:lnB cap="flat" cmpd="sng" w="12700">
+                      <a:solidFill>
+                        <a:schemeClr val="lt1"/>
+                      </a:solidFill>
+                      <a:prstDash val="solid"/>
+                      <a:round/>
+                      <a:headEnd len="sm" w="sm" type="none"/>
+                      <a:tailEnd len="sm" w="sm" type="none"/>
+                    </a:lnB>
+                  </a:tcPr>
                 </a:tc>
                 <a:tc>
                   <a:txBody>
@@ -23242,7 +23785,17 @@
                       </a:endParaRPr>
                     </a:p>
                   </a:txBody>
-                  <a:tcPr marT="45725" marB="45725" marR="91450" marL="91450"/>
+                  <a:tcPr marT="45725" marB="45725" marR="91450" marL="91450">
+                    <a:lnB cap="flat" cmpd="sng" w="12700">
+                      <a:solidFill>
+                        <a:schemeClr val="lt1"/>
+                      </a:solidFill>
+                      <a:prstDash val="solid"/>
+                      <a:round/>
+                      <a:headEnd len="sm" w="sm" type="none"/>
+                      <a:tailEnd len="sm" w="sm" type="none"/>
+                    </a:lnB>
+                  </a:tcPr>
                 </a:tc>
                 <a:tc>
                   <a:txBody>
@@ -23280,7 +23833,17 @@
                       </a:endParaRPr>
                     </a:p>
                   </a:txBody>
-                  <a:tcPr marT="45725" marB="45725" marR="91450" marL="91450"/>
+                  <a:tcPr marT="45725" marB="45725" marR="91450" marL="91450">
+                    <a:lnB cap="flat" cmpd="sng" w="12700">
+                      <a:solidFill>
+                        <a:schemeClr val="lt1"/>
+                      </a:solidFill>
+                      <a:prstDash val="solid"/>
+                      <a:round/>
+                      <a:headEnd len="sm" w="sm" type="none"/>
+                      <a:tailEnd len="sm" w="sm" type="none"/>
+                    </a:lnB>
+                  </a:tcPr>
                 </a:tc>
               </a:tr>
               <a:tr h="751200">
@@ -23310,7 +23873,7 @@
                           <a:cs typeface="Times New Roman"/>
                           <a:sym typeface="Times New Roman"/>
                         </a:rPr>
-                        <a:t>Apostolidis et al. (2025)</a:t>
+                        <a:t>Schwarz (2025)</a:t>
                       </a:r>
                       <a:endParaRPr b="0" sz="1000" u="none" cap="none" strike="noStrike">
                         <a:latin typeface="Times New Roman"/>
@@ -23320,7 +23883,44 @@
                       </a:endParaRPr>
                     </a:p>
                   </a:txBody>
-                  <a:tcPr marT="45725" marB="45725" marR="91450" marL="91450"/>
+                  <a:tcPr marT="45725" marB="45725" marR="91450" marL="91450">
+                    <a:lnL cap="flat" cmpd="sng" w="12700">
+                      <a:solidFill>
+                        <a:schemeClr val="lt1"/>
+                      </a:solidFill>
+                      <a:prstDash val="solid"/>
+                      <a:round/>
+                      <a:headEnd len="sm" w="sm" type="none"/>
+                      <a:tailEnd len="sm" w="sm" type="none"/>
+                    </a:lnL>
+                    <a:lnR cap="flat" cmpd="sng" w="12700">
+                      <a:solidFill>
+                        <a:schemeClr val="lt1"/>
+                      </a:solidFill>
+                      <a:prstDash val="solid"/>
+                      <a:round/>
+                      <a:headEnd len="sm" w="sm" type="none"/>
+                      <a:tailEnd len="sm" w="sm" type="none"/>
+                    </a:lnR>
+                    <a:lnT cap="flat" cmpd="sng" w="12700">
+                      <a:solidFill>
+                        <a:schemeClr val="lt1"/>
+                      </a:solidFill>
+                      <a:prstDash val="solid"/>
+                      <a:round/>
+                      <a:headEnd len="sm" w="sm" type="none"/>
+                      <a:tailEnd len="sm" w="sm" type="none"/>
+                    </a:lnT>
+                    <a:lnB cap="flat" cmpd="sng" w="12700">
+                      <a:solidFill>
+                        <a:schemeClr val="lt1"/>
+                      </a:solidFill>
+                      <a:prstDash val="solid"/>
+                      <a:round/>
+                      <a:headEnd len="sm" w="sm" type="none"/>
+                      <a:tailEnd len="sm" w="sm" type="none"/>
+                    </a:lnB>
+                  </a:tcPr>
                 </a:tc>
                 <a:tc>
                   <a:txBody>
@@ -23348,7 +23948,7 @@
                           <a:cs typeface="Times New Roman"/>
                           <a:sym typeface="Times New Roman"/>
                         </a:rPr>
-                        <a:t>CppCheck static analysis filtered by a fine-tuned CodeBERT vulnerability prediction model.</a:t>
+                        <a:t>"Countermind" multi-layered security architecture using Semantic Boundary Logic (SBL) and Parameter-Space Restriction (PSR).</a:t>
                       </a:r>
                       <a:endParaRPr b="0" sz="1000" u="none" cap="none" strike="noStrike">
                         <a:latin typeface="Times New Roman"/>
@@ -23358,7 +23958,44 @@
                       </a:endParaRPr>
                     </a:p>
                   </a:txBody>
-                  <a:tcPr marT="45725" marB="45725" marR="91450" marL="91450"/>
+                  <a:tcPr marT="45725" marB="45725" marR="91450" marL="91450">
+                    <a:lnL cap="flat" cmpd="sng" w="12700">
+                      <a:solidFill>
+                        <a:schemeClr val="lt1"/>
+                      </a:solidFill>
+                      <a:prstDash val="solid"/>
+                      <a:round/>
+                      <a:headEnd len="sm" w="sm" type="none"/>
+                      <a:tailEnd len="sm" w="sm" type="none"/>
+                    </a:lnL>
+                    <a:lnR cap="flat" cmpd="sng" w="12700">
+                      <a:solidFill>
+                        <a:schemeClr val="lt1"/>
+                      </a:solidFill>
+                      <a:prstDash val="solid"/>
+                      <a:round/>
+                      <a:headEnd len="sm" w="sm" type="none"/>
+                      <a:tailEnd len="sm" w="sm" type="none"/>
+                    </a:lnR>
+                    <a:lnT cap="flat" cmpd="sng" w="12700">
+                      <a:solidFill>
+                        <a:schemeClr val="lt1"/>
+                      </a:solidFill>
+                      <a:prstDash val="solid"/>
+                      <a:round/>
+                      <a:headEnd len="sm" w="sm" type="none"/>
+                      <a:tailEnd len="sm" w="sm" type="none"/>
+                    </a:lnT>
+                    <a:lnB cap="flat" cmpd="sng" w="12700">
+                      <a:solidFill>
+                        <a:schemeClr val="lt1"/>
+                      </a:solidFill>
+                      <a:prstDash val="solid"/>
+                      <a:round/>
+                      <a:headEnd len="sm" w="sm" type="none"/>
+                      <a:tailEnd len="sm" w="sm" type="none"/>
+                    </a:lnB>
+                  </a:tcPr>
                 </a:tc>
                 <a:tc>
                   <a:txBody>
@@ -23386,7 +24023,7 @@
                           <a:cs typeface="Times New Roman"/>
                           <a:sym typeface="Times New Roman"/>
                         </a:rPr>
-                        <a:t>Big-Vul and ReVeal (C/C++ GitHub samples).</a:t>
+                        <a:t>N/A (Conceptual/Architectural design).</a:t>
                       </a:r>
                       <a:endParaRPr b="0" sz="1000" u="none" cap="none" strike="noStrike">
                         <a:latin typeface="Times New Roman"/>
@@ -23396,7 +24033,44 @@
                       </a:endParaRPr>
                     </a:p>
                   </a:txBody>
-                  <a:tcPr marT="45725" marB="45725" marR="91450" marL="91450"/>
+                  <a:tcPr marT="45725" marB="45725" marR="91450" marL="91450">
+                    <a:lnL cap="flat" cmpd="sng" w="12700">
+                      <a:solidFill>
+                        <a:schemeClr val="lt1"/>
+                      </a:solidFill>
+                      <a:prstDash val="solid"/>
+                      <a:round/>
+                      <a:headEnd len="sm" w="sm" type="none"/>
+                      <a:tailEnd len="sm" w="sm" type="none"/>
+                    </a:lnL>
+                    <a:lnR cap="flat" cmpd="sng" w="12700">
+                      <a:solidFill>
+                        <a:schemeClr val="lt1"/>
+                      </a:solidFill>
+                      <a:prstDash val="solid"/>
+                      <a:round/>
+                      <a:headEnd len="sm" w="sm" type="none"/>
+                      <a:tailEnd len="sm" w="sm" type="none"/>
+                    </a:lnR>
+                    <a:lnT cap="flat" cmpd="sng" w="12700">
+                      <a:solidFill>
+                        <a:schemeClr val="lt1"/>
+                      </a:solidFill>
+                      <a:prstDash val="solid"/>
+                      <a:round/>
+                      <a:headEnd len="sm" w="sm" type="none"/>
+                      <a:tailEnd len="sm" w="sm" type="none"/>
+                    </a:lnT>
+                    <a:lnB cap="flat" cmpd="sng" w="12700">
+                      <a:solidFill>
+                        <a:schemeClr val="lt1"/>
+                      </a:solidFill>
+                      <a:prstDash val="solid"/>
+                      <a:round/>
+                      <a:headEnd len="sm" w="sm" type="none"/>
+                      <a:tailEnd len="sm" w="sm" type="none"/>
+                    </a:lnB>
+                  </a:tcPr>
                 </a:tc>
                 <a:tc>
                   <a:txBody>
@@ -23424,7 +24098,7 @@
                           <a:cs typeface="Times New Roman"/>
                           <a:sym typeface="Times New Roman"/>
                         </a:rPr>
-                        <a:t>Reduced false positives, improving static analysis practicality with minimal impact on detection accuracy.</a:t>
+                        <a:t>Shifts LLM defenses from reactive post-hoc filtering to proactive pre-inference structural validation.</a:t>
                       </a:r>
                       <a:endParaRPr b="0" sz="1000" u="none" cap="none" strike="noStrike">
                         <a:latin typeface="Times New Roman"/>
@@ -23434,7 +24108,44 @@
                       </a:endParaRPr>
                     </a:p>
                   </a:txBody>
-                  <a:tcPr marT="45725" marB="45725" marR="91450" marL="91450"/>
+                  <a:tcPr marT="45725" marB="45725" marR="91450" marL="91450">
+                    <a:lnL cap="flat" cmpd="sng" w="12700">
+                      <a:solidFill>
+                        <a:schemeClr val="lt1"/>
+                      </a:solidFill>
+                      <a:prstDash val="solid"/>
+                      <a:round/>
+                      <a:headEnd len="sm" w="sm" type="none"/>
+                      <a:tailEnd len="sm" w="sm" type="none"/>
+                    </a:lnL>
+                    <a:lnR cap="flat" cmpd="sng" w="12700">
+                      <a:solidFill>
+                        <a:schemeClr val="lt1"/>
+                      </a:solidFill>
+                      <a:prstDash val="solid"/>
+                      <a:round/>
+                      <a:headEnd len="sm" w="sm" type="none"/>
+                      <a:tailEnd len="sm" w="sm" type="none"/>
+                    </a:lnR>
+                    <a:lnT cap="flat" cmpd="sng" w="12700">
+                      <a:solidFill>
+                        <a:schemeClr val="lt1"/>
+                      </a:solidFill>
+                      <a:prstDash val="solid"/>
+                      <a:round/>
+                      <a:headEnd len="sm" w="sm" type="none"/>
+                      <a:tailEnd len="sm" w="sm" type="none"/>
+                    </a:lnT>
+                    <a:lnB cap="flat" cmpd="sng" w="12700">
+                      <a:solidFill>
+                        <a:schemeClr val="lt1"/>
+                      </a:solidFill>
+                      <a:prstDash val="solid"/>
+                      <a:round/>
+                      <a:headEnd len="sm" w="sm" type="none"/>
+                      <a:tailEnd len="sm" w="sm" type="none"/>
+                    </a:lnB>
+                  </a:tcPr>
                 </a:tc>
                 <a:tc>
                   <a:txBody>
@@ -23462,7 +24173,7 @@
                           <a:cs typeface="Times New Roman"/>
                           <a:sym typeface="Times New Roman"/>
                         </a:rPr>
-                        <a:t>Vulnerability prediction models lack line-level granularity; static tools suffer from overwhelming false alarms.</a:t>
+                        <a:t>Post-hoc filters are brittle against prompt injections; models inherently struggle to distinguish trusted instructions from untrusted data.</a:t>
                       </a:r>
                       <a:endParaRPr b="0" sz="1000" u="none" cap="none" strike="noStrike">
                         <a:latin typeface="Times New Roman"/>
@@ -23472,10 +24183,801 @@
                       </a:endParaRPr>
                     </a:p>
                   </a:txBody>
-                  <a:tcPr marT="45725" marB="45725" marR="91450" marL="91450"/>
+                  <a:tcPr marT="45725" marB="45725" marR="91450" marL="91450">
+                    <a:lnL cap="flat" cmpd="sng" w="12700">
+                      <a:solidFill>
+                        <a:schemeClr val="lt1"/>
+                      </a:solidFill>
+                      <a:prstDash val="solid"/>
+                      <a:round/>
+                      <a:headEnd len="sm" w="sm" type="none"/>
+                      <a:tailEnd len="sm" w="sm" type="none"/>
+                    </a:lnL>
+                    <a:lnR cap="flat" cmpd="sng" w="12700">
+                      <a:solidFill>
+                        <a:schemeClr val="lt1"/>
+                      </a:solidFill>
+                      <a:prstDash val="solid"/>
+                      <a:round/>
+                      <a:headEnd len="sm" w="sm" type="none"/>
+                      <a:tailEnd len="sm" w="sm" type="none"/>
+                    </a:lnR>
+                    <a:lnT cap="flat" cmpd="sng" w="12700">
+                      <a:solidFill>
+                        <a:schemeClr val="lt1"/>
+                      </a:solidFill>
+                      <a:prstDash val="solid"/>
+                      <a:round/>
+                      <a:headEnd len="sm" w="sm" type="none"/>
+                      <a:tailEnd len="sm" w="sm" type="none"/>
+                    </a:lnT>
+                    <a:lnB cap="flat" cmpd="sng" w="12700">
+                      <a:solidFill>
+                        <a:schemeClr val="lt1"/>
+                      </a:solidFill>
+                      <a:prstDash val="solid"/>
+                      <a:round/>
+                      <a:headEnd len="sm" w="sm" type="none"/>
+                      <a:tailEnd len="sm" w="sm" type="none"/>
+                    </a:lnB>
+                  </a:tcPr>
                 </a:tc>
               </a:tr>
-              <a:tr h="750575">
+              <a:tr h="751200">
+                <a:tc>
+                  <a:txBody>
+                    <a:bodyPr/>
+                    <a:lstStyle/>
+                    <a:p>
+                      <a:pPr indent="0" lvl="0" marL="0" marR="0" rtl="0" algn="l">
+                        <a:spcBef>
+                          <a:spcPts val="0"/>
+                        </a:spcBef>
+                        <a:spcAft>
+                          <a:spcPts val="0"/>
+                        </a:spcAft>
+                        <a:buClr>
+                          <a:schemeClr val="dk1"/>
+                        </a:buClr>
+                        <a:buSzPts val="1000"/>
+                        <a:buFont typeface="Times New Roman"/>
+                        <a:buNone/>
+                      </a:pPr>
+                      <a:r>
+                        <a:rPr b="0" lang="en" sz="1000" u="none" cap="none" strike="noStrike">
+                          <a:latin typeface="Times New Roman"/>
+                          <a:ea typeface="Times New Roman"/>
+                          <a:cs typeface="Times New Roman"/>
+                          <a:sym typeface="Times New Roman"/>
+                        </a:rPr>
+                        <a:t>Li et al. (2025)</a:t>
+                      </a:r>
+                      <a:endParaRPr b="0" sz="1000" u="none" cap="none" strike="noStrike">
+                        <a:latin typeface="Times New Roman"/>
+                        <a:ea typeface="Times New Roman"/>
+                        <a:cs typeface="Times New Roman"/>
+                        <a:sym typeface="Times New Roman"/>
+                      </a:endParaRPr>
+                    </a:p>
+                  </a:txBody>
+                  <a:tcPr marT="45725" marB="45725" marR="91450" marL="91450">
+                    <a:lnL cap="flat" cmpd="sng" w="12700">
+                      <a:solidFill>
+                        <a:schemeClr val="lt1"/>
+                      </a:solidFill>
+                      <a:prstDash val="solid"/>
+                      <a:round/>
+                      <a:headEnd len="sm" w="sm" type="none"/>
+                      <a:tailEnd len="sm" w="sm" type="none"/>
+                    </a:lnL>
+                    <a:lnR cap="flat" cmpd="sng" w="12700">
+                      <a:solidFill>
+                        <a:schemeClr val="lt1"/>
+                      </a:solidFill>
+                      <a:prstDash val="solid"/>
+                      <a:round/>
+                      <a:headEnd len="sm" w="sm" type="none"/>
+                      <a:tailEnd len="sm" w="sm" type="none"/>
+                    </a:lnR>
+                    <a:lnT cap="flat" cmpd="sng" w="12700">
+                      <a:solidFill>
+                        <a:schemeClr val="lt1"/>
+                      </a:solidFill>
+                      <a:prstDash val="solid"/>
+                      <a:round/>
+                      <a:headEnd len="sm" w="sm" type="none"/>
+                      <a:tailEnd len="sm" w="sm" type="none"/>
+                    </a:lnT>
+                    <a:lnB cap="flat" cmpd="sng" w="12700">
+                      <a:solidFill>
+                        <a:schemeClr val="lt1"/>
+                      </a:solidFill>
+                      <a:prstDash val="solid"/>
+                      <a:round/>
+                      <a:headEnd len="sm" w="sm" type="none"/>
+                      <a:tailEnd len="sm" w="sm" type="none"/>
+                    </a:lnB>
+                  </a:tcPr>
+                </a:tc>
+                <a:tc>
+                  <a:txBody>
+                    <a:bodyPr/>
+                    <a:lstStyle/>
+                    <a:p>
+                      <a:pPr indent="0" lvl="0" marL="0" marR="0" rtl="0" algn="l">
+                        <a:spcBef>
+                          <a:spcPts val="0"/>
+                        </a:spcBef>
+                        <a:spcAft>
+                          <a:spcPts val="0"/>
+                        </a:spcAft>
+                        <a:buClr>
+                          <a:schemeClr val="dk1"/>
+                        </a:buClr>
+                        <a:buSzPts val="1000"/>
+                        <a:buFont typeface="Times New Roman"/>
+                        <a:buNone/>
+                      </a:pPr>
+                      <a:r>
+                        <a:rPr b="0" lang="en" sz="1000" u="none" cap="none" strike="noStrike">
+                          <a:latin typeface="Times New Roman"/>
+                          <a:ea typeface="Times New Roman"/>
+                          <a:cs typeface="Times New Roman"/>
+                          <a:sym typeface="Times New Roman"/>
+                        </a:rPr>
+                        <a:t>Injecting vulnerability steering vectors into LLM activation layers without altering original parameters.</a:t>
+                      </a:r>
+                      <a:endParaRPr b="0" sz="1000" u="none" cap="none" strike="noStrike">
+                        <a:latin typeface="Times New Roman"/>
+                        <a:ea typeface="Times New Roman"/>
+                        <a:cs typeface="Times New Roman"/>
+                        <a:sym typeface="Times New Roman"/>
+                      </a:endParaRPr>
+                    </a:p>
+                  </a:txBody>
+                  <a:tcPr marT="45725" marB="45725" marR="91450" marL="91450">
+                    <a:lnL cap="flat" cmpd="sng" w="12700">
+                      <a:solidFill>
+                        <a:schemeClr val="lt1"/>
+                      </a:solidFill>
+                      <a:prstDash val="solid"/>
+                      <a:round/>
+                      <a:headEnd len="sm" w="sm" type="none"/>
+                      <a:tailEnd len="sm" w="sm" type="none"/>
+                    </a:lnL>
+                    <a:lnR cap="flat" cmpd="sng" w="12700">
+                      <a:solidFill>
+                        <a:schemeClr val="lt1"/>
+                      </a:solidFill>
+                      <a:prstDash val="solid"/>
+                      <a:round/>
+                      <a:headEnd len="sm" w="sm" type="none"/>
+                      <a:tailEnd len="sm" w="sm" type="none"/>
+                    </a:lnR>
+                    <a:lnT cap="flat" cmpd="sng" w="12700">
+                      <a:solidFill>
+                        <a:schemeClr val="lt1"/>
+                      </a:solidFill>
+                      <a:prstDash val="solid"/>
+                      <a:round/>
+                      <a:headEnd len="sm" w="sm" type="none"/>
+                      <a:tailEnd len="sm" w="sm" type="none"/>
+                    </a:lnT>
+                    <a:lnB cap="flat" cmpd="sng" w="12700">
+                      <a:solidFill>
+                        <a:schemeClr val="lt1"/>
+                      </a:solidFill>
+                      <a:prstDash val="solid"/>
+                      <a:round/>
+                      <a:headEnd len="sm" w="sm" type="none"/>
+                      <a:tailEnd len="sm" w="sm" type="none"/>
+                    </a:lnB>
+                  </a:tcPr>
+                </a:tc>
+                <a:tc>
+                  <a:txBody>
+                    <a:bodyPr/>
+                    <a:lstStyle/>
+                    <a:p>
+                      <a:pPr indent="0" lvl="0" marL="0" marR="0" rtl="0" algn="l">
+                        <a:spcBef>
+                          <a:spcPts val="0"/>
+                        </a:spcBef>
+                        <a:spcAft>
+                          <a:spcPts val="0"/>
+                        </a:spcAft>
+                        <a:buClr>
+                          <a:schemeClr val="dk1"/>
+                        </a:buClr>
+                        <a:buSzPts val="1000"/>
+                        <a:buFont typeface="Times New Roman"/>
+                        <a:buNone/>
+                      </a:pPr>
+                      <a:r>
+                        <a:rPr b="0" lang="en" sz="1000" u="none" cap="none" strike="noStrike">
+                          <a:latin typeface="Times New Roman"/>
+                          <a:ea typeface="Times New Roman"/>
+                          <a:cs typeface="Times New Roman"/>
+                          <a:sym typeface="Times New Roman"/>
+                        </a:rPr>
+                        <a:t>SARD, FFmpeg+Qemu, Reveal, REEF.</a:t>
+                      </a:r>
+                      <a:endParaRPr b="0" sz="1000" u="none" cap="none" strike="noStrike">
+                        <a:latin typeface="Times New Roman"/>
+                        <a:ea typeface="Times New Roman"/>
+                        <a:cs typeface="Times New Roman"/>
+                        <a:sym typeface="Times New Roman"/>
+                      </a:endParaRPr>
+                    </a:p>
+                  </a:txBody>
+                  <a:tcPr marT="45725" marB="45725" marR="91450" marL="91450">
+                    <a:lnL cap="flat" cmpd="sng" w="12700">
+                      <a:solidFill>
+                        <a:schemeClr val="lt1"/>
+                      </a:solidFill>
+                      <a:prstDash val="solid"/>
+                      <a:round/>
+                      <a:headEnd len="sm" w="sm" type="none"/>
+                      <a:tailEnd len="sm" w="sm" type="none"/>
+                    </a:lnL>
+                    <a:lnR cap="flat" cmpd="sng" w="12700">
+                      <a:solidFill>
+                        <a:schemeClr val="lt1"/>
+                      </a:solidFill>
+                      <a:prstDash val="solid"/>
+                      <a:round/>
+                      <a:headEnd len="sm" w="sm" type="none"/>
+                      <a:tailEnd len="sm" w="sm" type="none"/>
+                    </a:lnR>
+                    <a:lnT cap="flat" cmpd="sng" w="12700">
+                      <a:solidFill>
+                        <a:schemeClr val="lt1"/>
+                      </a:solidFill>
+                      <a:prstDash val="solid"/>
+                      <a:round/>
+                      <a:headEnd len="sm" w="sm" type="none"/>
+                      <a:tailEnd len="sm" w="sm" type="none"/>
+                    </a:lnT>
+                    <a:lnB cap="flat" cmpd="sng" w="12700">
+                      <a:solidFill>
+                        <a:schemeClr val="lt1"/>
+                      </a:solidFill>
+                      <a:prstDash val="solid"/>
+                      <a:round/>
+                      <a:headEnd len="sm" w="sm" type="none"/>
+                      <a:tailEnd len="sm" w="sm" type="none"/>
+                    </a:lnB>
+                  </a:tcPr>
+                </a:tc>
+                <a:tc>
+                  <a:txBody>
+                    <a:bodyPr/>
+                    <a:lstStyle/>
+                    <a:p>
+                      <a:pPr indent="0" lvl="0" marL="0" marR="0" rtl="0" algn="l">
+                        <a:spcBef>
+                          <a:spcPts val="0"/>
+                        </a:spcBef>
+                        <a:spcAft>
+                          <a:spcPts val="0"/>
+                        </a:spcAft>
+                        <a:buClr>
+                          <a:schemeClr val="dk1"/>
+                        </a:buClr>
+                        <a:buSzPts val="1000"/>
+                        <a:buFont typeface="Times New Roman"/>
+                        <a:buNone/>
+                      </a:pPr>
+                      <a:r>
+                        <a:rPr b="0" lang="en" sz="1000" u="none" cap="none" strike="noStrike">
+                          <a:latin typeface="Times New Roman"/>
+                          <a:ea typeface="Times New Roman"/>
+                          <a:cs typeface="Times New Roman"/>
+                          <a:sym typeface="Times New Roman"/>
+                        </a:rPr>
+                        <a:t>Outperformed state-of-the-art methods with a 12.86% F1-score increase on real-world datasets.</a:t>
+                      </a:r>
+                      <a:endParaRPr b="0" sz="1000" u="none" cap="none" strike="noStrike">
+                        <a:latin typeface="Times New Roman"/>
+                        <a:ea typeface="Times New Roman"/>
+                        <a:cs typeface="Times New Roman"/>
+                        <a:sym typeface="Times New Roman"/>
+                      </a:endParaRPr>
+                    </a:p>
+                  </a:txBody>
+                  <a:tcPr marT="45725" marB="45725" marR="91450" marL="91450">
+                    <a:lnL cap="flat" cmpd="sng" w="12700">
+                      <a:solidFill>
+                        <a:schemeClr val="lt1"/>
+                      </a:solidFill>
+                      <a:prstDash val="solid"/>
+                      <a:round/>
+                      <a:headEnd len="sm" w="sm" type="none"/>
+                      <a:tailEnd len="sm" w="sm" type="none"/>
+                    </a:lnL>
+                    <a:lnR cap="flat" cmpd="sng" w="12700">
+                      <a:solidFill>
+                        <a:schemeClr val="lt1"/>
+                      </a:solidFill>
+                      <a:prstDash val="solid"/>
+                      <a:round/>
+                      <a:headEnd len="sm" w="sm" type="none"/>
+                      <a:tailEnd len="sm" w="sm" type="none"/>
+                    </a:lnR>
+                    <a:lnT cap="flat" cmpd="sng" w="12700">
+                      <a:solidFill>
+                        <a:schemeClr val="lt1"/>
+                      </a:solidFill>
+                      <a:prstDash val="solid"/>
+                      <a:round/>
+                      <a:headEnd len="sm" w="sm" type="none"/>
+                      <a:tailEnd len="sm" w="sm" type="none"/>
+                    </a:lnT>
+                    <a:lnB cap="flat" cmpd="sng" w="12700">
+                      <a:solidFill>
+                        <a:schemeClr val="lt1"/>
+                      </a:solidFill>
+                      <a:prstDash val="solid"/>
+                      <a:round/>
+                      <a:headEnd len="sm" w="sm" type="none"/>
+                      <a:tailEnd len="sm" w="sm" type="none"/>
+                    </a:lnB>
+                  </a:tcPr>
+                </a:tc>
+                <a:tc>
+                  <a:txBody>
+                    <a:bodyPr/>
+                    <a:lstStyle/>
+                    <a:p>
+                      <a:pPr indent="0" lvl="0" marL="0" marR="0" rtl="0" algn="l">
+                        <a:spcBef>
+                          <a:spcPts val="0"/>
+                        </a:spcBef>
+                        <a:spcAft>
+                          <a:spcPts val="0"/>
+                        </a:spcAft>
+                        <a:buClr>
+                          <a:schemeClr val="dk1"/>
+                        </a:buClr>
+                        <a:buSzPts val="1000"/>
+                        <a:buFont typeface="Times New Roman"/>
+                        <a:buNone/>
+                      </a:pPr>
+                      <a:r>
+                        <a:rPr b="0" lang="en" sz="1000" u="none" cap="none" strike="noStrike">
+                          <a:latin typeface="Times New Roman"/>
+                          <a:ea typeface="Times New Roman"/>
+                          <a:cs typeface="Times New Roman"/>
+                          <a:sym typeface="Times New Roman"/>
+                        </a:rPr>
+                        <a:t>Existing representation methods focus on overall semantics instead of isolating specific vulnerability concepts.</a:t>
+                      </a:r>
+                      <a:endParaRPr b="0" sz="1000" u="none" cap="none" strike="noStrike">
+                        <a:latin typeface="Times New Roman"/>
+                        <a:ea typeface="Times New Roman"/>
+                        <a:cs typeface="Times New Roman"/>
+                        <a:sym typeface="Times New Roman"/>
+                      </a:endParaRPr>
+                    </a:p>
+                  </a:txBody>
+                  <a:tcPr marT="45725" marB="45725" marR="91450" marL="91450">
+                    <a:lnL cap="flat" cmpd="sng" w="12700">
+                      <a:solidFill>
+                        <a:schemeClr val="lt1"/>
+                      </a:solidFill>
+                      <a:prstDash val="solid"/>
+                      <a:round/>
+                      <a:headEnd len="sm" w="sm" type="none"/>
+                      <a:tailEnd len="sm" w="sm" type="none"/>
+                    </a:lnL>
+                    <a:lnR cap="flat" cmpd="sng" w="12700">
+                      <a:solidFill>
+                        <a:schemeClr val="lt1"/>
+                      </a:solidFill>
+                      <a:prstDash val="solid"/>
+                      <a:round/>
+                      <a:headEnd len="sm" w="sm" type="none"/>
+                      <a:tailEnd len="sm" w="sm" type="none"/>
+                    </a:lnR>
+                    <a:lnT cap="flat" cmpd="sng" w="12700">
+                      <a:solidFill>
+                        <a:schemeClr val="lt1"/>
+                      </a:solidFill>
+                      <a:prstDash val="solid"/>
+                      <a:round/>
+                      <a:headEnd len="sm" w="sm" type="none"/>
+                      <a:tailEnd len="sm" w="sm" type="none"/>
+                    </a:lnT>
+                    <a:lnB cap="flat" cmpd="sng" w="12700">
+                      <a:solidFill>
+                        <a:schemeClr val="lt1"/>
+                      </a:solidFill>
+                      <a:prstDash val="solid"/>
+                      <a:round/>
+                      <a:headEnd len="sm" w="sm" type="none"/>
+                      <a:tailEnd len="sm" w="sm" type="none"/>
+                    </a:lnB>
+                  </a:tcPr>
+                </a:tc>
+              </a:tr>
+              <a:tr h="751200">
+                <a:tc>
+                  <a:txBody>
+                    <a:bodyPr/>
+                    <a:lstStyle/>
+                    <a:p>
+                      <a:pPr indent="0" lvl="0" marL="0" marR="0" rtl="0" algn="l">
+                        <a:spcBef>
+                          <a:spcPts val="0"/>
+                        </a:spcBef>
+                        <a:spcAft>
+                          <a:spcPts val="0"/>
+                        </a:spcAft>
+                        <a:buClr>
+                          <a:schemeClr val="dk1"/>
+                        </a:buClr>
+                        <a:buSzPts val="1000"/>
+                        <a:buFont typeface="Times New Roman"/>
+                        <a:buNone/>
+                      </a:pPr>
+                      <a:r>
+                        <a:rPr b="0" lang="en" sz="1000" u="none" cap="none" strike="noStrike">
+                          <a:latin typeface="Times New Roman"/>
+                          <a:ea typeface="Times New Roman"/>
+                          <a:cs typeface="Times New Roman"/>
+                          <a:sym typeface="Times New Roman"/>
+                        </a:rPr>
+                        <a:t>Kim et al. (2025)</a:t>
+                      </a:r>
+                      <a:endParaRPr b="0" sz="1000" u="none" cap="none" strike="noStrike">
+                        <a:latin typeface="Times New Roman"/>
+                        <a:ea typeface="Times New Roman"/>
+                        <a:cs typeface="Times New Roman"/>
+                        <a:sym typeface="Times New Roman"/>
+                      </a:endParaRPr>
+                    </a:p>
+                  </a:txBody>
+                  <a:tcPr marT="45725" marB="45725" marR="91450" marL="91450">
+                    <a:lnL cap="flat" cmpd="sng" w="12700">
+                      <a:solidFill>
+                        <a:schemeClr val="lt1"/>
+                      </a:solidFill>
+                      <a:prstDash val="solid"/>
+                      <a:round/>
+                      <a:headEnd len="sm" w="sm" type="none"/>
+                      <a:tailEnd len="sm" w="sm" type="none"/>
+                    </a:lnL>
+                    <a:lnR cap="flat" cmpd="sng" w="12700">
+                      <a:solidFill>
+                        <a:schemeClr val="lt1"/>
+                      </a:solidFill>
+                      <a:prstDash val="solid"/>
+                      <a:round/>
+                      <a:headEnd len="sm" w="sm" type="none"/>
+                      <a:tailEnd len="sm" w="sm" type="none"/>
+                    </a:lnR>
+                    <a:lnT cap="flat" cmpd="sng" w="12700">
+                      <a:solidFill>
+                        <a:schemeClr val="lt1"/>
+                      </a:solidFill>
+                      <a:prstDash val="solid"/>
+                      <a:round/>
+                      <a:headEnd len="sm" w="sm" type="none"/>
+                      <a:tailEnd len="sm" w="sm" type="none"/>
+                    </a:lnT>
+                    <a:lnB cap="flat" cmpd="sng" w="12700">
+                      <a:solidFill>
+                        <a:schemeClr val="lt1"/>
+                      </a:solidFill>
+                      <a:prstDash val="solid"/>
+                      <a:round/>
+                      <a:headEnd len="sm" w="sm" type="none"/>
+                      <a:tailEnd len="sm" w="sm" type="none"/>
+                    </a:lnB>
+                  </a:tcPr>
+                </a:tc>
+                <a:tc>
+                  <a:txBody>
+                    <a:bodyPr/>
+                    <a:lstStyle/>
+                    <a:p>
+                      <a:pPr indent="0" lvl="0" marL="0" marR="0" rtl="0" algn="l">
+                        <a:spcBef>
+                          <a:spcPts val="0"/>
+                        </a:spcBef>
+                        <a:spcAft>
+                          <a:spcPts val="0"/>
+                        </a:spcAft>
+                        <a:buClr>
+                          <a:schemeClr val="dk1"/>
+                        </a:buClr>
+                        <a:buSzPts val="1000"/>
+                        <a:buFont typeface="Times New Roman"/>
+                        <a:buNone/>
+                      </a:pPr>
+                      <a:r>
+                        <a:rPr b="0" lang="en" sz="1000" u="none" cap="none" strike="noStrike">
+                          <a:latin typeface="Times New Roman"/>
+                          <a:ea typeface="Times New Roman"/>
+                          <a:cs typeface="Times New Roman"/>
+                          <a:sym typeface="Times New Roman"/>
+                        </a:rPr>
+                        <a:t>Reinforcement learning (RL) based context generator to infer contextual signals from user prompts.</a:t>
+                      </a:r>
+                      <a:endParaRPr b="0" sz="1000" u="none" cap="none" strike="noStrike">
+                        <a:latin typeface="Times New Roman"/>
+                        <a:ea typeface="Times New Roman"/>
+                        <a:cs typeface="Times New Roman"/>
+                        <a:sym typeface="Times New Roman"/>
+                      </a:endParaRPr>
+                    </a:p>
+                  </a:txBody>
+                  <a:tcPr marT="45725" marB="45725" marR="91450" marL="91450">
+                    <a:lnL cap="flat" cmpd="sng" w="12700">
+                      <a:solidFill>
+                        <a:schemeClr val="lt1"/>
+                      </a:solidFill>
+                      <a:prstDash val="solid"/>
+                      <a:round/>
+                      <a:headEnd len="sm" w="sm" type="none"/>
+                      <a:tailEnd len="sm" w="sm" type="none"/>
+                    </a:lnL>
+                    <a:lnR cap="flat" cmpd="sng" w="12700">
+                      <a:solidFill>
+                        <a:schemeClr val="lt1"/>
+                      </a:solidFill>
+                      <a:prstDash val="solid"/>
+                      <a:round/>
+                      <a:headEnd len="sm" w="sm" type="none"/>
+                      <a:tailEnd len="sm" w="sm" type="none"/>
+                    </a:lnR>
+                    <a:lnT cap="flat" cmpd="sng" w="12700">
+                      <a:solidFill>
+                        <a:schemeClr val="lt1"/>
+                      </a:solidFill>
+                      <a:prstDash val="solid"/>
+                      <a:round/>
+                      <a:headEnd len="sm" w="sm" type="none"/>
+                      <a:tailEnd len="sm" w="sm" type="none"/>
+                    </a:lnT>
+                    <a:lnB cap="flat" cmpd="sng" w="12700">
+                      <a:solidFill>
+                        <a:schemeClr val="lt1"/>
+                      </a:solidFill>
+                      <a:prstDash val="solid"/>
+                      <a:round/>
+                      <a:headEnd len="sm" w="sm" type="none"/>
+                      <a:tailEnd len="sm" w="sm" type="none"/>
+                    </a:lnB>
+                  </a:tcPr>
+                </a:tc>
+                <a:tc>
+                  <a:txBody>
+                    <a:bodyPr/>
+                    <a:lstStyle/>
+                    <a:p>
+                      <a:pPr indent="0" lvl="0" marL="0" marR="0" rtl="0" algn="l">
+                        <a:spcBef>
+                          <a:spcPts val="0"/>
+                        </a:spcBef>
+                        <a:spcAft>
+                          <a:spcPts val="0"/>
+                        </a:spcAft>
+                        <a:buClr>
+                          <a:schemeClr val="dk1"/>
+                        </a:buClr>
+                        <a:buSzPts val="1000"/>
+                        <a:buFont typeface="Times New Roman"/>
+                        <a:buNone/>
+                      </a:pPr>
+                      <a:r>
+                        <a:rPr b="0" lang="en" sz="1000" u="none" cap="none" strike="noStrike">
+                          <a:latin typeface="Times New Roman"/>
+                          <a:ea typeface="Times New Roman"/>
+                          <a:cs typeface="Times New Roman"/>
+                          <a:sym typeface="Times New Roman"/>
+                        </a:rPr>
+                        <a:t>SafetyInstruct, Advbench, Wildjailbreak, XSTest.</a:t>
+                      </a:r>
+                      <a:endParaRPr b="0" sz="1000" u="none" cap="none" strike="noStrike">
+                        <a:latin typeface="Times New Roman"/>
+                        <a:ea typeface="Times New Roman"/>
+                        <a:cs typeface="Times New Roman"/>
+                        <a:sym typeface="Times New Roman"/>
+                      </a:endParaRPr>
+                    </a:p>
+                  </a:txBody>
+                  <a:tcPr marT="45725" marB="45725" marR="91450" marL="91450">
+                    <a:lnL cap="flat" cmpd="sng" w="12700">
+                      <a:solidFill>
+                        <a:schemeClr val="lt1"/>
+                      </a:solidFill>
+                      <a:prstDash val="solid"/>
+                      <a:round/>
+                      <a:headEnd len="sm" w="sm" type="none"/>
+                      <a:tailEnd len="sm" w="sm" type="none"/>
+                    </a:lnL>
+                    <a:lnR cap="flat" cmpd="sng" w="12700">
+                      <a:solidFill>
+                        <a:schemeClr val="lt1"/>
+                      </a:solidFill>
+                      <a:prstDash val="solid"/>
+                      <a:round/>
+                      <a:headEnd len="sm" w="sm" type="none"/>
+                      <a:tailEnd len="sm" w="sm" type="none"/>
+                    </a:lnR>
+                    <a:lnT cap="flat" cmpd="sng" w="12700">
+                      <a:solidFill>
+                        <a:schemeClr val="lt1"/>
+                      </a:solidFill>
+                      <a:prstDash val="solid"/>
+                      <a:round/>
+                      <a:headEnd len="sm" w="sm" type="none"/>
+                      <a:tailEnd len="sm" w="sm" type="none"/>
+                    </a:lnT>
+                    <a:lnB cap="flat" cmpd="sng" w="12700">
+                      <a:solidFill>
+                        <a:schemeClr val="lt1"/>
+                      </a:solidFill>
+                      <a:prstDash val="solid"/>
+                      <a:round/>
+                      <a:headEnd len="sm" w="sm" type="none"/>
+                      <a:tailEnd len="sm" w="sm" type="none"/>
+                    </a:lnB>
+                  </a:tcPr>
+                </a:tc>
+                <a:tc>
+                  <a:txBody>
+                    <a:bodyPr/>
+                    <a:lstStyle/>
+                    <a:p>
+                      <a:pPr indent="0" lvl="0" marL="0" marR="0" rtl="0" algn="l">
+                        <a:spcBef>
+                          <a:spcPts val="0"/>
+                        </a:spcBef>
+                        <a:spcAft>
+                          <a:spcPts val="0"/>
+                        </a:spcAft>
+                        <a:buClr>
+                          <a:schemeClr val="dk1"/>
+                        </a:buClr>
+                        <a:buSzPts val="1000"/>
+                        <a:buFont typeface="Times New Roman"/>
+                        <a:buNone/>
+                      </a:pPr>
+                      <a:r>
+                        <a:rPr b="0" lang="en" sz="1000" u="none" cap="none" strike="noStrike">
+                          <a:latin typeface="Times New Roman"/>
+                          <a:ea typeface="Times New Roman"/>
+                          <a:cs typeface="Times New Roman"/>
+                          <a:sym typeface="Times New Roman"/>
+                        </a:rPr>
+                        <a:t>Reduces harmful responses while preventing unnecessary refusals of benign requests.</a:t>
+                      </a:r>
+                      <a:endParaRPr b="0" sz="1000" u="none" cap="none" strike="noStrike">
+                        <a:latin typeface="Times New Roman"/>
+                        <a:ea typeface="Times New Roman"/>
+                        <a:cs typeface="Times New Roman"/>
+                        <a:sym typeface="Times New Roman"/>
+                      </a:endParaRPr>
+                    </a:p>
+                  </a:txBody>
+                  <a:tcPr marT="45725" marB="45725" marR="91450" marL="91450">
+                    <a:lnL cap="flat" cmpd="sng" w="12700">
+                      <a:solidFill>
+                        <a:schemeClr val="lt1"/>
+                      </a:solidFill>
+                      <a:prstDash val="solid"/>
+                      <a:round/>
+                      <a:headEnd len="sm" w="sm" type="none"/>
+                      <a:tailEnd len="sm" w="sm" type="none"/>
+                    </a:lnL>
+                    <a:lnR cap="flat" cmpd="sng" w="12700">
+                      <a:solidFill>
+                        <a:schemeClr val="lt1"/>
+                      </a:solidFill>
+                      <a:prstDash val="solid"/>
+                      <a:round/>
+                      <a:headEnd len="sm" w="sm" type="none"/>
+                      <a:tailEnd len="sm" w="sm" type="none"/>
+                    </a:lnR>
+                    <a:lnT cap="flat" cmpd="sng" w="12700">
+                      <a:solidFill>
+                        <a:schemeClr val="lt1"/>
+                      </a:solidFill>
+                      <a:prstDash val="solid"/>
+                      <a:round/>
+                      <a:headEnd len="sm" w="sm" type="none"/>
+                      <a:tailEnd len="sm" w="sm" type="none"/>
+                    </a:lnT>
+                    <a:lnB cap="flat" cmpd="sng" w="12700">
+                      <a:solidFill>
+                        <a:schemeClr val="lt1"/>
+                      </a:solidFill>
+                      <a:prstDash val="solid"/>
+                      <a:round/>
+                      <a:headEnd len="sm" w="sm" type="none"/>
+                      <a:tailEnd len="sm" w="sm" type="none"/>
+                    </a:lnB>
+                  </a:tcPr>
+                </a:tc>
+                <a:tc>
+                  <a:txBody>
+                    <a:bodyPr/>
+                    <a:lstStyle/>
+                    <a:p>
+                      <a:pPr indent="0" lvl="0" marL="0" marR="0" rtl="0" algn="l">
+                        <a:spcBef>
+                          <a:spcPts val="0"/>
+                        </a:spcBef>
+                        <a:spcAft>
+                          <a:spcPts val="0"/>
+                        </a:spcAft>
+                        <a:buClr>
+                          <a:schemeClr val="dk1"/>
+                        </a:buClr>
+                        <a:buSzPts val="1000"/>
+                        <a:buFont typeface="Times New Roman"/>
+                        <a:buNone/>
+                      </a:pPr>
+                      <a:r>
+                        <a:rPr b="0" lang="en" sz="1000" u="none" cap="none" strike="noStrike">
+                          <a:latin typeface="Times New Roman"/>
+                          <a:ea typeface="Times New Roman"/>
+                          <a:cs typeface="Times New Roman"/>
+                          <a:sym typeface="Times New Roman"/>
+                        </a:rPr>
+                        <a:t>Conventional LLM frameworks fail on ambiguous tasks; extracting context is necessary to prevent bypassing safeguards.</a:t>
+                      </a:r>
+                      <a:endParaRPr b="0" sz="1000" u="none" cap="none" strike="noStrike">
+                        <a:latin typeface="Times New Roman"/>
+                        <a:ea typeface="Times New Roman"/>
+                        <a:cs typeface="Times New Roman"/>
+                        <a:sym typeface="Times New Roman"/>
+                      </a:endParaRPr>
+                    </a:p>
+                  </a:txBody>
+                  <a:tcPr marT="45725" marB="45725" marR="91450" marL="91450">
+                    <a:lnL cap="flat" cmpd="sng" w="12700">
+                      <a:solidFill>
+                        <a:schemeClr val="lt1"/>
+                      </a:solidFill>
+                      <a:prstDash val="solid"/>
+                      <a:round/>
+                      <a:headEnd len="sm" w="sm" type="none"/>
+                      <a:tailEnd len="sm" w="sm" type="none"/>
+                    </a:lnL>
+                    <a:lnR cap="flat" cmpd="sng" w="12700">
+                      <a:solidFill>
+                        <a:schemeClr val="lt1"/>
+                      </a:solidFill>
+                      <a:prstDash val="solid"/>
+                      <a:round/>
+                      <a:headEnd len="sm" w="sm" type="none"/>
+                      <a:tailEnd len="sm" w="sm" type="none"/>
+                    </a:lnR>
+                    <a:lnT cap="flat" cmpd="sng" w="12700">
+                      <a:solidFill>
+                        <a:schemeClr val="lt1"/>
+                      </a:solidFill>
+                      <a:prstDash val="solid"/>
+                      <a:round/>
+                      <a:headEnd len="sm" w="sm" type="none"/>
+                      <a:tailEnd len="sm" w="sm" type="none"/>
+                    </a:lnT>
+                    <a:lnB cap="flat" cmpd="sng" w="12700">
+                      <a:solidFill>
+                        <a:schemeClr val="lt1"/>
+                      </a:solidFill>
+                      <a:prstDash val="solid"/>
+                      <a:round/>
+                      <a:headEnd len="sm" w="sm" type="none"/>
+                      <a:tailEnd len="sm" w="sm" type="none"/>
+                    </a:lnB>
+                  </a:tcPr>
+                </a:tc>
+              </a:tr>
+              <a:tr h="751200">
                 <a:tc>
                   <a:txBody>
                     <a:bodyPr/>
@@ -23512,7 +25014,44 @@
                       </a:endParaRPr>
                     </a:p>
                   </a:txBody>
-                  <a:tcPr marT="45725" marB="45725" marR="91450" marL="91450"/>
+                  <a:tcPr marT="45725" marB="45725" marR="91450" marL="91450">
+                    <a:lnL cap="flat" cmpd="sng" w="12700">
+                      <a:solidFill>
+                        <a:schemeClr val="lt1"/>
+                      </a:solidFill>
+                      <a:prstDash val="solid"/>
+                      <a:round/>
+                      <a:headEnd len="sm" w="sm" type="none"/>
+                      <a:tailEnd len="sm" w="sm" type="none"/>
+                    </a:lnL>
+                    <a:lnR cap="flat" cmpd="sng" w="12700">
+                      <a:solidFill>
+                        <a:schemeClr val="lt1"/>
+                      </a:solidFill>
+                      <a:prstDash val="solid"/>
+                      <a:round/>
+                      <a:headEnd len="sm" w="sm" type="none"/>
+                      <a:tailEnd len="sm" w="sm" type="none"/>
+                    </a:lnR>
+                    <a:lnT cap="flat" cmpd="sng" w="12700">
+                      <a:solidFill>
+                        <a:schemeClr val="lt1"/>
+                      </a:solidFill>
+                      <a:prstDash val="solid"/>
+                      <a:round/>
+                      <a:headEnd len="sm" w="sm" type="none"/>
+                      <a:tailEnd len="sm" w="sm" type="none"/>
+                    </a:lnT>
+                    <a:lnB cap="flat" cmpd="sng" w="38100">
+                      <a:solidFill>
+                        <a:schemeClr val="lt1"/>
+                      </a:solidFill>
+                      <a:prstDash val="solid"/>
+                      <a:round/>
+                      <a:headEnd len="sm" w="sm" type="none"/>
+                      <a:tailEnd len="sm" w="sm" type="none"/>
+                    </a:lnB>
+                  </a:tcPr>
                 </a:tc>
                 <a:tc>
                   <a:txBody>
@@ -23550,7 +25089,44 @@
                       </a:endParaRPr>
                     </a:p>
                   </a:txBody>
-                  <a:tcPr marT="45725" marB="45725" marR="91450" marL="91450"/>
+                  <a:tcPr marT="45725" marB="45725" marR="91450" marL="91450">
+                    <a:lnL cap="flat" cmpd="sng" w="12700">
+                      <a:solidFill>
+                        <a:schemeClr val="lt1"/>
+                      </a:solidFill>
+                      <a:prstDash val="solid"/>
+                      <a:round/>
+                      <a:headEnd len="sm" w="sm" type="none"/>
+                      <a:tailEnd len="sm" w="sm" type="none"/>
+                    </a:lnL>
+                    <a:lnR cap="flat" cmpd="sng" w="12700">
+                      <a:solidFill>
+                        <a:schemeClr val="lt1"/>
+                      </a:solidFill>
+                      <a:prstDash val="solid"/>
+                      <a:round/>
+                      <a:headEnd len="sm" w="sm" type="none"/>
+                      <a:tailEnd len="sm" w="sm" type="none"/>
+                    </a:lnR>
+                    <a:lnT cap="flat" cmpd="sng" w="12700">
+                      <a:solidFill>
+                        <a:schemeClr val="lt1"/>
+                      </a:solidFill>
+                      <a:prstDash val="solid"/>
+                      <a:round/>
+                      <a:headEnd len="sm" w="sm" type="none"/>
+                      <a:tailEnd len="sm" w="sm" type="none"/>
+                    </a:lnT>
+                    <a:lnB cap="flat" cmpd="sng" w="38100">
+                      <a:solidFill>
+                        <a:schemeClr val="lt1"/>
+                      </a:solidFill>
+                      <a:prstDash val="solid"/>
+                      <a:round/>
+                      <a:headEnd len="sm" w="sm" type="none"/>
+                      <a:tailEnd len="sm" w="sm" type="none"/>
+                    </a:lnB>
+                  </a:tcPr>
                 </a:tc>
                 <a:tc>
                   <a:txBody>
@@ -23588,7 +25164,44 @@
                       </a:endParaRPr>
                     </a:p>
                   </a:txBody>
-                  <a:tcPr marT="45725" marB="45725" marR="91450" marL="91450"/>
+                  <a:tcPr marT="45725" marB="45725" marR="91450" marL="91450">
+                    <a:lnL cap="flat" cmpd="sng" w="12700">
+                      <a:solidFill>
+                        <a:schemeClr val="lt1"/>
+                      </a:solidFill>
+                      <a:prstDash val="solid"/>
+                      <a:round/>
+                      <a:headEnd len="sm" w="sm" type="none"/>
+                      <a:tailEnd len="sm" w="sm" type="none"/>
+                    </a:lnL>
+                    <a:lnR cap="flat" cmpd="sng" w="12700">
+                      <a:solidFill>
+                        <a:schemeClr val="lt1"/>
+                      </a:solidFill>
+                      <a:prstDash val="solid"/>
+                      <a:round/>
+                      <a:headEnd len="sm" w="sm" type="none"/>
+                      <a:tailEnd len="sm" w="sm" type="none"/>
+                    </a:lnR>
+                    <a:lnT cap="flat" cmpd="sng" w="12700">
+                      <a:solidFill>
+                        <a:schemeClr val="lt1"/>
+                      </a:solidFill>
+                      <a:prstDash val="solid"/>
+                      <a:round/>
+                      <a:headEnd len="sm" w="sm" type="none"/>
+                      <a:tailEnd len="sm" w="sm" type="none"/>
+                    </a:lnT>
+                    <a:lnB cap="flat" cmpd="sng" w="38100">
+                      <a:solidFill>
+                        <a:schemeClr val="lt1"/>
+                      </a:solidFill>
+                      <a:prstDash val="solid"/>
+                      <a:round/>
+                      <a:headEnd len="sm" w="sm" type="none"/>
+                      <a:tailEnd len="sm" w="sm" type="none"/>
+                    </a:lnB>
+                  </a:tcPr>
                 </a:tc>
                 <a:tc>
                   <a:txBody>
@@ -23626,7 +25239,44 @@
                       </a:endParaRPr>
                     </a:p>
                   </a:txBody>
-                  <a:tcPr marT="45725" marB="45725" marR="91450" marL="91450"/>
+                  <a:tcPr marT="45725" marB="45725" marR="91450" marL="91450">
+                    <a:lnL cap="flat" cmpd="sng" w="12700">
+                      <a:solidFill>
+                        <a:schemeClr val="lt1"/>
+                      </a:solidFill>
+                      <a:prstDash val="solid"/>
+                      <a:round/>
+                      <a:headEnd len="sm" w="sm" type="none"/>
+                      <a:tailEnd len="sm" w="sm" type="none"/>
+                    </a:lnL>
+                    <a:lnR cap="flat" cmpd="sng" w="12700">
+                      <a:solidFill>
+                        <a:schemeClr val="lt1"/>
+                      </a:solidFill>
+                      <a:prstDash val="solid"/>
+                      <a:round/>
+                      <a:headEnd len="sm" w="sm" type="none"/>
+                      <a:tailEnd len="sm" w="sm" type="none"/>
+                    </a:lnR>
+                    <a:lnT cap="flat" cmpd="sng" w="12700">
+                      <a:solidFill>
+                        <a:schemeClr val="lt1"/>
+                      </a:solidFill>
+                      <a:prstDash val="solid"/>
+                      <a:round/>
+                      <a:headEnd len="sm" w="sm" type="none"/>
+                      <a:tailEnd len="sm" w="sm" type="none"/>
+                    </a:lnT>
+                    <a:lnB cap="flat" cmpd="sng" w="38100">
+                      <a:solidFill>
+                        <a:schemeClr val="lt1"/>
+                      </a:solidFill>
+                      <a:prstDash val="solid"/>
+                      <a:round/>
+                      <a:headEnd len="sm" w="sm" type="none"/>
+                      <a:tailEnd len="sm" w="sm" type="none"/>
+                    </a:lnB>
+                  </a:tcPr>
                 </a:tc>
                 <a:tc>
                   <a:txBody>
@@ -23664,391 +25314,44 @@
                       </a:endParaRPr>
                     </a:p>
                   </a:txBody>
-                  <a:tcPr marT="45725" marB="45725" marR="91450" marL="91450"/>
-                </a:tc>
-              </a:tr>
-              <a:tr h="751200">
-                <a:tc>
-                  <a:txBody>
-                    <a:bodyPr/>
-                    <a:lstStyle/>
-                    <a:p>
-                      <a:pPr indent="0" lvl="0" marL="0" marR="0" rtl="0" algn="l">
-                        <a:spcBef>
-                          <a:spcPts val="0"/>
-                        </a:spcBef>
-                        <a:spcAft>
-                          <a:spcPts val="0"/>
-                        </a:spcAft>
-                        <a:buClr>
-                          <a:schemeClr val="dk1"/>
-                        </a:buClr>
-                        <a:buSzPts val="1000"/>
-                        <a:buFont typeface="Times New Roman"/>
-                        <a:buNone/>
-                      </a:pPr>
-                      <a:r>
-                        <a:rPr b="0" lang="en" sz="1000" u="none" cap="none" strike="noStrike">
-                          <a:latin typeface="Times New Roman"/>
-                          <a:ea typeface="Times New Roman"/>
-                          <a:cs typeface="Times New Roman"/>
-                          <a:sym typeface="Times New Roman"/>
-                        </a:rPr>
-                        <a:t>Dozono et al. (2025)</a:t>
-                      </a:r>
-                      <a:endParaRPr b="0" sz="1000" u="none" cap="none" strike="noStrike">
-                        <a:latin typeface="Times New Roman"/>
-                        <a:ea typeface="Times New Roman"/>
-                        <a:cs typeface="Times New Roman"/>
-                        <a:sym typeface="Times New Roman"/>
-                      </a:endParaRPr>
-                    </a:p>
-                  </a:txBody>
-                  <a:tcPr marT="45725" marB="45725" marR="91450" marL="91450"/>
-                </a:tc>
-                <a:tc>
-                  <a:txBody>
-                    <a:bodyPr/>
-                    <a:lstStyle/>
-                    <a:p>
-                      <a:pPr indent="0" lvl="0" marL="0" marR="0" rtl="0" algn="l">
-                        <a:spcBef>
-                          <a:spcPts val="0"/>
-                        </a:spcBef>
-                        <a:spcAft>
-                          <a:spcPts val="0"/>
-                        </a:spcAft>
-                        <a:buClr>
-                          <a:schemeClr val="dk1"/>
-                        </a:buClr>
-                        <a:buSzPts val="1000"/>
-                        <a:buFont typeface="Times New Roman"/>
-                        <a:buNone/>
-                      </a:pPr>
-                      <a:r>
-                        <a:rPr b="0" lang="en" sz="1000" u="none" cap="none" strike="noStrike">
-                          <a:latin typeface="Times New Roman"/>
-                          <a:ea typeface="Times New Roman"/>
-                          <a:cs typeface="Times New Roman"/>
-                          <a:sym typeface="Times New Roman"/>
-                        </a:rPr>
-                        <a:t>Empirical evaluation of 5 frontier LLMs comparing open-source vs. closed-source code performance.</a:t>
-                      </a:r>
-                      <a:endParaRPr b="0" sz="1000" u="none" cap="none" strike="noStrike">
-                        <a:latin typeface="Times New Roman"/>
-                        <a:ea typeface="Times New Roman"/>
-                        <a:cs typeface="Times New Roman"/>
-                        <a:sym typeface="Times New Roman"/>
-                      </a:endParaRPr>
-                    </a:p>
-                  </a:txBody>
-                  <a:tcPr marT="45725" marB="45725" marR="91450" marL="91450"/>
-                </a:tc>
-                <a:tc>
-                  <a:txBody>
-                    <a:bodyPr/>
-                    <a:lstStyle/>
-                    <a:p>
-                      <a:pPr indent="0" lvl="0" marL="0" marR="0" rtl="0" algn="l">
-                        <a:spcBef>
-                          <a:spcPts val="0"/>
-                        </a:spcBef>
-                        <a:spcAft>
-                          <a:spcPts val="0"/>
-                        </a:spcAft>
-                        <a:buClr>
-                          <a:schemeClr val="dk1"/>
-                        </a:buClr>
-                        <a:buSzPts val="1000"/>
-                        <a:buFont typeface="Times New Roman"/>
-                        <a:buNone/>
-                      </a:pPr>
-                      <a:r>
-                        <a:rPr b="0" lang="en" sz="1000" u="none" cap="none" strike="noStrike">
-                          <a:latin typeface="Times New Roman"/>
-                          <a:ea typeface="Times New Roman"/>
-                          <a:cs typeface="Times New Roman"/>
-                          <a:sym typeface="Times New Roman"/>
-                        </a:rPr>
-                        <a:t>CWE-Bench-Java (Open) and TS-Vuls (Closed, commercial Teamscale codebase).</a:t>
-                      </a:r>
-                      <a:endParaRPr b="0" sz="1000" u="none" cap="none" strike="noStrike">
-                        <a:latin typeface="Times New Roman"/>
-                        <a:ea typeface="Times New Roman"/>
-                        <a:cs typeface="Times New Roman"/>
-                        <a:sym typeface="Times New Roman"/>
-                      </a:endParaRPr>
-                    </a:p>
-                  </a:txBody>
-                  <a:tcPr marT="45725" marB="45725" marR="91450" marL="91450"/>
-                </a:tc>
-                <a:tc>
-                  <a:txBody>
-                    <a:bodyPr/>
-                    <a:lstStyle/>
-                    <a:p>
-                      <a:pPr indent="0" lvl="0" marL="0" marR="0" rtl="0" algn="l">
-                        <a:spcBef>
-                          <a:spcPts val="0"/>
-                        </a:spcBef>
-                        <a:spcAft>
-                          <a:spcPts val="0"/>
-                        </a:spcAft>
-                        <a:buClr>
-                          <a:schemeClr val="dk1"/>
-                        </a:buClr>
-                        <a:buSzPts val="1000"/>
-                        <a:buFont typeface="Times New Roman"/>
-                        <a:buNone/>
-                      </a:pPr>
-                      <a:r>
-                        <a:rPr b="0" lang="en" sz="1000" u="none" cap="none" strike="noStrike">
-                          <a:latin typeface="Times New Roman"/>
-                          <a:ea typeface="Times New Roman"/>
-                          <a:cs typeface="Times New Roman"/>
-                          <a:sym typeface="Times New Roman"/>
-                        </a:rPr>
-                        <a:t>Precision dropped significantly from 56% on open-source code to 34% on closed-source code.</a:t>
-                      </a:r>
-                      <a:endParaRPr b="0" sz="1000" u="none" cap="none" strike="noStrike">
-                        <a:latin typeface="Times New Roman"/>
-                        <a:ea typeface="Times New Roman"/>
-                        <a:cs typeface="Times New Roman"/>
-                        <a:sym typeface="Times New Roman"/>
-                      </a:endParaRPr>
-                    </a:p>
-                  </a:txBody>
-                  <a:tcPr marT="45725" marB="45725" marR="91450" marL="91450"/>
-                </a:tc>
-                <a:tc>
-                  <a:txBody>
-                    <a:bodyPr/>
-                    <a:lstStyle/>
-                    <a:p>
-                      <a:pPr indent="0" lvl="0" marL="0" marR="0" rtl="0" algn="l">
-                        <a:spcBef>
-                          <a:spcPts val="0"/>
-                        </a:spcBef>
-                        <a:spcAft>
-                          <a:spcPts val="0"/>
-                        </a:spcAft>
-                        <a:buClr>
-                          <a:schemeClr val="dk1"/>
-                        </a:buClr>
-                        <a:buSzPts val="1000"/>
-                        <a:buFont typeface="Times New Roman"/>
-                        <a:buNone/>
-                      </a:pPr>
-                      <a:r>
-                        <a:rPr b="0" lang="en" sz="1000" u="none" cap="none" strike="noStrike">
-                          <a:latin typeface="Times New Roman"/>
-                          <a:ea typeface="Times New Roman"/>
-                          <a:cs typeface="Times New Roman"/>
-                          <a:sym typeface="Times New Roman"/>
-                        </a:rPr>
-                        <a:t>LLM metrics are heavily inflated on open-source data due to training contamination.</a:t>
-                      </a:r>
-                      <a:endParaRPr b="0" sz="1000" u="none" cap="none" strike="noStrike">
-                        <a:latin typeface="Times New Roman"/>
-                        <a:ea typeface="Times New Roman"/>
-                        <a:cs typeface="Times New Roman"/>
-                        <a:sym typeface="Times New Roman"/>
-                      </a:endParaRPr>
-                    </a:p>
-                  </a:txBody>
-                  <a:tcPr marT="45725" marB="45725" marR="91450" marL="91450"/>
-                </a:tc>
-              </a:tr>
-              <a:tr h="750575">
-                <a:tc>
-                  <a:txBody>
-                    <a:bodyPr/>
-                    <a:lstStyle/>
-                    <a:p>
-                      <a:pPr indent="0" lvl="0" marL="0" marR="0" rtl="0" algn="l">
-                        <a:spcBef>
-                          <a:spcPts val="0"/>
-                        </a:spcBef>
-                        <a:spcAft>
-                          <a:spcPts val="0"/>
-                        </a:spcAft>
-                        <a:buClr>
-                          <a:schemeClr val="dk1"/>
-                        </a:buClr>
-                        <a:buSzPts val="1000"/>
-                        <a:buFont typeface="Times New Roman"/>
-                        <a:buNone/>
-                      </a:pPr>
-                      <a:r>
-                        <a:rPr b="0" lang="en" sz="1000" u="none" cap="none" strike="noStrike">
-                          <a:latin typeface="Times New Roman"/>
-                          <a:ea typeface="Times New Roman"/>
-                          <a:cs typeface="Times New Roman"/>
-                          <a:sym typeface="Times New Roman"/>
-                        </a:rPr>
-                        <a:t>Guo et al. (2023)</a:t>
-                      </a:r>
-                      <a:endParaRPr b="0" sz="1000" u="none" cap="none" strike="noStrike">
-                        <a:latin typeface="Times New Roman"/>
-                        <a:ea typeface="Times New Roman"/>
-                        <a:cs typeface="Times New Roman"/>
-                        <a:sym typeface="Times New Roman"/>
-                      </a:endParaRPr>
-                    </a:p>
-                  </a:txBody>
-                  <a:tcPr marT="45725" marB="45725" marR="91450" marL="91450"/>
-                </a:tc>
-                <a:tc>
-                  <a:txBody>
-                    <a:bodyPr/>
-                    <a:lstStyle/>
-                    <a:p>
-                      <a:pPr indent="0" lvl="0" marL="0" marR="0" rtl="0" algn="l">
-                        <a:spcBef>
-                          <a:spcPts val="0"/>
-                        </a:spcBef>
-                        <a:spcAft>
-                          <a:spcPts val="0"/>
-                        </a:spcAft>
-                        <a:buClr>
-                          <a:schemeClr val="dk1"/>
-                        </a:buClr>
-                        <a:buSzPts val="1000"/>
-                        <a:buFont typeface="Times New Roman"/>
-                        <a:buNone/>
-                      </a:pPr>
-                      <a:r>
-                        <a:rPr b="0" lang="en" sz="1000" u="none" cap="none" strike="noStrike">
-                          <a:latin typeface="Times New Roman"/>
-                          <a:ea typeface="Times New Roman"/>
-                          <a:cs typeface="Times New Roman"/>
-                          <a:sym typeface="Times New Roman"/>
-                        </a:rPr>
-                        <a:t>Systematic review of 130 false positive mitigation studies across 5 technical categories.</a:t>
-                      </a:r>
-                      <a:endParaRPr b="0" sz="1000" u="none" cap="none" strike="noStrike">
-                        <a:latin typeface="Times New Roman"/>
-                        <a:ea typeface="Times New Roman"/>
-                        <a:cs typeface="Times New Roman"/>
-                        <a:sym typeface="Times New Roman"/>
-                      </a:endParaRPr>
-                    </a:p>
-                  </a:txBody>
-                  <a:tcPr marT="45725" marB="45725" marR="91450" marL="91450"/>
-                </a:tc>
-                <a:tc>
-                  <a:txBody>
-                    <a:bodyPr/>
-                    <a:lstStyle/>
-                    <a:p>
-                      <a:pPr indent="0" lvl="0" marL="0" marR="0" rtl="0" algn="l">
-                        <a:spcBef>
-                          <a:spcPts val="0"/>
-                        </a:spcBef>
-                        <a:spcAft>
-                          <a:spcPts val="0"/>
-                        </a:spcAft>
-                        <a:buClr>
-                          <a:schemeClr val="dk1"/>
-                        </a:buClr>
-                        <a:buSzPts val="1000"/>
-                        <a:buFont typeface="Times New Roman"/>
-                        <a:buNone/>
-                      </a:pPr>
-                      <a:r>
-                        <a:rPr b="0" lang="en" sz="1000" u="none" cap="none" strike="noStrike">
-                          <a:latin typeface="Times New Roman"/>
-                          <a:ea typeface="Times New Roman"/>
-                          <a:cs typeface="Times New Roman"/>
-                          <a:sym typeface="Times New Roman"/>
-                        </a:rPr>
-                        <a:t>N/A (Literature Review).</a:t>
-                      </a:r>
-                      <a:endParaRPr b="0" sz="1000" u="none" cap="none" strike="noStrike">
-                        <a:latin typeface="Times New Roman"/>
-                        <a:ea typeface="Times New Roman"/>
-                        <a:cs typeface="Times New Roman"/>
-                        <a:sym typeface="Times New Roman"/>
-                      </a:endParaRPr>
-                    </a:p>
-                  </a:txBody>
-                  <a:tcPr marT="45725" marB="45725" marR="91450" marL="91450"/>
-                </a:tc>
-                <a:tc>
-                  <a:txBody>
-                    <a:bodyPr/>
-                    <a:lstStyle/>
-                    <a:p>
-                      <a:pPr indent="0" lvl="0" marL="0" marR="0" rtl="0" algn="l">
-                        <a:spcBef>
-                          <a:spcPts val="0"/>
-                        </a:spcBef>
-                        <a:spcAft>
-                          <a:spcPts val="0"/>
-                        </a:spcAft>
-                        <a:buClr>
-                          <a:schemeClr val="dk1"/>
-                        </a:buClr>
-                        <a:buSzPts val="1000"/>
-                        <a:buFont typeface="Times New Roman"/>
-                        <a:buNone/>
-                      </a:pPr>
-                      <a:r>
-                        <a:rPr b="0" lang="en" sz="1000" u="none" cap="none" strike="noStrike">
-                          <a:latin typeface="Times New Roman"/>
-                          <a:ea typeface="Times New Roman"/>
-                          <a:cs typeface="Times New Roman"/>
-                          <a:sym typeface="Times New Roman"/>
-                        </a:rPr>
-                        <a:t>Established a taxonomy for false positive mitigation and identified deep learning and NLP as future directions.</a:t>
-                      </a:r>
-                      <a:endParaRPr b="0" sz="1000" u="none" cap="none" strike="noStrike">
-                        <a:latin typeface="Times New Roman"/>
-                        <a:ea typeface="Times New Roman"/>
-                        <a:cs typeface="Times New Roman"/>
-                        <a:sym typeface="Times New Roman"/>
-                      </a:endParaRPr>
-                    </a:p>
-                  </a:txBody>
-                  <a:tcPr marT="45725" marB="45725" marR="91450" marL="91450"/>
-                </a:tc>
-                <a:tc>
-                  <a:txBody>
-                    <a:bodyPr/>
-                    <a:lstStyle/>
-                    <a:p>
-                      <a:pPr indent="0" lvl="0" marL="0" marR="0" rtl="0" algn="l">
-                        <a:spcBef>
-                          <a:spcPts val="0"/>
-                        </a:spcBef>
-                        <a:spcAft>
-                          <a:spcPts val="0"/>
-                        </a:spcAft>
-                        <a:buClr>
-                          <a:schemeClr val="dk1"/>
-                        </a:buClr>
-                        <a:buSzPts val="1000"/>
-                        <a:buFont typeface="Times New Roman"/>
-                        <a:buNone/>
-                      </a:pPr>
-                      <a:r>
-                        <a:rPr b="0" lang="en" sz="1000" u="none" cap="none" strike="noStrike">
-                          <a:latin typeface="Times New Roman"/>
-                          <a:ea typeface="Times New Roman"/>
-                          <a:cs typeface="Times New Roman"/>
-                          <a:sym typeface="Times New Roman"/>
-                        </a:rPr>
-                        <a:t>Current approaches suffer from low explainability, ambiguous concept definitions, and dataset biases.</a:t>
-                      </a:r>
-                      <a:endParaRPr b="0" sz="1000" u="none" cap="none" strike="noStrike">
-                        <a:latin typeface="Times New Roman"/>
-                        <a:ea typeface="Times New Roman"/>
-                        <a:cs typeface="Times New Roman"/>
-                        <a:sym typeface="Times New Roman"/>
-                      </a:endParaRPr>
-                    </a:p>
-                  </a:txBody>
-                  <a:tcPr marT="45725" marB="45725" marR="91450" marL="91450"/>
+                  <a:tcPr marT="45725" marB="45725" marR="91450" marL="91450">
+                    <a:lnL cap="flat" cmpd="sng" w="12700">
+                      <a:solidFill>
+                        <a:schemeClr val="lt1"/>
+                      </a:solidFill>
+                      <a:prstDash val="solid"/>
+                      <a:round/>
+                      <a:headEnd len="sm" w="sm" type="none"/>
+                      <a:tailEnd len="sm" w="sm" type="none"/>
+                    </a:lnL>
+                    <a:lnR cap="flat" cmpd="sng" w="12700">
+                      <a:solidFill>
+                        <a:schemeClr val="lt1"/>
+                      </a:solidFill>
+                      <a:prstDash val="solid"/>
+                      <a:round/>
+                      <a:headEnd len="sm" w="sm" type="none"/>
+                      <a:tailEnd len="sm" w="sm" type="none"/>
+                    </a:lnR>
+                    <a:lnT cap="flat" cmpd="sng" w="12700">
+                      <a:solidFill>
+                        <a:schemeClr val="lt1"/>
+                      </a:solidFill>
+                      <a:prstDash val="solid"/>
+                      <a:round/>
+                      <a:headEnd len="sm" w="sm" type="none"/>
+                      <a:tailEnd len="sm" w="sm" type="none"/>
+                    </a:lnT>
+                    <a:lnB cap="flat" cmpd="sng" w="38100">
+                      <a:solidFill>
+                        <a:schemeClr val="lt1"/>
+                      </a:solidFill>
+                      <a:prstDash val="solid"/>
+                      <a:round/>
+                      <a:headEnd len="sm" w="sm" type="none"/>
+                      <a:tailEnd len="sm" w="sm" type="none"/>
+                    </a:lnB>
+                  </a:tcPr>
                 </a:tc>
               </a:tr>
             </a:tbl>
@@ -24302,7 +25605,7 @@
             <a:tbl>
               <a:tblPr bandRow="1" firstRow="1">
                 <a:noFill/>
-                <a:tableStyleId>{91615823-763D-4289-AFF7-78FB870AD9B0}</a:tableStyleId>
+                <a:tableStyleId>{4988CF06-5FA7-4D49-9562-FA9D673A86ED}</a:tableStyleId>
               </a:tblPr>
               <a:tblGrid>
                 <a:gridCol w="872025"/>
@@ -24348,7 +25651,17 @@
                       </a:endParaRPr>
                     </a:p>
                   </a:txBody>
-                  <a:tcPr marT="45725" marB="45725" marR="91450" marL="91450"/>
+                  <a:tcPr marT="45725" marB="45725" marR="91450" marL="91450">
+                    <a:lnB cap="flat" cmpd="sng" w="12700">
+                      <a:solidFill>
+                        <a:schemeClr val="lt1"/>
+                      </a:solidFill>
+                      <a:prstDash val="solid"/>
+                      <a:round/>
+                      <a:headEnd len="sm" w="sm" type="none"/>
+                      <a:tailEnd len="sm" w="sm" type="none"/>
+                    </a:lnB>
+                  </a:tcPr>
                 </a:tc>
                 <a:tc>
                   <a:txBody>
@@ -24417,7 +25730,17 @@
                       </a:endParaRPr>
                     </a:p>
                   </a:txBody>
-                  <a:tcPr marT="45725" marB="45725" marR="91450" marL="91450"/>
+                  <a:tcPr marT="45725" marB="45725" marR="91450" marL="91450">
+                    <a:lnB cap="flat" cmpd="sng" w="12700">
+                      <a:solidFill>
+                        <a:schemeClr val="lt1"/>
+                      </a:solidFill>
+                      <a:prstDash val="solid"/>
+                      <a:round/>
+                      <a:headEnd len="sm" w="sm" type="none"/>
+                      <a:tailEnd len="sm" w="sm" type="none"/>
+                    </a:lnB>
+                  </a:tcPr>
                 </a:tc>
                 <a:tc>
                   <a:txBody>
@@ -24455,7 +25778,17 @@
                       </a:endParaRPr>
                     </a:p>
                   </a:txBody>
-                  <a:tcPr marT="45725" marB="45725" marR="91450" marL="91450"/>
+                  <a:tcPr marT="45725" marB="45725" marR="91450" marL="91450">
+                    <a:lnB cap="flat" cmpd="sng" w="12700">
+                      <a:solidFill>
+                        <a:schemeClr val="lt1"/>
+                      </a:solidFill>
+                      <a:prstDash val="solid"/>
+                      <a:round/>
+                      <a:headEnd len="sm" w="sm" type="none"/>
+                      <a:tailEnd len="sm" w="sm" type="none"/>
+                    </a:lnB>
+                  </a:tcPr>
                 </a:tc>
                 <a:tc>
                   <a:txBody>
@@ -24493,7 +25826,17 @@
                       </a:endParaRPr>
                     </a:p>
                   </a:txBody>
-                  <a:tcPr marT="45725" marB="45725" marR="91450" marL="91450"/>
+                  <a:tcPr marT="45725" marB="45725" marR="91450" marL="91450">
+                    <a:lnB cap="flat" cmpd="sng" w="12700">
+                      <a:solidFill>
+                        <a:schemeClr val="lt1"/>
+                      </a:solidFill>
+                      <a:prstDash val="solid"/>
+                      <a:round/>
+                      <a:headEnd len="sm" w="sm" type="none"/>
+                      <a:tailEnd len="sm" w="sm" type="none"/>
+                    </a:lnB>
+                  </a:tcPr>
                 </a:tc>
                 <a:tc>
                   <a:txBody>
@@ -24531,7 +25874,17 @@
                       </a:endParaRPr>
                     </a:p>
                   </a:txBody>
-                  <a:tcPr marT="45725" marB="45725" marR="91450" marL="91450"/>
+                  <a:tcPr marT="45725" marB="45725" marR="91450" marL="91450">
+                    <a:lnB cap="flat" cmpd="sng" w="12700">
+                      <a:solidFill>
+                        <a:schemeClr val="lt1"/>
+                      </a:solidFill>
+                      <a:prstDash val="solid"/>
+                      <a:round/>
+                      <a:headEnd len="sm" w="sm" type="none"/>
+                      <a:tailEnd len="sm" w="sm" type="none"/>
+                    </a:lnB>
+                  </a:tcPr>
                 </a:tc>
               </a:tr>
               <a:tr h="751200">
@@ -24561,7 +25914,7 @@
                           <a:cs typeface="Times New Roman"/>
                           <a:sym typeface="Times New Roman"/>
                         </a:rPr>
-                        <a:t>Li et al. (2025)</a:t>
+                        <a:t>Dozono et al. (2025)</a:t>
                       </a:r>
                       <a:endParaRPr b="0" sz="1000" u="none" cap="none" strike="noStrike">
                         <a:latin typeface="Times New Roman"/>
@@ -24571,7 +25924,44 @@
                       </a:endParaRPr>
                     </a:p>
                   </a:txBody>
-                  <a:tcPr marT="45725" marB="45725" marR="91450" marL="91450"/>
+                  <a:tcPr marT="45725" marB="45725" marR="91450" marL="91450">
+                    <a:lnL cap="flat" cmpd="sng" w="12700">
+                      <a:solidFill>
+                        <a:schemeClr val="lt1"/>
+                      </a:solidFill>
+                      <a:prstDash val="solid"/>
+                      <a:round/>
+                      <a:headEnd len="sm" w="sm" type="none"/>
+                      <a:tailEnd len="sm" w="sm" type="none"/>
+                    </a:lnL>
+                    <a:lnR cap="flat" cmpd="sng" w="12700">
+                      <a:solidFill>
+                        <a:schemeClr val="lt1"/>
+                      </a:solidFill>
+                      <a:prstDash val="solid"/>
+                      <a:round/>
+                      <a:headEnd len="sm" w="sm" type="none"/>
+                      <a:tailEnd len="sm" w="sm" type="none"/>
+                    </a:lnR>
+                    <a:lnT cap="flat" cmpd="sng" w="12700">
+                      <a:solidFill>
+                        <a:schemeClr val="lt1"/>
+                      </a:solidFill>
+                      <a:prstDash val="solid"/>
+                      <a:round/>
+                      <a:headEnd len="sm" w="sm" type="none"/>
+                      <a:tailEnd len="sm" w="sm" type="none"/>
+                    </a:lnT>
+                    <a:lnB cap="flat" cmpd="sng" w="38100">
+                      <a:solidFill>
+                        <a:schemeClr val="lt1"/>
+                      </a:solidFill>
+                      <a:prstDash val="solid"/>
+                      <a:round/>
+                      <a:headEnd len="sm" w="sm" type="none"/>
+                      <a:tailEnd len="sm" w="sm" type="none"/>
+                    </a:lnB>
+                  </a:tcPr>
                 </a:tc>
                 <a:tc>
                   <a:txBody>
@@ -24599,7 +25989,7 @@
                           <a:cs typeface="Times New Roman"/>
                           <a:sym typeface="Times New Roman"/>
                         </a:rPr>
-                        <a:t>Injecting vulnerability steering vectors into LLM activation layers without altering original parameters.</a:t>
+                        <a:t>Empirical evaluation of 5 frontier LLMs comparing open-source vs. closed-source code performance.</a:t>
                       </a:r>
                       <a:endParaRPr b="0" sz="1000" u="none" cap="none" strike="noStrike">
                         <a:latin typeface="Times New Roman"/>
@@ -24609,7 +25999,44 @@
                       </a:endParaRPr>
                     </a:p>
                   </a:txBody>
-                  <a:tcPr marT="45725" marB="45725" marR="91450" marL="91450"/>
+                  <a:tcPr marT="45725" marB="45725" marR="91450" marL="91450">
+                    <a:lnL cap="flat" cmpd="sng" w="12700">
+                      <a:solidFill>
+                        <a:schemeClr val="lt1"/>
+                      </a:solidFill>
+                      <a:prstDash val="solid"/>
+                      <a:round/>
+                      <a:headEnd len="sm" w="sm" type="none"/>
+                      <a:tailEnd len="sm" w="sm" type="none"/>
+                    </a:lnL>
+                    <a:lnR cap="flat" cmpd="sng" w="12700">
+                      <a:solidFill>
+                        <a:schemeClr val="lt1"/>
+                      </a:solidFill>
+                      <a:prstDash val="solid"/>
+                      <a:round/>
+                      <a:headEnd len="sm" w="sm" type="none"/>
+                      <a:tailEnd len="sm" w="sm" type="none"/>
+                    </a:lnR>
+                    <a:lnT cap="flat" cmpd="sng" w="12700">
+                      <a:solidFill>
+                        <a:schemeClr val="lt1"/>
+                      </a:solidFill>
+                      <a:prstDash val="solid"/>
+                      <a:round/>
+                      <a:headEnd len="sm" w="sm" type="none"/>
+                      <a:tailEnd len="sm" w="sm" type="none"/>
+                    </a:lnT>
+                    <a:lnB cap="flat" cmpd="sng" w="38100">
+                      <a:solidFill>
+                        <a:schemeClr val="lt1"/>
+                      </a:solidFill>
+                      <a:prstDash val="solid"/>
+                      <a:round/>
+                      <a:headEnd len="sm" w="sm" type="none"/>
+                      <a:tailEnd len="sm" w="sm" type="none"/>
+                    </a:lnB>
+                  </a:tcPr>
                 </a:tc>
                 <a:tc>
                   <a:txBody>
@@ -24637,7 +26064,7 @@
                           <a:cs typeface="Times New Roman"/>
                           <a:sym typeface="Times New Roman"/>
                         </a:rPr>
-                        <a:t>SARD, FFmpeg+Qemu, Reveal, REEF.</a:t>
+                        <a:t>CWE-Bench-Java (Open) and TS-Vuls (Closed, commercial Teamscale codebase).</a:t>
                       </a:r>
                       <a:endParaRPr b="0" sz="1000" u="none" cap="none" strike="noStrike">
                         <a:latin typeface="Times New Roman"/>
@@ -24647,7 +26074,44 @@
                       </a:endParaRPr>
                     </a:p>
                   </a:txBody>
-                  <a:tcPr marT="45725" marB="45725" marR="91450" marL="91450"/>
+                  <a:tcPr marT="45725" marB="45725" marR="91450" marL="91450">
+                    <a:lnL cap="flat" cmpd="sng" w="12700">
+                      <a:solidFill>
+                        <a:schemeClr val="lt1"/>
+                      </a:solidFill>
+                      <a:prstDash val="solid"/>
+                      <a:round/>
+                      <a:headEnd len="sm" w="sm" type="none"/>
+                      <a:tailEnd len="sm" w="sm" type="none"/>
+                    </a:lnL>
+                    <a:lnR cap="flat" cmpd="sng" w="12700">
+                      <a:solidFill>
+                        <a:schemeClr val="lt1"/>
+                      </a:solidFill>
+                      <a:prstDash val="solid"/>
+                      <a:round/>
+                      <a:headEnd len="sm" w="sm" type="none"/>
+                      <a:tailEnd len="sm" w="sm" type="none"/>
+                    </a:lnR>
+                    <a:lnT cap="flat" cmpd="sng" w="12700">
+                      <a:solidFill>
+                        <a:schemeClr val="lt1"/>
+                      </a:solidFill>
+                      <a:prstDash val="solid"/>
+                      <a:round/>
+                      <a:headEnd len="sm" w="sm" type="none"/>
+                      <a:tailEnd len="sm" w="sm" type="none"/>
+                    </a:lnT>
+                    <a:lnB cap="flat" cmpd="sng" w="38100">
+                      <a:solidFill>
+                        <a:schemeClr val="lt1"/>
+                      </a:solidFill>
+                      <a:prstDash val="solid"/>
+                      <a:round/>
+                      <a:headEnd len="sm" w="sm" type="none"/>
+                      <a:tailEnd len="sm" w="sm" type="none"/>
+                    </a:lnB>
+                  </a:tcPr>
                 </a:tc>
                 <a:tc>
                   <a:txBody>
@@ -24675,7 +26139,7 @@
                           <a:cs typeface="Times New Roman"/>
                           <a:sym typeface="Times New Roman"/>
                         </a:rPr>
-                        <a:t>Outperformed state-of-the-art methods with a 12.86% F1-score increase on real-world datasets.</a:t>
+                        <a:t>Precision dropped significantly from 56% on open-source code to 34% on closed-source code.</a:t>
                       </a:r>
                       <a:endParaRPr b="0" sz="1000" u="none" cap="none" strike="noStrike">
                         <a:latin typeface="Times New Roman"/>
@@ -24685,7 +26149,44 @@
                       </a:endParaRPr>
                     </a:p>
                   </a:txBody>
-                  <a:tcPr marT="45725" marB="45725" marR="91450" marL="91450"/>
+                  <a:tcPr marT="45725" marB="45725" marR="91450" marL="91450">
+                    <a:lnL cap="flat" cmpd="sng" w="12700">
+                      <a:solidFill>
+                        <a:schemeClr val="lt1"/>
+                      </a:solidFill>
+                      <a:prstDash val="solid"/>
+                      <a:round/>
+                      <a:headEnd len="sm" w="sm" type="none"/>
+                      <a:tailEnd len="sm" w="sm" type="none"/>
+                    </a:lnL>
+                    <a:lnR cap="flat" cmpd="sng" w="12700">
+                      <a:solidFill>
+                        <a:schemeClr val="lt1"/>
+                      </a:solidFill>
+                      <a:prstDash val="solid"/>
+                      <a:round/>
+                      <a:headEnd len="sm" w="sm" type="none"/>
+                      <a:tailEnd len="sm" w="sm" type="none"/>
+                    </a:lnR>
+                    <a:lnT cap="flat" cmpd="sng" w="12700">
+                      <a:solidFill>
+                        <a:schemeClr val="lt1"/>
+                      </a:solidFill>
+                      <a:prstDash val="solid"/>
+                      <a:round/>
+                      <a:headEnd len="sm" w="sm" type="none"/>
+                      <a:tailEnd len="sm" w="sm" type="none"/>
+                    </a:lnT>
+                    <a:lnB cap="flat" cmpd="sng" w="38100">
+                      <a:solidFill>
+                        <a:schemeClr val="lt1"/>
+                      </a:solidFill>
+                      <a:prstDash val="solid"/>
+                      <a:round/>
+                      <a:headEnd len="sm" w="sm" type="none"/>
+                      <a:tailEnd len="sm" w="sm" type="none"/>
+                    </a:lnB>
+                  </a:tcPr>
                 </a:tc>
                 <a:tc>
                   <a:txBody>
@@ -24713,7 +26214,7 @@
                           <a:cs typeface="Times New Roman"/>
                           <a:sym typeface="Times New Roman"/>
                         </a:rPr>
-                        <a:t>Existing representation methods focus on overall semantics instead of isolating specific vulnerability concepts.</a:t>
+                        <a:t>LLM metrics are heavily inflated on open-source data due to training contamination.</a:t>
                       </a:r>
                       <a:endParaRPr b="0" sz="1000" u="none" cap="none" strike="noStrike">
                         <a:latin typeface="Times New Roman"/>
@@ -24723,7 +26224,798 @@
                       </a:endParaRPr>
                     </a:p>
                   </a:txBody>
-                  <a:tcPr marT="45725" marB="45725" marR="91450" marL="91450"/>
+                  <a:tcPr marT="45725" marB="45725" marR="91450" marL="91450">
+                    <a:lnL cap="flat" cmpd="sng" w="12700">
+                      <a:solidFill>
+                        <a:schemeClr val="lt1"/>
+                      </a:solidFill>
+                      <a:prstDash val="solid"/>
+                      <a:round/>
+                      <a:headEnd len="sm" w="sm" type="none"/>
+                      <a:tailEnd len="sm" w="sm" type="none"/>
+                    </a:lnL>
+                    <a:lnR cap="flat" cmpd="sng" w="12700">
+                      <a:solidFill>
+                        <a:schemeClr val="lt1"/>
+                      </a:solidFill>
+                      <a:prstDash val="solid"/>
+                      <a:round/>
+                      <a:headEnd len="sm" w="sm" type="none"/>
+                      <a:tailEnd len="sm" w="sm" type="none"/>
+                    </a:lnR>
+                    <a:lnT cap="flat" cmpd="sng" w="12700">
+                      <a:solidFill>
+                        <a:schemeClr val="lt1"/>
+                      </a:solidFill>
+                      <a:prstDash val="solid"/>
+                      <a:round/>
+                      <a:headEnd len="sm" w="sm" type="none"/>
+                      <a:tailEnd len="sm" w="sm" type="none"/>
+                    </a:lnT>
+                    <a:lnB cap="flat" cmpd="sng" w="38100">
+                      <a:solidFill>
+                        <a:schemeClr val="lt1"/>
+                      </a:solidFill>
+                      <a:prstDash val="solid"/>
+                      <a:round/>
+                      <a:headEnd len="sm" w="sm" type="none"/>
+                      <a:tailEnd len="sm" w="sm" type="none"/>
+                    </a:lnB>
+                  </a:tcPr>
+                </a:tc>
+              </a:tr>
+              <a:tr h="750575">
+                <a:tc>
+                  <a:txBody>
+                    <a:bodyPr/>
+                    <a:lstStyle/>
+                    <a:p>
+                      <a:pPr indent="0" lvl="0" marL="0" marR="0" rtl="0" algn="l">
+                        <a:spcBef>
+                          <a:spcPts val="0"/>
+                        </a:spcBef>
+                        <a:spcAft>
+                          <a:spcPts val="0"/>
+                        </a:spcAft>
+                        <a:buClr>
+                          <a:schemeClr val="dk1"/>
+                        </a:buClr>
+                        <a:buSzPts val="1000"/>
+                        <a:buFont typeface="Times New Roman"/>
+                        <a:buNone/>
+                      </a:pPr>
+                      <a:r>
+                        <a:rPr b="0" lang="en" sz="1000" u="none" cap="none" strike="noStrike">
+                          <a:latin typeface="Times New Roman"/>
+                          <a:ea typeface="Times New Roman"/>
+                          <a:cs typeface="Times New Roman"/>
+                          <a:sym typeface="Times New Roman"/>
+                        </a:rPr>
+                        <a:t>Apostolidis et al. (2025)</a:t>
+                      </a:r>
+                      <a:endParaRPr b="0" sz="1000" u="none" cap="none" strike="noStrike">
+                        <a:latin typeface="Times New Roman"/>
+                        <a:ea typeface="Times New Roman"/>
+                        <a:cs typeface="Times New Roman"/>
+                        <a:sym typeface="Times New Roman"/>
+                      </a:endParaRPr>
+                    </a:p>
+                  </a:txBody>
+                  <a:tcPr marT="45725" marB="45725" marR="91450" marL="91450">
+                    <a:lnL cap="flat" cmpd="sng" w="12700">
+                      <a:solidFill>
+                        <a:schemeClr val="lt1"/>
+                      </a:solidFill>
+                      <a:prstDash val="solid"/>
+                      <a:round/>
+                      <a:headEnd len="sm" w="sm" type="none"/>
+                      <a:tailEnd len="sm" w="sm" type="none"/>
+                    </a:lnL>
+                    <a:lnR cap="flat" cmpd="sng" w="12700">
+                      <a:solidFill>
+                        <a:schemeClr val="lt1"/>
+                      </a:solidFill>
+                      <a:prstDash val="solid"/>
+                      <a:round/>
+                      <a:headEnd len="sm" w="sm" type="none"/>
+                      <a:tailEnd len="sm" w="sm" type="none"/>
+                    </a:lnR>
+                    <a:lnT cap="flat" cmpd="sng" w="38100">
+                      <a:solidFill>
+                        <a:schemeClr val="lt1"/>
+                      </a:solidFill>
+                      <a:prstDash val="solid"/>
+                      <a:round/>
+                      <a:headEnd len="sm" w="sm" type="none"/>
+                      <a:tailEnd len="sm" w="sm" type="none"/>
+                    </a:lnT>
+                    <a:lnB cap="flat" cmpd="sng" w="12700">
+                      <a:solidFill>
+                        <a:schemeClr val="lt1"/>
+                      </a:solidFill>
+                      <a:prstDash val="solid"/>
+                      <a:round/>
+                      <a:headEnd len="sm" w="sm" type="none"/>
+                      <a:tailEnd len="sm" w="sm" type="none"/>
+                    </a:lnB>
+                  </a:tcPr>
+                </a:tc>
+                <a:tc>
+                  <a:txBody>
+                    <a:bodyPr/>
+                    <a:lstStyle/>
+                    <a:p>
+                      <a:pPr indent="0" lvl="0" marL="0" marR="0" rtl="0" algn="l">
+                        <a:spcBef>
+                          <a:spcPts val="0"/>
+                        </a:spcBef>
+                        <a:spcAft>
+                          <a:spcPts val="0"/>
+                        </a:spcAft>
+                        <a:buClr>
+                          <a:schemeClr val="dk1"/>
+                        </a:buClr>
+                        <a:buSzPts val="1000"/>
+                        <a:buFont typeface="Times New Roman"/>
+                        <a:buNone/>
+                      </a:pPr>
+                      <a:r>
+                        <a:rPr b="0" lang="en" sz="1000" u="none" cap="none" strike="noStrike">
+                          <a:latin typeface="Times New Roman"/>
+                          <a:ea typeface="Times New Roman"/>
+                          <a:cs typeface="Times New Roman"/>
+                          <a:sym typeface="Times New Roman"/>
+                        </a:rPr>
+                        <a:t>CppCheck static analysis filtered by a fine-tuned CodeBERT vulnerability prediction model.</a:t>
+                      </a:r>
+                      <a:endParaRPr b="0" sz="1000" u="none" cap="none" strike="noStrike">
+                        <a:latin typeface="Times New Roman"/>
+                        <a:ea typeface="Times New Roman"/>
+                        <a:cs typeface="Times New Roman"/>
+                        <a:sym typeface="Times New Roman"/>
+                      </a:endParaRPr>
+                    </a:p>
+                  </a:txBody>
+                  <a:tcPr marT="45725" marB="45725" marR="91450" marL="91450">
+                    <a:lnL cap="flat" cmpd="sng" w="12700">
+                      <a:solidFill>
+                        <a:schemeClr val="lt1"/>
+                      </a:solidFill>
+                      <a:prstDash val="solid"/>
+                      <a:round/>
+                      <a:headEnd len="sm" w="sm" type="none"/>
+                      <a:tailEnd len="sm" w="sm" type="none"/>
+                    </a:lnL>
+                    <a:lnR cap="flat" cmpd="sng" w="12700">
+                      <a:solidFill>
+                        <a:schemeClr val="lt1"/>
+                      </a:solidFill>
+                      <a:prstDash val="solid"/>
+                      <a:round/>
+                      <a:headEnd len="sm" w="sm" type="none"/>
+                      <a:tailEnd len="sm" w="sm" type="none"/>
+                    </a:lnR>
+                    <a:lnT cap="flat" cmpd="sng" w="38100">
+                      <a:solidFill>
+                        <a:schemeClr val="lt1"/>
+                      </a:solidFill>
+                      <a:prstDash val="solid"/>
+                      <a:round/>
+                      <a:headEnd len="sm" w="sm" type="none"/>
+                      <a:tailEnd len="sm" w="sm" type="none"/>
+                    </a:lnT>
+                    <a:lnB cap="flat" cmpd="sng" w="12700">
+                      <a:solidFill>
+                        <a:schemeClr val="lt1"/>
+                      </a:solidFill>
+                      <a:prstDash val="solid"/>
+                      <a:round/>
+                      <a:headEnd len="sm" w="sm" type="none"/>
+                      <a:tailEnd len="sm" w="sm" type="none"/>
+                    </a:lnB>
+                  </a:tcPr>
+                </a:tc>
+                <a:tc>
+                  <a:txBody>
+                    <a:bodyPr/>
+                    <a:lstStyle/>
+                    <a:p>
+                      <a:pPr indent="0" lvl="0" marL="0" marR="0" rtl="0" algn="l">
+                        <a:spcBef>
+                          <a:spcPts val="0"/>
+                        </a:spcBef>
+                        <a:spcAft>
+                          <a:spcPts val="0"/>
+                        </a:spcAft>
+                        <a:buClr>
+                          <a:schemeClr val="dk1"/>
+                        </a:buClr>
+                        <a:buSzPts val="1000"/>
+                        <a:buFont typeface="Times New Roman"/>
+                        <a:buNone/>
+                      </a:pPr>
+                      <a:r>
+                        <a:rPr b="0" lang="en" sz="1000" u="none" cap="none" strike="noStrike">
+                          <a:latin typeface="Times New Roman"/>
+                          <a:ea typeface="Times New Roman"/>
+                          <a:cs typeface="Times New Roman"/>
+                          <a:sym typeface="Times New Roman"/>
+                        </a:rPr>
+                        <a:t>Big-Vul and ReVeal (C/C++ GitHub samples).</a:t>
+                      </a:r>
+                      <a:endParaRPr b="0" sz="1000" u="none" cap="none" strike="noStrike">
+                        <a:latin typeface="Times New Roman"/>
+                        <a:ea typeface="Times New Roman"/>
+                        <a:cs typeface="Times New Roman"/>
+                        <a:sym typeface="Times New Roman"/>
+                      </a:endParaRPr>
+                    </a:p>
+                  </a:txBody>
+                  <a:tcPr marT="45725" marB="45725" marR="91450" marL="91450">
+                    <a:lnL cap="flat" cmpd="sng" w="12700">
+                      <a:solidFill>
+                        <a:schemeClr val="lt1"/>
+                      </a:solidFill>
+                      <a:prstDash val="solid"/>
+                      <a:round/>
+                      <a:headEnd len="sm" w="sm" type="none"/>
+                      <a:tailEnd len="sm" w="sm" type="none"/>
+                    </a:lnL>
+                    <a:lnR cap="flat" cmpd="sng" w="12700">
+                      <a:solidFill>
+                        <a:schemeClr val="lt1"/>
+                      </a:solidFill>
+                      <a:prstDash val="solid"/>
+                      <a:round/>
+                      <a:headEnd len="sm" w="sm" type="none"/>
+                      <a:tailEnd len="sm" w="sm" type="none"/>
+                    </a:lnR>
+                    <a:lnT cap="flat" cmpd="sng" w="38100">
+                      <a:solidFill>
+                        <a:schemeClr val="lt1"/>
+                      </a:solidFill>
+                      <a:prstDash val="solid"/>
+                      <a:round/>
+                      <a:headEnd len="sm" w="sm" type="none"/>
+                      <a:tailEnd len="sm" w="sm" type="none"/>
+                    </a:lnT>
+                    <a:lnB cap="flat" cmpd="sng" w="12700">
+                      <a:solidFill>
+                        <a:schemeClr val="lt1"/>
+                      </a:solidFill>
+                      <a:prstDash val="solid"/>
+                      <a:round/>
+                      <a:headEnd len="sm" w="sm" type="none"/>
+                      <a:tailEnd len="sm" w="sm" type="none"/>
+                    </a:lnB>
+                  </a:tcPr>
+                </a:tc>
+                <a:tc>
+                  <a:txBody>
+                    <a:bodyPr/>
+                    <a:lstStyle/>
+                    <a:p>
+                      <a:pPr indent="0" lvl="0" marL="0" marR="0" rtl="0" algn="l">
+                        <a:spcBef>
+                          <a:spcPts val="0"/>
+                        </a:spcBef>
+                        <a:spcAft>
+                          <a:spcPts val="0"/>
+                        </a:spcAft>
+                        <a:buClr>
+                          <a:schemeClr val="dk1"/>
+                        </a:buClr>
+                        <a:buSzPts val="1000"/>
+                        <a:buFont typeface="Times New Roman"/>
+                        <a:buNone/>
+                      </a:pPr>
+                      <a:r>
+                        <a:rPr b="0" lang="en" sz="1000" u="none" cap="none" strike="noStrike">
+                          <a:latin typeface="Times New Roman"/>
+                          <a:ea typeface="Times New Roman"/>
+                          <a:cs typeface="Times New Roman"/>
+                          <a:sym typeface="Times New Roman"/>
+                        </a:rPr>
+                        <a:t>Reduced false positives, improving static analysis practicality with minimal impact on detection accuracy.</a:t>
+                      </a:r>
+                      <a:endParaRPr b="0" sz="1000" u="none" cap="none" strike="noStrike">
+                        <a:latin typeface="Times New Roman"/>
+                        <a:ea typeface="Times New Roman"/>
+                        <a:cs typeface="Times New Roman"/>
+                        <a:sym typeface="Times New Roman"/>
+                      </a:endParaRPr>
+                    </a:p>
+                  </a:txBody>
+                  <a:tcPr marT="45725" marB="45725" marR="91450" marL="91450">
+                    <a:lnL cap="flat" cmpd="sng" w="12700">
+                      <a:solidFill>
+                        <a:schemeClr val="lt1"/>
+                      </a:solidFill>
+                      <a:prstDash val="solid"/>
+                      <a:round/>
+                      <a:headEnd len="sm" w="sm" type="none"/>
+                      <a:tailEnd len="sm" w="sm" type="none"/>
+                    </a:lnL>
+                    <a:lnR cap="flat" cmpd="sng" w="12700">
+                      <a:solidFill>
+                        <a:schemeClr val="lt1"/>
+                      </a:solidFill>
+                      <a:prstDash val="solid"/>
+                      <a:round/>
+                      <a:headEnd len="sm" w="sm" type="none"/>
+                      <a:tailEnd len="sm" w="sm" type="none"/>
+                    </a:lnR>
+                    <a:lnT cap="flat" cmpd="sng" w="38100">
+                      <a:solidFill>
+                        <a:schemeClr val="lt1"/>
+                      </a:solidFill>
+                      <a:prstDash val="solid"/>
+                      <a:round/>
+                      <a:headEnd len="sm" w="sm" type="none"/>
+                      <a:tailEnd len="sm" w="sm" type="none"/>
+                    </a:lnT>
+                    <a:lnB cap="flat" cmpd="sng" w="12700">
+                      <a:solidFill>
+                        <a:schemeClr val="lt1"/>
+                      </a:solidFill>
+                      <a:prstDash val="solid"/>
+                      <a:round/>
+                      <a:headEnd len="sm" w="sm" type="none"/>
+                      <a:tailEnd len="sm" w="sm" type="none"/>
+                    </a:lnB>
+                  </a:tcPr>
+                </a:tc>
+                <a:tc>
+                  <a:txBody>
+                    <a:bodyPr/>
+                    <a:lstStyle/>
+                    <a:p>
+                      <a:pPr indent="0" lvl="0" marL="0" marR="0" rtl="0" algn="l">
+                        <a:spcBef>
+                          <a:spcPts val="0"/>
+                        </a:spcBef>
+                        <a:spcAft>
+                          <a:spcPts val="0"/>
+                        </a:spcAft>
+                        <a:buClr>
+                          <a:schemeClr val="dk1"/>
+                        </a:buClr>
+                        <a:buSzPts val="1000"/>
+                        <a:buFont typeface="Times New Roman"/>
+                        <a:buNone/>
+                      </a:pPr>
+                      <a:r>
+                        <a:rPr b="0" lang="en" sz="1000" u="none" cap="none" strike="noStrike">
+                          <a:latin typeface="Times New Roman"/>
+                          <a:ea typeface="Times New Roman"/>
+                          <a:cs typeface="Times New Roman"/>
+                          <a:sym typeface="Times New Roman"/>
+                        </a:rPr>
+                        <a:t>Vulnerability prediction models lack line-level granularity; static tools suffer from overwhelming false alarms.</a:t>
+                      </a:r>
+                      <a:endParaRPr b="0" sz="1000" u="none" cap="none" strike="noStrike">
+                        <a:latin typeface="Times New Roman"/>
+                        <a:ea typeface="Times New Roman"/>
+                        <a:cs typeface="Times New Roman"/>
+                        <a:sym typeface="Times New Roman"/>
+                      </a:endParaRPr>
+                    </a:p>
+                  </a:txBody>
+                  <a:tcPr marT="45725" marB="45725" marR="91450" marL="91450">
+                    <a:lnL cap="flat" cmpd="sng" w="12700">
+                      <a:solidFill>
+                        <a:schemeClr val="lt1"/>
+                      </a:solidFill>
+                      <a:prstDash val="solid"/>
+                      <a:round/>
+                      <a:headEnd len="sm" w="sm" type="none"/>
+                      <a:tailEnd len="sm" w="sm" type="none"/>
+                    </a:lnL>
+                    <a:lnR cap="flat" cmpd="sng" w="12700">
+                      <a:solidFill>
+                        <a:schemeClr val="lt1"/>
+                      </a:solidFill>
+                      <a:prstDash val="solid"/>
+                      <a:round/>
+                      <a:headEnd len="sm" w="sm" type="none"/>
+                      <a:tailEnd len="sm" w="sm" type="none"/>
+                    </a:lnR>
+                    <a:lnT cap="flat" cmpd="sng" w="38100">
+                      <a:solidFill>
+                        <a:schemeClr val="lt1"/>
+                      </a:solidFill>
+                      <a:prstDash val="solid"/>
+                      <a:round/>
+                      <a:headEnd len="sm" w="sm" type="none"/>
+                      <a:tailEnd len="sm" w="sm" type="none"/>
+                    </a:lnT>
+                    <a:lnB cap="flat" cmpd="sng" w="12700">
+                      <a:solidFill>
+                        <a:schemeClr val="lt1"/>
+                      </a:solidFill>
+                      <a:prstDash val="solid"/>
+                      <a:round/>
+                      <a:headEnd len="sm" w="sm" type="none"/>
+                      <a:tailEnd len="sm" w="sm" type="none"/>
+                    </a:lnB>
+                  </a:tcPr>
+                </a:tc>
+              </a:tr>
+              <a:tr h="750575">
+                <a:tc>
+                  <a:txBody>
+                    <a:bodyPr/>
+                    <a:lstStyle/>
+                    <a:p>
+                      <a:pPr indent="0" lvl="0" marL="0" marR="0" rtl="0" algn="l">
+                        <a:spcBef>
+                          <a:spcPts val="0"/>
+                        </a:spcBef>
+                        <a:spcAft>
+                          <a:spcPts val="0"/>
+                        </a:spcAft>
+                        <a:buClr>
+                          <a:schemeClr val="dk1"/>
+                        </a:buClr>
+                        <a:buSzPts val="1000"/>
+                        <a:buFont typeface="Times New Roman"/>
+                        <a:buNone/>
+                      </a:pPr>
+                      <a:r>
+                        <a:rPr b="0" lang="en" sz="1000" u="none" cap="none" strike="noStrike">
+                          <a:latin typeface="Times New Roman"/>
+                          <a:ea typeface="Times New Roman"/>
+                          <a:cs typeface="Times New Roman"/>
+                          <a:sym typeface="Times New Roman"/>
+                        </a:rPr>
+                        <a:t>Dozono et al. (2025)</a:t>
+                      </a:r>
+                      <a:endParaRPr b="0" sz="1000" u="none" cap="none" strike="noStrike">
+                        <a:latin typeface="Times New Roman"/>
+                        <a:ea typeface="Times New Roman"/>
+                        <a:cs typeface="Times New Roman"/>
+                        <a:sym typeface="Times New Roman"/>
+                      </a:endParaRPr>
+                    </a:p>
+                  </a:txBody>
+                  <a:tcPr marT="45725" marB="45725" marR="91450" marL="91450">
+                    <a:lnL cap="flat" cmpd="sng" w="12700">
+                      <a:solidFill>
+                        <a:schemeClr val="lt1"/>
+                      </a:solidFill>
+                      <a:prstDash val="solid"/>
+                      <a:round/>
+                      <a:headEnd len="sm" w="sm" type="none"/>
+                      <a:tailEnd len="sm" w="sm" type="none"/>
+                    </a:lnL>
+                    <a:lnR cap="flat" cmpd="sng" w="12700">
+                      <a:solidFill>
+                        <a:schemeClr val="lt1"/>
+                      </a:solidFill>
+                      <a:prstDash val="solid"/>
+                      <a:round/>
+                      <a:headEnd len="sm" w="sm" type="none"/>
+                      <a:tailEnd len="sm" w="sm" type="none"/>
+                    </a:lnR>
+                    <a:lnT cap="flat" cmpd="sng" w="12700">
+                      <a:solidFill>
+                        <a:schemeClr val="lt1"/>
+                      </a:solidFill>
+                      <a:prstDash val="solid"/>
+                      <a:round/>
+                      <a:headEnd len="sm" w="sm" type="none"/>
+                      <a:tailEnd len="sm" w="sm" type="none"/>
+                    </a:lnT>
+                    <a:lnB cap="flat" cmpd="sng" w="38100">
+                      <a:solidFill>
+                        <a:schemeClr val="lt1"/>
+                      </a:solidFill>
+                      <a:prstDash val="solid"/>
+                      <a:round/>
+                      <a:headEnd len="sm" w="sm" type="none"/>
+                      <a:tailEnd len="sm" w="sm" type="none"/>
+                    </a:lnB>
+                  </a:tcPr>
+                </a:tc>
+                <a:tc>
+                  <a:txBody>
+                    <a:bodyPr/>
+                    <a:lstStyle/>
+                    <a:p>
+                      <a:pPr indent="0" lvl="0" marL="0" marR="0" rtl="0" algn="l">
+                        <a:spcBef>
+                          <a:spcPts val="0"/>
+                        </a:spcBef>
+                        <a:spcAft>
+                          <a:spcPts val="0"/>
+                        </a:spcAft>
+                        <a:buClr>
+                          <a:schemeClr val="dk1"/>
+                        </a:buClr>
+                        <a:buSzPts val="1000"/>
+                        <a:buFont typeface="Times New Roman"/>
+                        <a:buNone/>
+                      </a:pPr>
+                      <a:r>
+                        <a:rPr b="0" lang="en" sz="1000" u="none" cap="none" strike="noStrike">
+                          <a:latin typeface="Times New Roman"/>
+                          <a:ea typeface="Times New Roman"/>
+                          <a:cs typeface="Times New Roman"/>
+                          <a:sym typeface="Times New Roman"/>
+                        </a:rPr>
+                        <a:t>Empirical evaluation of 5 frontier LLMs comparing open-source vs. closed-source code performance.</a:t>
+                      </a:r>
+                      <a:endParaRPr b="0" sz="1000" u="none" cap="none" strike="noStrike">
+                        <a:latin typeface="Times New Roman"/>
+                        <a:ea typeface="Times New Roman"/>
+                        <a:cs typeface="Times New Roman"/>
+                        <a:sym typeface="Times New Roman"/>
+                      </a:endParaRPr>
+                    </a:p>
+                  </a:txBody>
+                  <a:tcPr marT="45725" marB="45725" marR="91450" marL="91450">
+                    <a:lnL cap="flat" cmpd="sng" w="12700">
+                      <a:solidFill>
+                        <a:schemeClr val="lt1"/>
+                      </a:solidFill>
+                      <a:prstDash val="solid"/>
+                      <a:round/>
+                      <a:headEnd len="sm" w="sm" type="none"/>
+                      <a:tailEnd len="sm" w="sm" type="none"/>
+                    </a:lnL>
+                    <a:lnR cap="flat" cmpd="sng" w="12700">
+                      <a:solidFill>
+                        <a:schemeClr val="lt1"/>
+                      </a:solidFill>
+                      <a:prstDash val="solid"/>
+                      <a:round/>
+                      <a:headEnd len="sm" w="sm" type="none"/>
+                      <a:tailEnd len="sm" w="sm" type="none"/>
+                    </a:lnR>
+                    <a:lnT cap="flat" cmpd="sng" w="12700">
+                      <a:solidFill>
+                        <a:schemeClr val="lt1"/>
+                      </a:solidFill>
+                      <a:prstDash val="solid"/>
+                      <a:round/>
+                      <a:headEnd len="sm" w="sm" type="none"/>
+                      <a:tailEnd len="sm" w="sm" type="none"/>
+                    </a:lnT>
+                    <a:lnB cap="flat" cmpd="sng" w="38100">
+                      <a:solidFill>
+                        <a:schemeClr val="lt1"/>
+                      </a:solidFill>
+                      <a:prstDash val="solid"/>
+                      <a:round/>
+                      <a:headEnd len="sm" w="sm" type="none"/>
+                      <a:tailEnd len="sm" w="sm" type="none"/>
+                    </a:lnB>
+                  </a:tcPr>
+                </a:tc>
+                <a:tc>
+                  <a:txBody>
+                    <a:bodyPr/>
+                    <a:lstStyle/>
+                    <a:p>
+                      <a:pPr indent="0" lvl="0" marL="0" marR="0" rtl="0" algn="l">
+                        <a:spcBef>
+                          <a:spcPts val="0"/>
+                        </a:spcBef>
+                        <a:spcAft>
+                          <a:spcPts val="0"/>
+                        </a:spcAft>
+                        <a:buClr>
+                          <a:schemeClr val="dk1"/>
+                        </a:buClr>
+                        <a:buSzPts val="1000"/>
+                        <a:buFont typeface="Times New Roman"/>
+                        <a:buNone/>
+                      </a:pPr>
+                      <a:r>
+                        <a:rPr b="0" lang="en" sz="1000" u="none" cap="none" strike="noStrike">
+                          <a:latin typeface="Times New Roman"/>
+                          <a:ea typeface="Times New Roman"/>
+                          <a:cs typeface="Times New Roman"/>
+                          <a:sym typeface="Times New Roman"/>
+                        </a:rPr>
+                        <a:t>CWE-Bench-Java (Open) and TS-Vuls (Closed, commercial Teamscale codebase).</a:t>
+                      </a:r>
+                      <a:endParaRPr b="0" sz="1000" u="none" cap="none" strike="noStrike">
+                        <a:latin typeface="Times New Roman"/>
+                        <a:ea typeface="Times New Roman"/>
+                        <a:cs typeface="Times New Roman"/>
+                        <a:sym typeface="Times New Roman"/>
+                      </a:endParaRPr>
+                    </a:p>
+                  </a:txBody>
+                  <a:tcPr marT="45725" marB="45725" marR="91450" marL="91450">
+                    <a:lnL cap="flat" cmpd="sng" w="12700">
+                      <a:solidFill>
+                        <a:schemeClr val="lt1"/>
+                      </a:solidFill>
+                      <a:prstDash val="solid"/>
+                      <a:round/>
+                      <a:headEnd len="sm" w="sm" type="none"/>
+                      <a:tailEnd len="sm" w="sm" type="none"/>
+                    </a:lnL>
+                    <a:lnR cap="flat" cmpd="sng" w="12700">
+                      <a:solidFill>
+                        <a:schemeClr val="lt1"/>
+                      </a:solidFill>
+                      <a:prstDash val="solid"/>
+                      <a:round/>
+                      <a:headEnd len="sm" w="sm" type="none"/>
+                      <a:tailEnd len="sm" w="sm" type="none"/>
+                    </a:lnR>
+                    <a:lnT cap="flat" cmpd="sng" w="12700">
+                      <a:solidFill>
+                        <a:schemeClr val="lt1"/>
+                      </a:solidFill>
+                      <a:prstDash val="solid"/>
+                      <a:round/>
+                      <a:headEnd len="sm" w="sm" type="none"/>
+                      <a:tailEnd len="sm" w="sm" type="none"/>
+                    </a:lnT>
+                    <a:lnB cap="flat" cmpd="sng" w="38100">
+                      <a:solidFill>
+                        <a:schemeClr val="lt1"/>
+                      </a:solidFill>
+                      <a:prstDash val="solid"/>
+                      <a:round/>
+                      <a:headEnd len="sm" w="sm" type="none"/>
+                      <a:tailEnd len="sm" w="sm" type="none"/>
+                    </a:lnB>
+                  </a:tcPr>
+                </a:tc>
+                <a:tc>
+                  <a:txBody>
+                    <a:bodyPr/>
+                    <a:lstStyle/>
+                    <a:p>
+                      <a:pPr indent="0" lvl="0" marL="0" marR="0" rtl="0" algn="l">
+                        <a:spcBef>
+                          <a:spcPts val="0"/>
+                        </a:spcBef>
+                        <a:spcAft>
+                          <a:spcPts val="0"/>
+                        </a:spcAft>
+                        <a:buClr>
+                          <a:schemeClr val="dk1"/>
+                        </a:buClr>
+                        <a:buSzPts val="1000"/>
+                        <a:buFont typeface="Times New Roman"/>
+                        <a:buNone/>
+                      </a:pPr>
+                      <a:r>
+                        <a:rPr b="0" lang="en" sz="1000" u="none" cap="none" strike="noStrike">
+                          <a:latin typeface="Times New Roman"/>
+                          <a:ea typeface="Times New Roman"/>
+                          <a:cs typeface="Times New Roman"/>
+                          <a:sym typeface="Times New Roman"/>
+                        </a:rPr>
+                        <a:t>Precision dropped significantly from 56% on open-source code to 34% on closed-source code.</a:t>
+                      </a:r>
+                      <a:endParaRPr b="0" sz="1000" u="none" cap="none" strike="noStrike">
+                        <a:latin typeface="Times New Roman"/>
+                        <a:ea typeface="Times New Roman"/>
+                        <a:cs typeface="Times New Roman"/>
+                        <a:sym typeface="Times New Roman"/>
+                      </a:endParaRPr>
+                    </a:p>
+                  </a:txBody>
+                  <a:tcPr marT="45725" marB="45725" marR="91450" marL="91450">
+                    <a:lnL cap="flat" cmpd="sng" w="12700">
+                      <a:solidFill>
+                        <a:schemeClr val="lt1"/>
+                      </a:solidFill>
+                      <a:prstDash val="solid"/>
+                      <a:round/>
+                      <a:headEnd len="sm" w="sm" type="none"/>
+                      <a:tailEnd len="sm" w="sm" type="none"/>
+                    </a:lnL>
+                    <a:lnR cap="flat" cmpd="sng" w="12700">
+                      <a:solidFill>
+                        <a:schemeClr val="lt1"/>
+                      </a:solidFill>
+                      <a:prstDash val="solid"/>
+                      <a:round/>
+                      <a:headEnd len="sm" w="sm" type="none"/>
+                      <a:tailEnd len="sm" w="sm" type="none"/>
+                    </a:lnR>
+                    <a:lnT cap="flat" cmpd="sng" w="12700">
+                      <a:solidFill>
+                        <a:schemeClr val="lt1"/>
+                      </a:solidFill>
+                      <a:prstDash val="solid"/>
+                      <a:round/>
+                      <a:headEnd len="sm" w="sm" type="none"/>
+                      <a:tailEnd len="sm" w="sm" type="none"/>
+                    </a:lnT>
+                    <a:lnB cap="flat" cmpd="sng" w="38100">
+                      <a:solidFill>
+                        <a:schemeClr val="lt1"/>
+                      </a:solidFill>
+                      <a:prstDash val="solid"/>
+                      <a:round/>
+                      <a:headEnd len="sm" w="sm" type="none"/>
+                      <a:tailEnd len="sm" w="sm" type="none"/>
+                    </a:lnB>
+                  </a:tcPr>
+                </a:tc>
+                <a:tc>
+                  <a:txBody>
+                    <a:bodyPr/>
+                    <a:lstStyle/>
+                    <a:p>
+                      <a:pPr indent="0" lvl="0" marL="0" marR="0" rtl="0" algn="l">
+                        <a:spcBef>
+                          <a:spcPts val="0"/>
+                        </a:spcBef>
+                        <a:spcAft>
+                          <a:spcPts val="0"/>
+                        </a:spcAft>
+                        <a:buClr>
+                          <a:schemeClr val="dk1"/>
+                        </a:buClr>
+                        <a:buSzPts val="1000"/>
+                        <a:buFont typeface="Times New Roman"/>
+                        <a:buNone/>
+                      </a:pPr>
+                      <a:r>
+                        <a:rPr b="0" lang="en" sz="1000" u="none" cap="none" strike="noStrike">
+                          <a:latin typeface="Times New Roman"/>
+                          <a:ea typeface="Times New Roman"/>
+                          <a:cs typeface="Times New Roman"/>
+                          <a:sym typeface="Times New Roman"/>
+                        </a:rPr>
+                        <a:t>LLM metrics are heavily inflated on open-source data due to training contamination.</a:t>
+                      </a:r>
+                      <a:endParaRPr b="0" sz="1000" u="none" cap="none" strike="noStrike">
+                        <a:latin typeface="Times New Roman"/>
+                        <a:ea typeface="Times New Roman"/>
+                        <a:cs typeface="Times New Roman"/>
+                        <a:sym typeface="Times New Roman"/>
+                      </a:endParaRPr>
+                    </a:p>
+                  </a:txBody>
+                  <a:tcPr marT="45725" marB="45725" marR="91450" marL="91450">
+                    <a:lnL cap="flat" cmpd="sng" w="12700">
+                      <a:solidFill>
+                        <a:schemeClr val="lt1"/>
+                      </a:solidFill>
+                      <a:prstDash val="solid"/>
+                      <a:round/>
+                      <a:headEnd len="sm" w="sm" type="none"/>
+                      <a:tailEnd len="sm" w="sm" type="none"/>
+                    </a:lnL>
+                    <a:lnR cap="flat" cmpd="sng" w="12700">
+                      <a:solidFill>
+                        <a:schemeClr val="lt1"/>
+                      </a:solidFill>
+                      <a:prstDash val="solid"/>
+                      <a:round/>
+                      <a:headEnd len="sm" w="sm" type="none"/>
+                      <a:tailEnd len="sm" w="sm" type="none"/>
+                    </a:lnR>
+                    <a:lnT cap="flat" cmpd="sng" w="12700">
+                      <a:solidFill>
+                        <a:schemeClr val="lt1"/>
+                      </a:solidFill>
+                      <a:prstDash val="solid"/>
+                      <a:round/>
+                      <a:headEnd len="sm" w="sm" type="none"/>
+                      <a:tailEnd len="sm" w="sm" type="none"/>
+                    </a:lnT>
+                    <a:lnB cap="flat" cmpd="sng" w="38100">
+                      <a:solidFill>
+                        <a:schemeClr val="lt1"/>
+                      </a:solidFill>
+                      <a:prstDash val="solid"/>
+                      <a:round/>
+                      <a:headEnd len="sm" w="sm" type="none"/>
+                      <a:tailEnd len="sm" w="sm" type="none"/>
+                    </a:lnB>
+                  </a:tcPr>
                 </a:tc>
               </a:tr>
               <a:tr h="750575">
@@ -24763,7 +27055,17 @@
                       </a:endParaRPr>
                     </a:p>
                   </a:txBody>
-                  <a:tcPr marT="45725" marB="45725" marR="91450" marL="91450"/>
+                  <a:tcPr marT="45725" marB="45725" marR="91450" marL="91450">
+                    <a:lnT cap="flat" cmpd="sng" w="38100">
+                      <a:solidFill>
+                        <a:schemeClr val="lt1"/>
+                      </a:solidFill>
+                      <a:prstDash val="solid"/>
+                      <a:round/>
+                      <a:headEnd len="sm" w="sm" type="none"/>
+                      <a:tailEnd len="sm" w="sm" type="none"/>
+                    </a:lnT>
+                  </a:tcPr>
                 </a:tc>
                 <a:tc>
                   <a:txBody>
@@ -24801,7 +27103,17 @@
                       </a:endParaRPr>
                     </a:p>
                   </a:txBody>
-                  <a:tcPr marT="45725" marB="45725" marR="91450" marL="91450"/>
+                  <a:tcPr marT="45725" marB="45725" marR="91450" marL="91450">
+                    <a:lnT cap="flat" cmpd="sng" w="38100">
+                      <a:solidFill>
+                        <a:schemeClr val="lt1"/>
+                      </a:solidFill>
+                      <a:prstDash val="solid"/>
+                      <a:round/>
+                      <a:headEnd len="sm" w="sm" type="none"/>
+                      <a:tailEnd len="sm" w="sm" type="none"/>
+                    </a:lnT>
+                  </a:tcPr>
                 </a:tc>
                 <a:tc>
                   <a:txBody>
@@ -24839,7 +27151,17 @@
                       </a:endParaRPr>
                     </a:p>
                   </a:txBody>
-                  <a:tcPr marT="45725" marB="45725" marR="91450" marL="91450"/>
+                  <a:tcPr marT="45725" marB="45725" marR="91450" marL="91450">
+                    <a:lnT cap="flat" cmpd="sng" w="38100">
+                      <a:solidFill>
+                        <a:schemeClr val="lt1"/>
+                      </a:solidFill>
+                      <a:prstDash val="solid"/>
+                      <a:round/>
+                      <a:headEnd len="sm" w="sm" type="none"/>
+                      <a:tailEnd len="sm" w="sm" type="none"/>
+                    </a:lnT>
+                  </a:tcPr>
                 </a:tc>
                 <a:tc>
                   <a:txBody>
@@ -24877,7 +27199,17 @@
                       </a:endParaRPr>
                     </a:p>
                   </a:txBody>
-                  <a:tcPr marT="45725" marB="45725" marR="91450" marL="91450"/>
+                  <a:tcPr marT="45725" marB="45725" marR="91450" marL="91450">
+                    <a:lnT cap="flat" cmpd="sng" w="38100">
+                      <a:solidFill>
+                        <a:schemeClr val="lt1"/>
+                      </a:solidFill>
+                      <a:prstDash val="solid"/>
+                      <a:round/>
+                      <a:headEnd len="sm" w="sm" type="none"/>
+                      <a:tailEnd len="sm" w="sm" type="none"/>
+                    </a:lnT>
+                  </a:tcPr>
                 </a:tc>
                 <a:tc>
                   <a:txBody>
@@ -24915,391 +27247,17 @@
                       </a:endParaRPr>
                     </a:p>
                   </a:txBody>
-                  <a:tcPr marT="45725" marB="45725" marR="91450" marL="91450"/>
-                </a:tc>
-              </a:tr>
-              <a:tr h="751200">
-                <a:tc>
-                  <a:txBody>
-                    <a:bodyPr/>
-                    <a:lstStyle/>
-                    <a:p>
-                      <a:pPr indent="0" lvl="0" marL="0" marR="0" rtl="0" algn="l">
-                        <a:spcBef>
-                          <a:spcPts val="0"/>
-                        </a:spcBef>
-                        <a:spcAft>
-                          <a:spcPts val="0"/>
-                        </a:spcAft>
-                        <a:buClr>
-                          <a:schemeClr val="dk1"/>
-                        </a:buClr>
-                        <a:buSzPts val="1000"/>
-                        <a:buFont typeface="Times New Roman"/>
-                        <a:buNone/>
-                      </a:pPr>
-                      <a:r>
-                        <a:rPr b="0" lang="en" sz="1000" u="none" cap="none" strike="noStrike">
-                          <a:latin typeface="Times New Roman"/>
-                          <a:ea typeface="Times New Roman"/>
-                          <a:cs typeface="Times New Roman"/>
-                          <a:sym typeface="Times New Roman"/>
-                        </a:rPr>
-                        <a:t>Kim et al. (2025)</a:t>
-                      </a:r>
-                      <a:endParaRPr b="0" sz="1000" u="none" cap="none" strike="noStrike">
-                        <a:latin typeface="Times New Roman"/>
-                        <a:ea typeface="Times New Roman"/>
-                        <a:cs typeface="Times New Roman"/>
-                        <a:sym typeface="Times New Roman"/>
-                      </a:endParaRPr>
-                    </a:p>
-                  </a:txBody>
-                  <a:tcPr marT="45725" marB="45725" marR="91450" marL="91450"/>
-                </a:tc>
-                <a:tc>
-                  <a:txBody>
-                    <a:bodyPr/>
-                    <a:lstStyle/>
-                    <a:p>
-                      <a:pPr indent="0" lvl="0" marL="0" marR="0" rtl="0" algn="l">
-                        <a:spcBef>
-                          <a:spcPts val="0"/>
-                        </a:spcBef>
-                        <a:spcAft>
-                          <a:spcPts val="0"/>
-                        </a:spcAft>
-                        <a:buClr>
-                          <a:schemeClr val="dk1"/>
-                        </a:buClr>
-                        <a:buSzPts val="1000"/>
-                        <a:buFont typeface="Times New Roman"/>
-                        <a:buNone/>
-                      </a:pPr>
-                      <a:r>
-                        <a:rPr b="0" lang="en" sz="1000" u="none" cap="none" strike="noStrike">
-                          <a:latin typeface="Times New Roman"/>
-                          <a:ea typeface="Times New Roman"/>
-                          <a:cs typeface="Times New Roman"/>
-                          <a:sym typeface="Times New Roman"/>
-                        </a:rPr>
-                        <a:t>Reinforcement learning (RL) based context generator to infer contextual signals from user prompts.</a:t>
-                      </a:r>
-                      <a:endParaRPr b="0" sz="1000" u="none" cap="none" strike="noStrike">
-                        <a:latin typeface="Times New Roman"/>
-                        <a:ea typeface="Times New Roman"/>
-                        <a:cs typeface="Times New Roman"/>
-                        <a:sym typeface="Times New Roman"/>
-                      </a:endParaRPr>
-                    </a:p>
-                  </a:txBody>
-                  <a:tcPr marT="45725" marB="45725" marR="91450" marL="91450"/>
-                </a:tc>
-                <a:tc>
-                  <a:txBody>
-                    <a:bodyPr/>
-                    <a:lstStyle/>
-                    <a:p>
-                      <a:pPr indent="0" lvl="0" marL="0" marR="0" rtl="0" algn="l">
-                        <a:spcBef>
-                          <a:spcPts val="0"/>
-                        </a:spcBef>
-                        <a:spcAft>
-                          <a:spcPts val="0"/>
-                        </a:spcAft>
-                        <a:buClr>
-                          <a:schemeClr val="dk1"/>
-                        </a:buClr>
-                        <a:buSzPts val="1000"/>
-                        <a:buFont typeface="Times New Roman"/>
-                        <a:buNone/>
-                      </a:pPr>
-                      <a:r>
-                        <a:rPr b="0" lang="en" sz="1000" u="none" cap="none" strike="noStrike">
-                          <a:latin typeface="Times New Roman"/>
-                          <a:ea typeface="Times New Roman"/>
-                          <a:cs typeface="Times New Roman"/>
-                          <a:sym typeface="Times New Roman"/>
-                        </a:rPr>
-                        <a:t>SafetyInstruct, Advbench, Wildjailbreak, XSTest.</a:t>
-                      </a:r>
-                      <a:endParaRPr b="0" sz="1000" u="none" cap="none" strike="noStrike">
-                        <a:latin typeface="Times New Roman"/>
-                        <a:ea typeface="Times New Roman"/>
-                        <a:cs typeface="Times New Roman"/>
-                        <a:sym typeface="Times New Roman"/>
-                      </a:endParaRPr>
-                    </a:p>
-                  </a:txBody>
-                  <a:tcPr marT="45725" marB="45725" marR="91450" marL="91450"/>
-                </a:tc>
-                <a:tc>
-                  <a:txBody>
-                    <a:bodyPr/>
-                    <a:lstStyle/>
-                    <a:p>
-                      <a:pPr indent="0" lvl="0" marL="0" marR="0" rtl="0" algn="l">
-                        <a:spcBef>
-                          <a:spcPts val="0"/>
-                        </a:spcBef>
-                        <a:spcAft>
-                          <a:spcPts val="0"/>
-                        </a:spcAft>
-                        <a:buClr>
-                          <a:schemeClr val="dk1"/>
-                        </a:buClr>
-                        <a:buSzPts val="1000"/>
-                        <a:buFont typeface="Times New Roman"/>
-                        <a:buNone/>
-                      </a:pPr>
-                      <a:r>
-                        <a:rPr b="0" lang="en" sz="1000" u="none" cap="none" strike="noStrike">
-                          <a:latin typeface="Times New Roman"/>
-                          <a:ea typeface="Times New Roman"/>
-                          <a:cs typeface="Times New Roman"/>
-                          <a:sym typeface="Times New Roman"/>
-                        </a:rPr>
-                        <a:t>Reduces harmful responses while preventing unnecessary refusals of benign requests.</a:t>
-                      </a:r>
-                      <a:endParaRPr b="0" sz="1000" u="none" cap="none" strike="noStrike">
-                        <a:latin typeface="Times New Roman"/>
-                        <a:ea typeface="Times New Roman"/>
-                        <a:cs typeface="Times New Roman"/>
-                        <a:sym typeface="Times New Roman"/>
-                      </a:endParaRPr>
-                    </a:p>
-                  </a:txBody>
-                  <a:tcPr marT="45725" marB="45725" marR="91450" marL="91450"/>
-                </a:tc>
-                <a:tc>
-                  <a:txBody>
-                    <a:bodyPr/>
-                    <a:lstStyle/>
-                    <a:p>
-                      <a:pPr indent="0" lvl="0" marL="0" marR="0" rtl="0" algn="l">
-                        <a:spcBef>
-                          <a:spcPts val="0"/>
-                        </a:spcBef>
-                        <a:spcAft>
-                          <a:spcPts val="0"/>
-                        </a:spcAft>
-                        <a:buClr>
-                          <a:schemeClr val="dk1"/>
-                        </a:buClr>
-                        <a:buSzPts val="1000"/>
-                        <a:buFont typeface="Times New Roman"/>
-                        <a:buNone/>
-                      </a:pPr>
-                      <a:r>
-                        <a:rPr b="0" lang="en" sz="1000" u="none" cap="none" strike="noStrike">
-                          <a:latin typeface="Times New Roman"/>
-                          <a:ea typeface="Times New Roman"/>
-                          <a:cs typeface="Times New Roman"/>
-                          <a:sym typeface="Times New Roman"/>
-                        </a:rPr>
-                        <a:t>Conventional LLM frameworks fail on ambiguous tasks; extracting context is necessary to prevent bypassing safeguards.</a:t>
-                      </a:r>
-                      <a:endParaRPr b="0" sz="1000" u="none" cap="none" strike="noStrike">
-                        <a:latin typeface="Times New Roman"/>
-                        <a:ea typeface="Times New Roman"/>
-                        <a:cs typeface="Times New Roman"/>
-                        <a:sym typeface="Times New Roman"/>
-                      </a:endParaRPr>
-                    </a:p>
-                  </a:txBody>
-                  <a:tcPr marT="45725" marB="45725" marR="91450" marL="91450"/>
-                </a:tc>
-              </a:tr>
-              <a:tr h="750575">
-                <a:tc>
-                  <a:txBody>
-                    <a:bodyPr/>
-                    <a:lstStyle/>
-                    <a:p>
-                      <a:pPr indent="0" lvl="0" marL="0" marR="0" rtl="0" algn="l">
-                        <a:spcBef>
-                          <a:spcPts val="0"/>
-                        </a:spcBef>
-                        <a:spcAft>
-                          <a:spcPts val="0"/>
-                        </a:spcAft>
-                        <a:buClr>
-                          <a:schemeClr val="dk1"/>
-                        </a:buClr>
-                        <a:buSzPts val="1000"/>
-                        <a:buFont typeface="Times New Roman"/>
-                        <a:buNone/>
-                      </a:pPr>
-                      <a:r>
-                        <a:rPr b="0" lang="en" sz="1000" u="none" cap="none" strike="noStrike">
-                          <a:latin typeface="Times New Roman"/>
-                          <a:ea typeface="Times New Roman"/>
-                          <a:cs typeface="Times New Roman"/>
-                          <a:sym typeface="Times New Roman"/>
-                        </a:rPr>
-                        <a:t>Schwarz (2025)</a:t>
-                      </a:r>
-                      <a:endParaRPr b="0" sz="1000" u="none" cap="none" strike="noStrike">
-                        <a:latin typeface="Times New Roman"/>
-                        <a:ea typeface="Times New Roman"/>
-                        <a:cs typeface="Times New Roman"/>
-                        <a:sym typeface="Times New Roman"/>
-                      </a:endParaRPr>
-                    </a:p>
-                  </a:txBody>
-                  <a:tcPr marT="45725" marB="45725" marR="91450" marL="91450"/>
-                </a:tc>
-                <a:tc>
-                  <a:txBody>
-                    <a:bodyPr/>
-                    <a:lstStyle/>
-                    <a:p>
-                      <a:pPr indent="0" lvl="0" marL="0" marR="0" rtl="0" algn="l">
-                        <a:spcBef>
-                          <a:spcPts val="0"/>
-                        </a:spcBef>
-                        <a:spcAft>
-                          <a:spcPts val="0"/>
-                        </a:spcAft>
-                        <a:buClr>
-                          <a:schemeClr val="dk1"/>
-                        </a:buClr>
-                        <a:buSzPts val="1000"/>
-                        <a:buFont typeface="Times New Roman"/>
-                        <a:buNone/>
-                      </a:pPr>
-                      <a:r>
-                        <a:rPr b="0" lang="en" sz="1000" u="none" cap="none" strike="noStrike">
-                          <a:latin typeface="Times New Roman"/>
-                          <a:ea typeface="Times New Roman"/>
-                          <a:cs typeface="Times New Roman"/>
-                          <a:sym typeface="Times New Roman"/>
-                        </a:rPr>
-                        <a:t>"Countermind" multi-layered security architecture using Semantic Boundary Logic (SBL) and Parameter-Space Restriction (PSR).</a:t>
-                      </a:r>
-                      <a:endParaRPr b="0" sz="1000" u="none" cap="none" strike="noStrike">
-                        <a:latin typeface="Times New Roman"/>
-                        <a:ea typeface="Times New Roman"/>
-                        <a:cs typeface="Times New Roman"/>
-                        <a:sym typeface="Times New Roman"/>
-                      </a:endParaRPr>
-                    </a:p>
-                  </a:txBody>
-                  <a:tcPr marT="45725" marB="45725" marR="91450" marL="91450"/>
-                </a:tc>
-                <a:tc>
-                  <a:txBody>
-                    <a:bodyPr/>
-                    <a:lstStyle/>
-                    <a:p>
-                      <a:pPr indent="0" lvl="0" marL="0" marR="0" rtl="0" algn="l">
-                        <a:spcBef>
-                          <a:spcPts val="0"/>
-                        </a:spcBef>
-                        <a:spcAft>
-                          <a:spcPts val="0"/>
-                        </a:spcAft>
-                        <a:buClr>
-                          <a:schemeClr val="dk1"/>
-                        </a:buClr>
-                        <a:buSzPts val="1000"/>
-                        <a:buFont typeface="Times New Roman"/>
-                        <a:buNone/>
-                      </a:pPr>
-                      <a:r>
-                        <a:rPr b="0" lang="en" sz="1000" u="none" cap="none" strike="noStrike">
-                          <a:latin typeface="Times New Roman"/>
-                          <a:ea typeface="Times New Roman"/>
-                          <a:cs typeface="Times New Roman"/>
-                          <a:sym typeface="Times New Roman"/>
-                        </a:rPr>
-                        <a:t>N/A (Conceptual/Architectural design).</a:t>
-                      </a:r>
-                      <a:endParaRPr b="0" sz="1000" u="none" cap="none" strike="noStrike">
-                        <a:latin typeface="Times New Roman"/>
-                        <a:ea typeface="Times New Roman"/>
-                        <a:cs typeface="Times New Roman"/>
-                        <a:sym typeface="Times New Roman"/>
-                      </a:endParaRPr>
-                    </a:p>
-                  </a:txBody>
-                  <a:tcPr marT="45725" marB="45725" marR="91450" marL="91450"/>
-                </a:tc>
-                <a:tc>
-                  <a:txBody>
-                    <a:bodyPr/>
-                    <a:lstStyle/>
-                    <a:p>
-                      <a:pPr indent="0" lvl="0" marL="0" marR="0" rtl="0" algn="l">
-                        <a:spcBef>
-                          <a:spcPts val="0"/>
-                        </a:spcBef>
-                        <a:spcAft>
-                          <a:spcPts val="0"/>
-                        </a:spcAft>
-                        <a:buClr>
-                          <a:schemeClr val="dk1"/>
-                        </a:buClr>
-                        <a:buSzPts val="1000"/>
-                        <a:buFont typeface="Times New Roman"/>
-                        <a:buNone/>
-                      </a:pPr>
-                      <a:r>
-                        <a:rPr b="0" lang="en" sz="1000" u="none" cap="none" strike="noStrike">
-                          <a:latin typeface="Times New Roman"/>
-                          <a:ea typeface="Times New Roman"/>
-                          <a:cs typeface="Times New Roman"/>
-                          <a:sym typeface="Times New Roman"/>
-                        </a:rPr>
-                        <a:t>Shifts LLM defenses from reactive post-hoc filtering to proactive pre-inference structural validation.</a:t>
-                      </a:r>
-                      <a:endParaRPr b="0" sz="1000" u="none" cap="none" strike="noStrike">
-                        <a:latin typeface="Times New Roman"/>
-                        <a:ea typeface="Times New Roman"/>
-                        <a:cs typeface="Times New Roman"/>
-                        <a:sym typeface="Times New Roman"/>
-                      </a:endParaRPr>
-                    </a:p>
-                  </a:txBody>
-                  <a:tcPr marT="45725" marB="45725" marR="91450" marL="91450"/>
-                </a:tc>
-                <a:tc>
-                  <a:txBody>
-                    <a:bodyPr/>
-                    <a:lstStyle/>
-                    <a:p>
-                      <a:pPr indent="0" lvl="0" marL="0" marR="0" rtl="0" algn="l">
-                        <a:spcBef>
-                          <a:spcPts val="0"/>
-                        </a:spcBef>
-                        <a:spcAft>
-                          <a:spcPts val="0"/>
-                        </a:spcAft>
-                        <a:buClr>
-                          <a:schemeClr val="dk1"/>
-                        </a:buClr>
-                        <a:buSzPts val="1000"/>
-                        <a:buFont typeface="Times New Roman"/>
-                        <a:buNone/>
-                      </a:pPr>
-                      <a:r>
-                        <a:rPr b="0" lang="en" sz="1000" u="none" cap="none" strike="noStrike">
-                          <a:latin typeface="Times New Roman"/>
-                          <a:ea typeface="Times New Roman"/>
-                          <a:cs typeface="Times New Roman"/>
-                          <a:sym typeface="Times New Roman"/>
-                        </a:rPr>
-                        <a:t>Post-hoc filters are brittle against prompt injections; models inherently struggle to distinguish trusted instructions from untrusted data.</a:t>
-                      </a:r>
-                      <a:endParaRPr b="0" sz="1000" u="none" cap="none" strike="noStrike">
-                        <a:latin typeface="Times New Roman"/>
-                        <a:ea typeface="Times New Roman"/>
-                        <a:cs typeface="Times New Roman"/>
-                        <a:sym typeface="Times New Roman"/>
-                      </a:endParaRPr>
-                    </a:p>
-                  </a:txBody>
-                  <a:tcPr marT="45725" marB="45725" marR="91450" marL="91450"/>
+                  <a:tcPr marT="45725" marB="45725" marR="91450" marL="91450">
+                    <a:lnT cap="flat" cmpd="sng" w="38100">
+                      <a:solidFill>
+                        <a:schemeClr val="lt1"/>
+                      </a:solidFill>
+                      <a:prstDash val="solid"/>
+                      <a:round/>
+                      <a:headEnd len="sm" w="sm" type="none"/>
+                      <a:tailEnd len="sm" w="sm" type="none"/>
+                    </a:lnT>
+                  </a:tcPr>
                 </a:tc>
               </a:tr>
             </a:tbl>

</xml_diff>

<commit_message>
chore: update project documentation, presentation slides, and manuscript report files
</commit_message>
<xml_diff>
--- a/SEM_8/FRP/FRP End Term.pptx
+++ b/SEM_8/FRP/FRP End Term.pptx
@@ -21771,8 +21771,8 @@
         </p:nvSpPr>
         <p:spPr>
           <a:xfrm>
-            <a:off x="342900" y="1004625"/>
-            <a:ext cx="7798800" cy="3885600"/>
+            <a:off x="342900" y="1002150"/>
+            <a:ext cx="7798800" cy="3888000"/>
           </a:xfrm>
           <a:prstGeom prst="rect">
             <a:avLst/>
@@ -22957,7 +22957,28 @@
                 <a:cs typeface="Times New Roman"/>
                 <a:sym typeface="Times New Roman"/>
               </a:rPr>
-              <a:t>High FPR causes severe </a:t>
+              <a:t>High Fals</a:t>
+            </a:r>
+            <a:r>
+              <a:rPr lang="en" sz="1600">
+                <a:latin typeface="Times New Roman"/>
+                <a:ea typeface="Times New Roman"/>
+                <a:cs typeface="Times New Roman"/>
+                <a:sym typeface="Times New Roman"/>
+              </a:rPr>
+              <a:t>e </a:t>
+            </a:r>
+            <a:r>
+              <a:rPr lang="en" sz="1600">
+                <a:solidFill>
+                  <a:srgbClr val="000000"/>
+                </a:solidFill>
+                <a:latin typeface="Times New Roman"/>
+                <a:ea typeface="Times New Roman"/>
+                <a:cs typeface="Times New Roman"/>
+                <a:sym typeface="Times New Roman"/>
+              </a:rPr>
+              <a:t>Positive Rates causes severe </a:t>
             </a:r>
             <a:r>
               <a:rPr lang="en" sz="1600">
@@ -23564,7 +23585,7 @@
             <a:tbl>
               <a:tblPr bandRow="1" firstRow="1">
                 <a:noFill/>
-                <a:tableStyleId>{4988CF06-5FA7-4D49-9562-FA9D673A86ED}</a:tableStyleId>
+                <a:tableStyleId>{F6D91C87-4AD5-411E-980C-5EFCEA8410E2}</a:tableStyleId>
               </a:tblPr>
               <a:tblGrid>
                 <a:gridCol w="872025"/>
@@ -25605,7 +25626,7 @@
             <a:tbl>
               <a:tblPr bandRow="1" firstRow="1">
                 <a:noFill/>
-                <a:tableStyleId>{4988CF06-5FA7-4D49-9562-FA9D673A86ED}</a:tableStyleId>
+                <a:tableStyleId>{F6D91C87-4AD5-411E-980C-5EFCEA8410E2}</a:tableStyleId>
               </a:tblPr>
               <a:tblGrid>
                 <a:gridCol w="872025"/>

</xml_diff>

<commit_message>
update FRP midterm and end term course materials and presentations
</commit_message>
<xml_diff>
--- a/SEM_8/FRP/FRP End Term.pptx
+++ b/SEM_8/FRP/FRP End Term.pptx
@@ -23577,7 +23577,7 @@
           <p:nvPr/>
         </p:nvGraphicFramePr>
         <p:xfrm>
-          <a:off x="342900" y="1201590"/>
+          <a:off x="342900" y="1142990"/>
           <a:ext cx="3000000" cy="3000000"/>
         </p:xfrm>
         <a:graphic>
@@ -23585,7 +23585,7 @@
             <a:tbl>
               <a:tblPr bandRow="1" firstRow="1">
                 <a:noFill/>
-                <a:tableStyleId>{F6D91C87-4AD5-411E-980C-5EFCEA8410E2}</a:tableStyleId>
+                <a:tableStyleId>{7EE7BD04-5100-45B7-942F-DE3A5380CB05}</a:tableStyleId>
               </a:tblPr>
               <a:tblGrid>
                 <a:gridCol w="872025"/>
@@ -25618,7 +25618,7 @@
           <p:nvPr/>
         </p:nvGraphicFramePr>
         <p:xfrm>
-          <a:off x="342900" y="1095305"/>
+          <a:off x="342900" y="1143005"/>
           <a:ext cx="3000000" cy="3000000"/>
         </p:xfrm>
         <a:graphic>
@@ -25626,7 +25626,7 @@
             <a:tbl>
               <a:tblPr bandRow="1" firstRow="1">
                 <a:noFill/>
-                <a:tableStyleId>{F6D91C87-4AD5-411E-980C-5EFCEA8410E2}</a:tableStyleId>
+                <a:tableStyleId>{7EE7BD04-5100-45B7-942F-DE3A5380CB05}</a:tableStyleId>
               </a:tblPr>
               <a:tblGrid>
                 <a:gridCol w="872025"/>
@@ -26689,7 +26689,7 @@
                           <a:cs typeface="Times New Roman"/>
                           <a:sym typeface="Times New Roman"/>
                         </a:rPr>
-                        <a:t>Dozono et al. (2025)</a:t>
+                        <a:t>Guo et al. (2023)</a:t>
                       </a:r>
                       <a:endParaRPr b="0" sz="1000" u="none" cap="none" strike="noStrike">
                         <a:latin typeface="Times New Roman"/>
@@ -26764,7 +26764,7 @@
                           <a:cs typeface="Times New Roman"/>
                           <a:sym typeface="Times New Roman"/>
                         </a:rPr>
-                        <a:t>Empirical evaluation of 5 frontier LLMs comparing open-source vs. closed-source code performance.</a:t>
+                        <a:t>Systematic review of 130 false positive mitigation studies across 5 technical categories.</a:t>
                       </a:r>
                       <a:endParaRPr b="0" sz="1000" u="none" cap="none" strike="noStrike">
                         <a:latin typeface="Times New Roman"/>
@@ -26839,7 +26839,7 @@
                           <a:cs typeface="Times New Roman"/>
                           <a:sym typeface="Times New Roman"/>
                         </a:rPr>
-                        <a:t>CWE-Bench-Java (Open) and TS-Vuls (Closed, commercial Teamscale codebase).</a:t>
+                        <a:t>N/A (Literature Review).</a:t>
                       </a:r>
                       <a:endParaRPr b="0" sz="1000" u="none" cap="none" strike="noStrike">
                         <a:latin typeface="Times New Roman"/>
@@ -26914,7 +26914,7 @@
                           <a:cs typeface="Times New Roman"/>
                           <a:sym typeface="Times New Roman"/>
                         </a:rPr>
-                        <a:t>Precision dropped significantly from 56% on open-source code to 34% on closed-source code.</a:t>
+                        <a:t>Established a taxonomy for false positive mitigation and identified deep learning and NLP as future directions.</a:t>
                       </a:r>
                       <a:endParaRPr b="0" sz="1000" u="none" cap="none" strike="noStrike">
                         <a:latin typeface="Times New Roman"/>
@@ -26989,7 +26989,7 @@
                           <a:cs typeface="Times New Roman"/>
                           <a:sym typeface="Times New Roman"/>
                         </a:rPr>
-                        <a:t>LLM metrics are heavily inflated on open-source data due to training contamination.</a:t>
+                        <a:t>Current approaches suffer from low explainability, ambiguous concept definitions, and dataset biases.</a:t>
                       </a:r>
                       <a:endParaRPr b="0" sz="1000" u="none" cap="none" strike="noStrike">
                         <a:latin typeface="Times New Roman"/>
@@ -28511,285 +28511,6 @@
 </file>
 
 <file path=ppt/theme/theme1.xml><?xml version="1.0" encoding="utf-8"?>
-<a:theme xmlns:a="http://schemas.openxmlformats.org/drawingml/2006/main" xmlns:r="http://schemas.openxmlformats.org/officeDocument/2006/relationships" name="Simple Light">
-  <a:themeElements>
-    <a:clrScheme name="Simple Light">
-      <a:dk1>
-        <a:srgbClr val="000000"/>
-      </a:dk1>
-      <a:lt1>
-        <a:srgbClr val="FFFFFF"/>
-      </a:lt1>
-      <a:dk2>
-        <a:srgbClr val="595959"/>
-      </a:dk2>
-      <a:lt2>
-        <a:srgbClr val="EEEEEE"/>
-      </a:lt2>
-      <a:accent1>
-        <a:srgbClr val="4285F4"/>
-      </a:accent1>
-      <a:accent2>
-        <a:srgbClr val="212121"/>
-      </a:accent2>
-      <a:accent3>
-        <a:srgbClr val="78909C"/>
-      </a:accent3>
-      <a:accent4>
-        <a:srgbClr val="FFAB40"/>
-      </a:accent4>
-      <a:accent5>
-        <a:srgbClr val="0097A7"/>
-      </a:accent5>
-      <a:accent6>
-        <a:srgbClr val="EEFF41"/>
-      </a:accent6>
-      <a:hlink>
-        <a:srgbClr val="0097A7"/>
-      </a:hlink>
-      <a:folHlink>
-        <a:srgbClr val="0097A7"/>
-      </a:folHlink>
-    </a:clrScheme>
-    <a:fontScheme name="Office">
-      <a:majorFont>
-        <a:latin typeface="Arial"/>
-        <a:ea typeface=""/>
-        <a:cs typeface=""/>
-        <a:font script="Jpan" typeface="ＭＳ Ｐゴシック"/>
-        <a:font script="Hang" typeface="맑은 고딕"/>
-        <a:font script="Hans" typeface="宋体"/>
-        <a:font script="Hant" typeface="新細明體"/>
-        <a:font script="Arab" typeface="Times New Roman"/>
-        <a:font script="Hebr" typeface="Times New Roman"/>
-        <a:font script="Thai" typeface="Angsana New"/>
-        <a:font script="Ethi" typeface="Nyala"/>
-        <a:font script="Beng" typeface="Vrinda"/>
-        <a:font script="Gujr" typeface="Shruti"/>
-        <a:font script="Khmr" typeface="MoolBoran"/>
-        <a:font script="Knda" typeface="Tunga"/>
-        <a:font script="Guru" typeface="Raavi"/>
-        <a:font script="Cans" typeface="Euphemia"/>
-        <a:font script="Cher" typeface="Plantagenet Cherokee"/>
-        <a:font script="Yiii" typeface="Microsoft Yi Baiti"/>
-        <a:font script="Tibt" typeface="Microsoft Himalaya"/>
-        <a:font script="Thaa" typeface="MV Boli"/>
-        <a:font script="Deva" typeface="Mangal"/>
-        <a:font script="Telu" typeface="Gautami"/>
-        <a:font script="Taml" typeface="Latha"/>
-        <a:font script="Syrc" typeface="Estrangelo Edessa"/>
-        <a:font script="Orya" typeface="Kalinga"/>
-        <a:font script="Mlym" typeface="Kartika"/>
-        <a:font script="Laoo" typeface="DokChampa"/>
-        <a:font script="Sinh" typeface="Iskoola Pota"/>
-        <a:font script="Mong" typeface="Mongolian Baiti"/>
-        <a:font script="Viet" typeface="Times New Roman"/>
-        <a:font script="Uigh" typeface="Microsoft Uighur"/>
-        <a:font script="Geor" typeface="Sylfaen"/>
-      </a:majorFont>
-      <a:minorFont>
-        <a:latin typeface="Arial"/>
-        <a:ea typeface=""/>
-        <a:cs typeface=""/>
-        <a:font script="Jpan" typeface="ＭＳ Ｐゴシック"/>
-        <a:font script="Hang" typeface="맑은 고딕"/>
-        <a:font script="Hans" typeface="宋体"/>
-        <a:font script="Hant" typeface="新細明體"/>
-        <a:font script="Arab" typeface="Arial"/>
-        <a:font script="Hebr" typeface="Arial"/>
-        <a:font script="Thai" typeface="Cordia New"/>
-        <a:font script="Ethi" typeface="Nyala"/>
-        <a:font script="Beng" typeface="Vrinda"/>
-        <a:font script="Gujr" typeface="Shruti"/>
-        <a:font script="Khmr" typeface="DaunPenh"/>
-        <a:font script="Knda" typeface="Tunga"/>
-        <a:font script="Guru" typeface="Raavi"/>
-        <a:font script="Cans" typeface="Euphemia"/>
-        <a:font script="Cher" typeface="Plantagenet Cherokee"/>
-        <a:font script="Yiii" typeface="Microsoft Yi Baiti"/>
-        <a:font script="Tibt" typeface="Microsoft Himalaya"/>
-        <a:font script="Thaa" typeface="MV Boli"/>
-        <a:font script="Deva" typeface="Mangal"/>
-        <a:font script="Telu" typeface="Gautami"/>
-        <a:font script="Taml" typeface="Latha"/>
-        <a:font script="Syrc" typeface="Estrangelo Edessa"/>
-        <a:font script="Orya" typeface="Kalinga"/>
-        <a:font script="Mlym" typeface="Kartika"/>
-        <a:font script="Laoo" typeface="DokChampa"/>
-        <a:font script="Sinh" typeface="Iskoola Pota"/>
-        <a:font script="Mong" typeface="Mongolian Baiti"/>
-        <a:font script="Viet" typeface="Arial"/>
-        <a:font script="Uigh" typeface="Microsoft Uighur"/>
-        <a:font script="Geor" typeface="Sylfaen"/>
-      </a:minorFont>
-    </a:fontScheme>
-    <a:fmtScheme name="Office">
-      <a:fillStyleLst>
-        <a:solidFill>
-          <a:schemeClr val="phClr"/>
-        </a:solidFill>
-        <a:gradFill rotWithShape="1">
-          <a:gsLst>
-            <a:gs pos="0">
-              <a:schemeClr val="phClr">
-                <a:tint val="50000"/>
-                <a:satMod val="300000"/>
-              </a:schemeClr>
-            </a:gs>
-            <a:gs pos="35000">
-              <a:schemeClr val="phClr">
-                <a:tint val="37000"/>
-                <a:satMod val="300000"/>
-              </a:schemeClr>
-            </a:gs>
-            <a:gs pos="100000">
-              <a:schemeClr val="phClr">
-                <a:tint val="15000"/>
-                <a:satMod val="350000"/>
-              </a:schemeClr>
-            </a:gs>
-          </a:gsLst>
-          <a:lin ang="16200000" scaled="1"/>
-        </a:gradFill>
-        <a:gradFill rotWithShape="1">
-          <a:gsLst>
-            <a:gs pos="0">
-              <a:schemeClr val="phClr">
-                <a:tint val="100000"/>
-                <a:shade val="100000"/>
-                <a:satMod val="130000"/>
-              </a:schemeClr>
-            </a:gs>
-            <a:gs pos="100000">
-              <a:schemeClr val="phClr">
-                <a:tint val="50000"/>
-                <a:shade val="100000"/>
-                <a:satMod val="350000"/>
-              </a:schemeClr>
-            </a:gs>
-          </a:gsLst>
-          <a:lin ang="16200000" scaled="0"/>
-        </a:gradFill>
-      </a:fillStyleLst>
-      <a:lnStyleLst>
-        <a:ln w="9525" cap="flat" cmpd="sng" algn="ctr">
-          <a:solidFill>
-            <a:schemeClr val="phClr">
-              <a:shade val="95000"/>
-              <a:satMod val="105000"/>
-            </a:schemeClr>
-          </a:solidFill>
-          <a:prstDash val="solid"/>
-        </a:ln>
-        <a:ln w="25400" cap="flat" cmpd="sng" algn="ctr">
-          <a:solidFill>
-            <a:schemeClr val="phClr"/>
-          </a:solidFill>
-          <a:prstDash val="solid"/>
-        </a:ln>
-        <a:ln w="38100" cap="flat" cmpd="sng" algn="ctr">
-          <a:solidFill>
-            <a:schemeClr val="phClr"/>
-          </a:solidFill>
-          <a:prstDash val="solid"/>
-        </a:ln>
-      </a:lnStyleLst>
-      <a:effectStyleLst>
-        <a:effectStyle>
-          <a:effectLst>
-            <a:outerShdw blurRad="40000" dist="20000" dir="5400000" rotWithShape="0">
-              <a:srgbClr val="000000">
-                <a:alpha val="38000"/>
-              </a:srgbClr>
-            </a:outerShdw>
-          </a:effectLst>
-        </a:effectStyle>
-        <a:effectStyle>
-          <a:effectLst>
-            <a:outerShdw blurRad="40000" dist="23000" dir="5400000" rotWithShape="0">
-              <a:srgbClr val="000000">
-                <a:alpha val="35000"/>
-              </a:srgbClr>
-            </a:outerShdw>
-          </a:effectLst>
-        </a:effectStyle>
-        <a:effectStyle>
-          <a:effectLst>
-            <a:outerShdw blurRad="40000" dist="23000" dir="5400000" rotWithShape="0">
-              <a:srgbClr val="000000">
-                <a:alpha val="35000"/>
-              </a:srgbClr>
-            </a:outerShdw>
-          </a:effectLst>
-          <a:scene3d>
-            <a:camera prst="orthographicFront">
-              <a:rot lat="0" lon="0" rev="0"/>
-            </a:camera>
-            <a:lightRig rig="threePt" dir="t">
-              <a:rot lat="0" lon="0" rev="1200000"/>
-            </a:lightRig>
-          </a:scene3d>
-          <a:sp3d>
-            <a:bevelT w="63500" h="25400"/>
-          </a:sp3d>
-        </a:effectStyle>
-      </a:effectStyleLst>
-      <a:bgFillStyleLst>
-        <a:solidFill>
-          <a:schemeClr val="phClr"/>
-        </a:solidFill>
-        <a:gradFill rotWithShape="1">
-          <a:gsLst>
-            <a:gs pos="0">
-              <a:schemeClr val="phClr">
-                <a:tint val="40000"/>
-                <a:satMod val="350000"/>
-              </a:schemeClr>
-            </a:gs>
-            <a:gs pos="40000">
-              <a:schemeClr val="phClr">
-                <a:tint val="45000"/>
-                <a:shade val="99000"/>
-                <a:satMod val="350000"/>
-              </a:schemeClr>
-            </a:gs>
-            <a:gs pos="100000">
-              <a:schemeClr val="phClr">
-                <a:shade val="20000"/>
-                <a:satMod val="255000"/>
-              </a:schemeClr>
-            </a:gs>
-          </a:gsLst>
-          <a:path path="circle">
-            <a:fillToRect l="50000" t="-80000" r="50000" b="180000"/>
-          </a:path>
-        </a:gradFill>
-        <a:gradFill rotWithShape="1">
-          <a:gsLst>
-            <a:gs pos="0">
-              <a:schemeClr val="phClr">
-                <a:tint val="80000"/>
-                <a:satMod val="300000"/>
-              </a:schemeClr>
-            </a:gs>
-            <a:gs pos="100000">
-              <a:schemeClr val="phClr">
-                <a:shade val="30000"/>
-                <a:satMod val="200000"/>
-              </a:schemeClr>
-            </a:gs>
-          </a:gsLst>
-          <a:path path="circle">
-            <a:fillToRect l="50000" t="50000" r="50000" b="50000"/>
-          </a:path>
-        </a:gradFill>
-      </a:bgFillStyleLst>
-    </a:fmtScheme>
-  </a:themeElements>
-</a:theme>
-</file>
-
-<file path=ppt/theme/theme2.xml><?xml version="1.0" encoding="utf-8"?>
 <a:theme xmlns:a="http://schemas.openxmlformats.org/drawingml/2006/main" xmlns:r="http://schemas.openxmlformats.org/officeDocument/2006/relationships" name="Clarity">
   <a:themeElements>
     <a:clrScheme name="Office">
@@ -29068,7 +28789,7 @@
 </a:theme>
 </file>
 
-<file path=ppt/theme/theme3.xml><?xml version="1.0" encoding="utf-8"?>
+<file path=ppt/theme/theme2.xml><?xml version="1.0" encoding="utf-8"?>
 <a:theme xmlns:a="http://schemas.openxmlformats.org/drawingml/2006/main" xmlns:r="http://schemas.openxmlformats.org/officeDocument/2006/relationships">
   <a:themeElements>
     <a:clrScheme name="Default">
@@ -29345,4 +29066,283 @@
     </a:fmtScheme>
   </a:themeElements>
 </a:theme>
+</file>
+
+<file path=ppt/theme/theme3.xml><?xml version="1.0" encoding="utf-8"?>
+<a:theme xmlns:a="http://schemas.openxmlformats.org/drawingml/2006/main" xmlns:r="http://schemas.openxmlformats.org/officeDocument/2006/relationships" name="Simple Light">
+  <a:themeElements>
+    <a:clrScheme name="Simple Light">
+      <a:dk1>
+        <a:srgbClr val="000000"/>
+      </a:dk1>
+      <a:lt1>
+        <a:srgbClr val="FFFFFF"/>
+      </a:lt1>
+      <a:dk2>
+        <a:srgbClr val="595959"/>
+      </a:dk2>
+      <a:lt2>
+        <a:srgbClr val="EEEEEE"/>
+      </a:lt2>
+      <a:accent1>
+        <a:srgbClr val="4285F4"/>
+      </a:accent1>
+      <a:accent2>
+        <a:srgbClr val="212121"/>
+      </a:accent2>
+      <a:accent3>
+        <a:srgbClr val="78909C"/>
+      </a:accent3>
+      <a:accent4>
+        <a:srgbClr val="FFAB40"/>
+      </a:accent4>
+      <a:accent5>
+        <a:srgbClr val="0097A7"/>
+      </a:accent5>
+      <a:accent6>
+        <a:srgbClr val="EEFF41"/>
+      </a:accent6>
+      <a:hlink>
+        <a:srgbClr val="0097A7"/>
+      </a:hlink>
+      <a:folHlink>
+        <a:srgbClr val="0097A7"/>
+      </a:folHlink>
+    </a:clrScheme>
+    <a:fontScheme name="Office">
+      <a:majorFont>
+        <a:latin typeface="Arial"/>
+        <a:ea typeface=""/>
+        <a:cs typeface=""/>
+        <a:font script="Jpan" typeface="ＭＳ Ｐゴシック"/>
+        <a:font script="Hang" typeface="맑은 고딕"/>
+        <a:font script="Hans" typeface="宋体"/>
+        <a:font script="Hant" typeface="新細明體"/>
+        <a:font script="Arab" typeface="Times New Roman"/>
+        <a:font script="Hebr" typeface="Times New Roman"/>
+        <a:font script="Thai" typeface="Angsana New"/>
+        <a:font script="Ethi" typeface="Nyala"/>
+        <a:font script="Beng" typeface="Vrinda"/>
+        <a:font script="Gujr" typeface="Shruti"/>
+        <a:font script="Khmr" typeface="MoolBoran"/>
+        <a:font script="Knda" typeface="Tunga"/>
+        <a:font script="Guru" typeface="Raavi"/>
+        <a:font script="Cans" typeface="Euphemia"/>
+        <a:font script="Cher" typeface="Plantagenet Cherokee"/>
+        <a:font script="Yiii" typeface="Microsoft Yi Baiti"/>
+        <a:font script="Tibt" typeface="Microsoft Himalaya"/>
+        <a:font script="Thaa" typeface="MV Boli"/>
+        <a:font script="Deva" typeface="Mangal"/>
+        <a:font script="Telu" typeface="Gautami"/>
+        <a:font script="Taml" typeface="Latha"/>
+        <a:font script="Syrc" typeface="Estrangelo Edessa"/>
+        <a:font script="Orya" typeface="Kalinga"/>
+        <a:font script="Mlym" typeface="Kartika"/>
+        <a:font script="Laoo" typeface="DokChampa"/>
+        <a:font script="Sinh" typeface="Iskoola Pota"/>
+        <a:font script="Mong" typeface="Mongolian Baiti"/>
+        <a:font script="Viet" typeface="Times New Roman"/>
+        <a:font script="Uigh" typeface="Microsoft Uighur"/>
+        <a:font script="Geor" typeface="Sylfaen"/>
+      </a:majorFont>
+      <a:minorFont>
+        <a:latin typeface="Arial"/>
+        <a:ea typeface=""/>
+        <a:cs typeface=""/>
+        <a:font script="Jpan" typeface="ＭＳ Ｐゴシック"/>
+        <a:font script="Hang" typeface="맑은 고딕"/>
+        <a:font script="Hans" typeface="宋体"/>
+        <a:font script="Hant" typeface="新細明體"/>
+        <a:font script="Arab" typeface="Arial"/>
+        <a:font script="Hebr" typeface="Arial"/>
+        <a:font script="Thai" typeface="Cordia New"/>
+        <a:font script="Ethi" typeface="Nyala"/>
+        <a:font script="Beng" typeface="Vrinda"/>
+        <a:font script="Gujr" typeface="Shruti"/>
+        <a:font script="Khmr" typeface="DaunPenh"/>
+        <a:font script="Knda" typeface="Tunga"/>
+        <a:font script="Guru" typeface="Raavi"/>
+        <a:font script="Cans" typeface="Euphemia"/>
+        <a:font script="Cher" typeface="Plantagenet Cherokee"/>
+        <a:font script="Yiii" typeface="Microsoft Yi Baiti"/>
+        <a:font script="Tibt" typeface="Microsoft Himalaya"/>
+        <a:font script="Thaa" typeface="MV Boli"/>
+        <a:font script="Deva" typeface="Mangal"/>
+        <a:font script="Telu" typeface="Gautami"/>
+        <a:font script="Taml" typeface="Latha"/>
+        <a:font script="Syrc" typeface="Estrangelo Edessa"/>
+        <a:font script="Orya" typeface="Kalinga"/>
+        <a:font script="Mlym" typeface="Kartika"/>
+        <a:font script="Laoo" typeface="DokChampa"/>
+        <a:font script="Sinh" typeface="Iskoola Pota"/>
+        <a:font script="Mong" typeface="Mongolian Baiti"/>
+        <a:font script="Viet" typeface="Arial"/>
+        <a:font script="Uigh" typeface="Microsoft Uighur"/>
+        <a:font script="Geor" typeface="Sylfaen"/>
+      </a:minorFont>
+    </a:fontScheme>
+    <a:fmtScheme name="Office">
+      <a:fillStyleLst>
+        <a:solidFill>
+          <a:schemeClr val="phClr"/>
+        </a:solidFill>
+        <a:gradFill rotWithShape="1">
+          <a:gsLst>
+            <a:gs pos="0">
+              <a:schemeClr val="phClr">
+                <a:tint val="50000"/>
+                <a:satMod val="300000"/>
+              </a:schemeClr>
+            </a:gs>
+            <a:gs pos="35000">
+              <a:schemeClr val="phClr">
+                <a:tint val="37000"/>
+                <a:satMod val="300000"/>
+              </a:schemeClr>
+            </a:gs>
+            <a:gs pos="100000">
+              <a:schemeClr val="phClr">
+                <a:tint val="15000"/>
+                <a:satMod val="350000"/>
+              </a:schemeClr>
+            </a:gs>
+          </a:gsLst>
+          <a:lin ang="16200000" scaled="1"/>
+        </a:gradFill>
+        <a:gradFill rotWithShape="1">
+          <a:gsLst>
+            <a:gs pos="0">
+              <a:schemeClr val="phClr">
+                <a:tint val="100000"/>
+                <a:shade val="100000"/>
+                <a:satMod val="130000"/>
+              </a:schemeClr>
+            </a:gs>
+            <a:gs pos="100000">
+              <a:schemeClr val="phClr">
+                <a:tint val="50000"/>
+                <a:shade val="100000"/>
+                <a:satMod val="350000"/>
+              </a:schemeClr>
+            </a:gs>
+          </a:gsLst>
+          <a:lin ang="16200000" scaled="0"/>
+        </a:gradFill>
+      </a:fillStyleLst>
+      <a:lnStyleLst>
+        <a:ln w="9525" cap="flat" cmpd="sng" algn="ctr">
+          <a:solidFill>
+            <a:schemeClr val="phClr">
+              <a:shade val="95000"/>
+              <a:satMod val="105000"/>
+            </a:schemeClr>
+          </a:solidFill>
+          <a:prstDash val="solid"/>
+        </a:ln>
+        <a:ln w="25400" cap="flat" cmpd="sng" algn="ctr">
+          <a:solidFill>
+            <a:schemeClr val="phClr"/>
+          </a:solidFill>
+          <a:prstDash val="solid"/>
+        </a:ln>
+        <a:ln w="38100" cap="flat" cmpd="sng" algn="ctr">
+          <a:solidFill>
+            <a:schemeClr val="phClr"/>
+          </a:solidFill>
+          <a:prstDash val="solid"/>
+        </a:ln>
+      </a:lnStyleLst>
+      <a:effectStyleLst>
+        <a:effectStyle>
+          <a:effectLst>
+            <a:outerShdw blurRad="40000" dist="20000" dir="5400000" rotWithShape="0">
+              <a:srgbClr val="000000">
+                <a:alpha val="38000"/>
+              </a:srgbClr>
+            </a:outerShdw>
+          </a:effectLst>
+        </a:effectStyle>
+        <a:effectStyle>
+          <a:effectLst>
+            <a:outerShdw blurRad="40000" dist="23000" dir="5400000" rotWithShape="0">
+              <a:srgbClr val="000000">
+                <a:alpha val="35000"/>
+              </a:srgbClr>
+            </a:outerShdw>
+          </a:effectLst>
+        </a:effectStyle>
+        <a:effectStyle>
+          <a:effectLst>
+            <a:outerShdw blurRad="40000" dist="23000" dir="5400000" rotWithShape="0">
+              <a:srgbClr val="000000">
+                <a:alpha val="35000"/>
+              </a:srgbClr>
+            </a:outerShdw>
+          </a:effectLst>
+          <a:scene3d>
+            <a:camera prst="orthographicFront">
+              <a:rot lat="0" lon="0" rev="0"/>
+            </a:camera>
+            <a:lightRig rig="threePt" dir="t">
+              <a:rot lat="0" lon="0" rev="1200000"/>
+            </a:lightRig>
+          </a:scene3d>
+          <a:sp3d>
+            <a:bevelT w="63500" h="25400"/>
+          </a:sp3d>
+        </a:effectStyle>
+      </a:effectStyleLst>
+      <a:bgFillStyleLst>
+        <a:solidFill>
+          <a:schemeClr val="phClr"/>
+        </a:solidFill>
+        <a:gradFill rotWithShape="1">
+          <a:gsLst>
+            <a:gs pos="0">
+              <a:schemeClr val="phClr">
+                <a:tint val="40000"/>
+                <a:satMod val="350000"/>
+              </a:schemeClr>
+            </a:gs>
+            <a:gs pos="40000">
+              <a:schemeClr val="phClr">
+                <a:tint val="45000"/>
+                <a:shade val="99000"/>
+                <a:satMod val="350000"/>
+              </a:schemeClr>
+            </a:gs>
+            <a:gs pos="100000">
+              <a:schemeClr val="phClr">
+                <a:shade val="20000"/>
+                <a:satMod val="255000"/>
+              </a:schemeClr>
+            </a:gs>
+          </a:gsLst>
+          <a:path path="circle">
+            <a:fillToRect l="50000" t="-80000" r="50000" b="180000"/>
+          </a:path>
+        </a:gradFill>
+        <a:gradFill rotWithShape="1">
+          <a:gsLst>
+            <a:gs pos="0">
+              <a:schemeClr val="phClr">
+                <a:tint val="80000"/>
+                <a:satMod val="300000"/>
+              </a:schemeClr>
+            </a:gs>
+            <a:gs pos="100000">
+              <a:schemeClr val="phClr">
+                <a:shade val="30000"/>
+                <a:satMod val="200000"/>
+              </a:schemeClr>
+            </a:gs>
+          </a:gsLst>
+          <a:path path="circle">
+            <a:fillToRect l="50000" t="50000" r="50000" b="50000"/>
+          </a:path>
+        </a:gradFill>
+      </a:bgFillStyleLst>
+    </a:fmtScheme>
+  </a:themeElements>
+</a:theme>
 </file>
</xml_diff>